<commit_message>
feat: 安装 Guizang PPT Skill
Co-authored-by: traeagent <traeagent@users.noreply.github.com>
</commit_message>
<xml_diff>
--- a/SOLO-0408-直播/ppt/SOLO_0418_直播.pptx
+++ b/SOLO-0408-直播/ppt/SOLO_0418_直播.pptx
@@ -1935,7 +1935,7 @@
         <p:spPr>
           <a:xfrm>
             <a:off x="457200" y="2743200"/>
-            <a:ext cx="7772400" cy="1828800"/>
+            <a:ext cx="5029200" cy="1828800"/>
           </a:xfrm>
           <a:prstGeom prst="rect">
             <a:avLst/>
@@ -2075,7 +2075,7 @@
         <p:spPr>
           <a:xfrm>
             <a:off x="457200" y="2743200"/>
-            <a:ext cx="7772400" cy="1828800"/>
+            <a:ext cx="5029200" cy="1828800"/>
           </a:xfrm>
           <a:prstGeom prst="rect">
             <a:avLst/>
@@ -2243,7 +2243,7 @@
         <p:spPr>
           <a:xfrm>
             <a:off x="457200" y="2743200"/>
-            <a:ext cx="7772400" cy="1828800"/>
+            <a:ext cx="5029200" cy="1828800"/>
           </a:xfrm>
           <a:prstGeom prst="rect">
             <a:avLst/>
@@ -2306,6 +2306,30 @@
           </a:p>
         </p:txBody>
       </p:sp>
+      <p:pic>
+        <p:nvPicPr>
+          <p:cNvPr id="6" name="Image 0" descr="/workspace/SOLO-0408-直播/ppt/images/04-slide-image.png">    </p:cNvPr>
+          <p:cNvPicPr>
+            <a:picLocks noChangeAspect="1"/>
+          </p:cNvPicPr>
+          <p:nvPr/>
+        </p:nvPicPr>
+        <p:blipFill>
+          <a:blip r:embed="rId1"/>
+          <a:stretch>
+            <a:fillRect/>
+          </a:stretch>
+        </p:blipFill>
+        <p:spPr>
+          <a:xfrm>
+            <a:off x="5029200" y="1371600"/>
+            <a:ext cx="3840480" cy="2157984"/>
+          </a:xfrm>
+          <a:prstGeom prst="rect">
+            <a:avLst/>
+          </a:prstGeom>
+        </p:spPr>
+      </p:pic>
     </p:spTree>
   </p:cSld>
   <p:clrMapOvr>
@@ -2419,7 +2443,7 @@
         <p:spPr>
           <a:xfrm>
             <a:off x="457200" y="2743200"/>
-            <a:ext cx="7772400" cy="1828800"/>
+            <a:ext cx="5029200" cy="1828800"/>
           </a:xfrm>
           <a:prstGeom prst="rect">
             <a:avLst/>
@@ -3163,7 +3187,7 @@
         <p:spPr>
           <a:xfrm>
             <a:off x="457200" y="2743200"/>
-            <a:ext cx="7772400" cy="1828800"/>
+            <a:ext cx="5029200" cy="1828800"/>
           </a:xfrm>
           <a:prstGeom prst="rect">
             <a:avLst/>
@@ -3331,7 +3355,7 @@
         <p:spPr>
           <a:xfrm>
             <a:off x="457200" y="2743200"/>
-            <a:ext cx="7772400" cy="1828800"/>
+            <a:ext cx="5029200" cy="1828800"/>
           </a:xfrm>
           <a:prstGeom prst="rect">
             <a:avLst/>
@@ -3827,7 +3851,7 @@
         <p:spPr>
           <a:xfrm>
             <a:off x="457200" y="2743200"/>
-            <a:ext cx="7772400" cy="1828800"/>
+            <a:ext cx="5029200" cy="1828800"/>
           </a:xfrm>
           <a:prstGeom prst="rect">
             <a:avLst/>
@@ -3890,6 +3914,30 @@
           </a:p>
         </p:txBody>
       </p:sp>
+      <p:pic>
+        <p:nvPicPr>
+          <p:cNvPr id="6" name="Image 0" descr="/workspace/SOLO-0408-直播/ppt/images/01-slide-image.png">    </p:cNvPr>
+          <p:cNvPicPr>
+            <a:picLocks noChangeAspect="1"/>
+          </p:cNvPicPr>
+          <p:nvPr/>
+        </p:nvPicPr>
+        <p:blipFill>
+          <a:blip r:embed="rId1"/>
+          <a:stretch>
+            <a:fillRect/>
+          </a:stretch>
+        </p:blipFill>
+        <p:spPr>
+          <a:xfrm>
+            <a:off x="5029200" y="1371600"/>
+            <a:ext cx="3840480" cy="2157984"/>
+          </a:xfrm>
+          <a:prstGeom prst="rect">
+            <a:avLst/>
+          </a:prstGeom>
+        </p:spPr>
+      </p:pic>
     </p:spTree>
   </p:cSld>
   <p:clrMapOvr>
@@ -4003,7 +4051,7 @@
         <p:spPr>
           <a:xfrm>
             <a:off x="457200" y="2743200"/>
-            <a:ext cx="7772400" cy="1828800"/>
+            <a:ext cx="5029200" cy="1828800"/>
           </a:xfrm>
           <a:prstGeom prst="rect">
             <a:avLst/>
@@ -4066,6 +4114,30 @@
           </a:p>
         </p:txBody>
       </p:sp>
+      <p:pic>
+        <p:nvPicPr>
+          <p:cNvPr id="6" name="Image 0" descr="/workspace/SOLO-0408-直播/ppt/images/02-slide-image.png">    </p:cNvPr>
+          <p:cNvPicPr>
+            <a:picLocks noChangeAspect="1"/>
+          </p:cNvPicPr>
+          <p:nvPr/>
+        </p:nvPicPr>
+        <p:blipFill>
+          <a:blip r:embed="rId1"/>
+          <a:stretch>
+            <a:fillRect/>
+          </a:stretch>
+        </p:blipFill>
+        <p:spPr>
+          <a:xfrm>
+            <a:off x="5029200" y="1371600"/>
+            <a:ext cx="3840480" cy="2157984"/>
+          </a:xfrm>
+          <a:prstGeom prst="rect">
+            <a:avLst/>
+          </a:prstGeom>
+        </p:spPr>
+      </p:pic>
     </p:spTree>
   </p:cSld>
   <p:clrMapOvr>
@@ -4179,7 +4251,7 @@
         <p:spPr>
           <a:xfrm>
             <a:off x="457200" y="2743200"/>
-            <a:ext cx="7772400" cy="1828800"/>
+            <a:ext cx="5029200" cy="1828800"/>
           </a:xfrm>
           <a:prstGeom prst="rect">
             <a:avLst/>

</xml_diff>

<commit_message>
fix: adjust pptxgenjs layout to prevent text overlapping
</commit_message>
<xml_diff>
--- a/SOLO-0408-直播/ppt/SOLO_0418_直播.pptx
+++ b/SOLO-0408-直播/ppt/SOLO_0418_直播.pptx
@@ -1934,31 +1934,31 @@
         </p:nvSpPr>
         <p:spPr>
           <a:xfrm>
-            <a:off x="457200" y="2743200"/>
-            <a:ext cx="5029200" cy="1828800"/>
-          </a:xfrm>
-          <a:prstGeom prst="rect">
-            <a:avLst/>
-          </a:prstGeom>
-          <a:noFill/>
-          <a:ln/>
-        </p:spPr>
-        <p:txBody>
-          <a:bodyPr wrap="square" rtlCol="0" anchor="ctr"/>
-          <a:lstStyle/>
-          <a:p>
-            <a:pPr indent="0" marL="0">
-              <a:buNone/>
-            </a:pPr>
-            <a:r>
-              <a:rPr lang="en-US" sz="2000" dirty="0">
+            <a:off x="457200" y="2286000"/>
+            <a:ext cx="7772400" cy="1371600"/>
+          </a:xfrm>
+          <a:prstGeom prst="rect">
+            <a:avLst/>
+          </a:prstGeom>
+          <a:noFill/>
+          <a:ln/>
+        </p:spPr>
+        <p:txBody>
+          <a:bodyPr wrap="square" rtlCol="0" anchor="ctr"/>
+          <a:lstStyle/>
+          <a:p>
+            <a:pPr indent="0" marL="0">
+              <a:buNone/>
+            </a:pPr>
+            <a:r>
+              <a:rPr lang="en-US" sz="1800" dirty="0">
                 <a:solidFill>
                   <a:srgbClr val="CCCCCC"/>
                 </a:solidFill>
               </a:rPr>
               <a:t>随着大模型能力的极大提升，AI 已经从编程扩展到各个领域。今天，我们正式推出 SOLO 独立版。</a:t>
             </a:r>
-            <a:endParaRPr lang="en-US" sz="2000" dirty="0"/>
+            <a:endParaRPr lang="en-US" sz="1800" dirty="0"/>
           </a:p>
         </p:txBody>
       </p:sp>
@@ -2074,59 +2074,59 @@
         </p:nvSpPr>
         <p:spPr>
           <a:xfrm>
-            <a:off x="457200" y="2743200"/>
-            <a:ext cx="5029200" cy="1828800"/>
-          </a:xfrm>
-          <a:prstGeom prst="rect">
-            <a:avLst/>
-          </a:prstGeom>
-          <a:noFill/>
-          <a:ln/>
-        </p:spPr>
-        <p:txBody>
-          <a:bodyPr wrap="square" rtlCol="0" anchor="ctr"/>
-          <a:lstStyle/>
-          <a:p>
-            <a:pPr indent="0" marL="0">
-              <a:buNone/>
-            </a:pPr>
-            <a:r>
-              <a:rPr lang="en-US" sz="2000" dirty="0">
+            <a:off x="457200" y="2286000"/>
+            <a:ext cx="7772400" cy="1371600"/>
+          </a:xfrm>
+          <a:prstGeom prst="rect">
+            <a:avLst/>
+          </a:prstGeom>
+          <a:noFill/>
+          <a:ln/>
+        </p:spPr>
+        <p:txBody>
+          <a:bodyPr wrap="square" rtlCol="0" anchor="ctr"/>
+          <a:lstStyle/>
+          <a:p>
+            <a:pPr indent="0" marL="0">
+              <a:buNone/>
+            </a:pPr>
+            <a:r>
+              <a:rPr lang="en-US" sz="1800" dirty="0">
                 <a:solidFill>
                   <a:srgbClr val="555555"/>
                 </a:solidFill>
               </a:rPr>
               <a:t>从需求分析、交互设计、编码研发，到质量保障、线上运维。整条链路上的角色都在从中受益，不再只是程序员的专属。</a:t>
             </a:r>
-            <a:endParaRPr lang="en-US" sz="2000" dirty="0"/>
-          </a:p>
-          <a:p>
-            <a:pPr indent="0" marL="0">
-              <a:buNone/>
-            </a:pPr>
-            <a:r>
-              <a:rPr lang="en-US" sz="2000" dirty="0">
+            <a:endParaRPr lang="en-US" sz="1800" dirty="0"/>
+          </a:p>
+          <a:p>
+            <a:pPr indent="0" marL="0">
+              <a:buNone/>
+            </a:pPr>
+            <a:r>
+              <a:rPr lang="en-US" sz="1800" dirty="0">
                 <a:solidFill>
                   <a:srgbClr val="555555"/>
                 </a:solidFill>
               </a:rPr>
               <a:t>        </a:t>
             </a:r>
-            <a:endParaRPr lang="en-US" sz="2000" dirty="0"/>
-          </a:p>
-          <a:p>
-            <a:pPr indent="0" marL="0">
-              <a:buNone/>
-            </a:pPr>
-            <a:r>
-              <a:rPr lang="en-US" sz="2000" dirty="0">
+            <a:endParaRPr lang="en-US" sz="1800" dirty="0"/>
+          </a:p>
+          <a:p>
+            <a:pPr indent="0" marL="0">
+              <a:buNone/>
+            </a:pPr>
+            <a:r>
+              <a:rPr lang="en-US" sz="1800" dirty="0">
                 <a:solidFill>
                   <a:srgbClr val="555555"/>
                 </a:solidFill>
               </a:rPr>
               <a:t>          技术调研、写设计文档、整理会议纪要，甚至管理本地知识库。AI 的价值远不止于写代码。这也是 SOLO 提供 Work 模式的原因。</a:t>
             </a:r>
-            <a:endParaRPr lang="en-US" sz="2000" dirty="0"/>
+            <a:endParaRPr lang="en-US" sz="1800" dirty="0"/>
           </a:p>
         </p:txBody>
       </p:sp>
@@ -2242,31 +2242,31 @@
         </p:nvSpPr>
         <p:spPr>
           <a:xfrm>
-            <a:off x="457200" y="2743200"/>
-            <a:ext cx="5029200" cy="1828800"/>
-          </a:xfrm>
-          <a:prstGeom prst="rect">
-            <a:avLst/>
-          </a:prstGeom>
-          <a:noFill/>
-          <a:ln/>
-        </p:spPr>
-        <p:txBody>
-          <a:bodyPr wrap="square" rtlCol="0" anchor="ctr"/>
-          <a:lstStyle/>
-          <a:p>
-            <a:pPr indent="0" marL="0">
-              <a:buNone/>
-            </a:pPr>
-            <a:r>
-              <a:rPr lang="en-US" sz="2000" dirty="0">
+            <a:off x="457200" y="2286000"/>
+            <a:ext cx="7772400" cy="1371600"/>
+          </a:xfrm>
+          <a:prstGeom prst="rect">
+            <a:avLst/>
+          </a:prstGeom>
+          <a:noFill/>
+          <a:ln/>
+        </p:spPr>
+        <p:txBody>
+          <a:bodyPr wrap="square" rtlCol="0" anchor="ctr"/>
+          <a:lstStyle/>
+          <a:p>
+            <a:pPr indent="0" marL="0">
+              <a:buNone/>
+            </a:pPr>
+            <a:r>
+              <a:rPr lang="en-US" sz="1800" dirty="0">
                 <a:solidFill>
                   <a:srgbClr val="CCCCCC"/>
                 </a:solidFill>
               </a:rPr>
               <a:t>过去你是 In the Loop，每一行代码都经过你的手；现在你要学会 On the Loop，设定约束、委派任务、审查结果。</a:t>
             </a:r>
-            <a:endParaRPr lang="en-US" sz="2000" dirty="0"/>
+            <a:endParaRPr lang="en-US" sz="1800" dirty="0"/>
           </a:p>
         </p:txBody>
       </p:sp>
@@ -2442,31 +2442,31 @@
         </p:nvSpPr>
         <p:spPr>
           <a:xfrm>
-            <a:off x="457200" y="2743200"/>
-            <a:ext cx="5029200" cy="1828800"/>
-          </a:xfrm>
-          <a:prstGeom prst="rect">
-            <a:avLst/>
-          </a:prstGeom>
-          <a:noFill/>
-          <a:ln/>
-        </p:spPr>
-        <p:txBody>
-          <a:bodyPr wrap="square" rtlCol="0" anchor="ctr"/>
-          <a:lstStyle/>
-          <a:p>
-            <a:pPr indent="0" marL="0">
-              <a:buNone/>
-            </a:pPr>
-            <a:r>
-              <a:rPr lang="en-US" sz="2000" dirty="0">
+            <a:off x="457200" y="2286000"/>
+            <a:ext cx="7772400" cy="1371600"/>
+          </a:xfrm>
+          <a:prstGeom prst="rect">
+            <a:avLst/>
+          </a:prstGeom>
+          <a:noFill/>
+          <a:ln/>
+        </p:spPr>
+        <p:txBody>
+          <a:bodyPr wrap="square" rtlCol="0" anchor="ctr"/>
+          <a:lstStyle/>
+          <a:p>
+            <a:pPr indent="0" marL="0">
+              <a:buNone/>
+            </a:pPr>
+            <a:r>
+              <a:rPr lang="en-US" sz="1800" dirty="0">
                 <a:solidFill>
                   <a:srgbClr val="555555"/>
                 </a:solidFill>
               </a:rPr>
               <a:t>不是取代工程师，而是让每个工程师都能站在更高的抽象层次上思考和创造。</a:t>
             </a:r>
-            <a:endParaRPr lang="en-US" sz="2000" dirty="0"/>
+            <a:endParaRPr lang="en-US" sz="1800" dirty="0"/>
           </a:p>
         </p:txBody>
       </p:sp>
@@ -2582,31 +2582,31 @@
         </p:nvSpPr>
         <p:spPr>
           <a:xfrm>
-            <a:off x="457200" y="2743200"/>
-            <a:ext cx="1828800" cy="914400"/>
-          </a:xfrm>
-          <a:prstGeom prst="rect">
-            <a:avLst/>
-          </a:prstGeom>
-          <a:noFill/>
-          <a:ln/>
-        </p:spPr>
-        <p:txBody>
-          <a:bodyPr wrap="square" rtlCol="0" anchor="ctr"/>
-          <a:lstStyle/>
-          <a:p>
-            <a:pPr indent="0" marL="0">
-              <a:buNone/>
-            </a:pPr>
-            <a:r>
-              <a:rPr lang="en-US" sz="4000" b="1" dirty="0">
+            <a:off x="457200" y="2926080"/>
+            <a:ext cx="2011680" cy="731520"/>
+          </a:xfrm>
+          <a:prstGeom prst="rect">
+            <a:avLst/>
+          </a:prstGeom>
+          <a:noFill/>
+          <a:ln/>
+        </p:spPr>
+        <p:txBody>
+          <a:bodyPr wrap="square" rtlCol="0" anchor="ctr"/>
+          <a:lstStyle/>
+          <a:p>
+            <a:pPr indent="0" marL="0">
+              <a:buNone/>
+            </a:pPr>
+            <a:r>
+              <a:rPr lang="en-US" sz="3200" b="1" dirty="0">
                 <a:solidFill>
                   <a:srgbClr val="0A0A0B"/>
                 </a:solidFill>
               </a:rPr>
               <a:t>2022.11.15</a:t>
             </a:r>
-            <a:endParaRPr lang="en-US" sz="4000" dirty="0"/>
+            <a:endParaRPr lang="en-US" sz="3200" dirty="0"/>
           </a:p>
         </p:txBody>
       </p:sp>
@@ -2618,31 +2618,31 @@
         </p:nvSpPr>
         <p:spPr>
           <a:xfrm>
-            <a:off x="457200" y="3840480"/>
-            <a:ext cx="1828800" cy="457200"/>
-          </a:xfrm>
-          <a:prstGeom prst="rect">
-            <a:avLst/>
-          </a:prstGeom>
-          <a:noFill/>
-          <a:ln/>
-        </p:spPr>
-        <p:txBody>
-          <a:bodyPr wrap="square" rtlCol="0" anchor="ctr"/>
-          <a:lstStyle/>
-          <a:p>
-            <a:pPr indent="0" marL="0">
-              <a:buNone/>
-            </a:pPr>
-            <a:r>
-              <a:rPr lang="en-US" sz="1600" dirty="0">
+            <a:off x="457200" y="3749040"/>
+            <a:ext cx="2011680" cy="365760"/>
+          </a:xfrm>
+          <a:prstGeom prst="rect">
+            <a:avLst/>
+          </a:prstGeom>
+          <a:noFill/>
+          <a:ln/>
+        </p:spPr>
+        <p:txBody>
+          <a:bodyPr wrap="square" rtlCol="0" anchor="ctr"/>
+          <a:lstStyle/>
+          <a:p>
+            <a:pPr indent="0" marL="0">
+              <a:buNone/>
+            </a:pPr>
+            <a:r>
+              <a:rPr lang="en-US" sz="1400" dirty="0">
                 <a:solidFill>
                   <a:srgbClr val="555555"/>
                 </a:solidFill>
               </a:rPr>
               <a:t>加入字节</a:t>
             </a:r>
-            <a:endParaRPr lang="en-US" sz="1600" dirty="0"/>
+            <a:endParaRPr lang="en-US" sz="1400" dirty="0"/>
           </a:p>
         </p:txBody>
       </p:sp>
@@ -2654,31 +2654,31 @@
         </p:nvSpPr>
         <p:spPr>
           <a:xfrm>
-            <a:off x="2743200" y="2743200"/>
-            <a:ext cx="1828800" cy="914400"/>
-          </a:xfrm>
-          <a:prstGeom prst="rect">
-            <a:avLst/>
-          </a:prstGeom>
-          <a:noFill/>
-          <a:ln/>
-        </p:spPr>
-        <p:txBody>
-          <a:bodyPr wrap="square" rtlCol="0" anchor="ctr"/>
-          <a:lstStyle/>
-          <a:p>
-            <a:pPr indent="0" marL="0">
-              <a:buNone/>
-            </a:pPr>
-            <a:r>
-              <a:rPr lang="en-US" sz="4000" b="1" dirty="0">
+            <a:off x="2651760" y="2926080"/>
+            <a:ext cx="2011680" cy="731520"/>
+          </a:xfrm>
+          <a:prstGeom prst="rect">
+            <a:avLst/>
+          </a:prstGeom>
+          <a:noFill/>
+          <a:ln/>
+        </p:spPr>
+        <p:txBody>
+          <a:bodyPr wrap="square" rtlCol="0" anchor="ctr"/>
+          <a:lstStyle/>
+          <a:p>
+            <a:pPr indent="0" marL="0">
+              <a:buNone/>
+            </a:pPr>
+            <a:r>
+              <a:rPr lang="en-US" sz="3200" b="1" dirty="0">
                 <a:solidFill>
                   <a:srgbClr val="0A0A0B"/>
                 </a:solidFill>
               </a:rPr>
               <a:t>MarsCode Cloud IDE</a:t>
             </a:r>
-            <a:endParaRPr lang="en-US" sz="4000" dirty="0"/>
+            <a:endParaRPr lang="en-US" sz="3200" dirty="0"/>
           </a:p>
         </p:txBody>
       </p:sp>
@@ -2690,31 +2690,31 @@
         </p:nvSpPr>
         <p:spPr>
           <a:xfrm>
-            <a:off x="2743200" y="3840480"/>
-            <a:ext cx="1828800" cy="457200"/>
-          </a:xfrm>
-          <a:prstGeom prst="rect">
-            <a:avLst/>
-          </a:prstGeom>
-          <a:noFill/>
-          <a:ln/>
-        </p:spPr>
-        <p:txBody>
-          <a:bodyPr wrap="square" rtlCol="0" anchor="ctr"/>
-          <a:lstStyle/>
-          <a:p>
-            <a:pPr indent="0" marL="0">
-              <a:buNone/>
-            </a:pPr>
-            <a:r>
-              <a:rPr lang="en-US" sz="1600" dirty="0">
+            <a:off x="2651760" y="3749040"/>
+            <a:ext cx="2011680" cy="365760"/>
+          </a:xfrm>
+          <a:prstGeom prst="rect">
+            <a:avLst/>
+          </a:prstGeom>
+          <a:noFill/>
+          <a:ln/>
+        </p:spPr>
+        <p:txBody>
+          <a:bodyPr wrap="square" rtlCol="0" anchor="ctr"/>
+          <a:lstStyle/>
+          <a:p>
+            <a:pPr indent="0" marL="0">
+              <a:buNone/>
+            </a:pPr>
+            <a:r>
+              <a:rPr lang="en-US" sz="1400" dirty="0">
                 <a:solidFill>
                   <a:srgbClr val="555555"/>
                 </a:solidFill>
               </a:rPr>
               <a:t>闭关产出</a:t>
             </a:r>
-            <a:endParaRPr lang="en-US" sz="1600" dirty="0"/>
+            <a:endParaRPr lang="en-US" sz="1400" dirty="0"/>
           </a:p>
         </p:txBody>
       </p:sp>
@@ -2726,31 +2726,31 @@
         </p:nvSpPr>
         <p:spPr>
           <a:xfrm>
-            <a:off x="2743200" y="4297680"/>
-            <a:ext cx="1828800" cy="457200"/>
-          </a:xfrm>
-          <a:prstGeom prst="rect">
-            <a:avLst/>
-          </a:prstGeom>
-          <a:noFill/>
-          <a:ln/>
-        </p:spPr>
-        <p:txBody>
-          <a:bodyPr wrap="square" rtlCol="0" anchor="ctr"/>
-          <a:lstStyle/>
-          <a:p>
-            <a:pPr indent="0" marL="0">
-              <a:buNone/>
-            </a:pPr>
-            <a:r>
-              <a:rPr lang="en-US" sz="1200" dirty="0">
+            <a:off x="2651760" y="4114800"/>
+            <a:ext cx="2011680" cy="365760"/>
+          </a:xfrm>
+          <a:prstGeom prst="rect">
+            <a:avLst/>
+          </a:prstGeom>
+          <a:noFill/>
+          <a:ln/>
+        </p:spPr>
+        <p:txBody>
+          <a:bodyPr wrap="square" rtlCol="0" anchor="ctr"/>
+          <a:lstStyle/>
+          <a:p>
+            <a:pPr indent="0" marL="0">
+              <a:buNone/>
+            </a:pPr>
+            <a:r>
+              <a:rPr lang="en-US" sz="1000" dirty="0">
                 <a:solidFill>
                   <a:srgbClr val="555555"/>
                 </a:solidFill>
               </a:rPr>
               <a:t>2023.11.15</a:t>
             </a:r>
-            <a:endParaRPr lang="en-US" sz="1200" dirty="0"/>
+            <a:endParaRPr lang="en-US" sz="1000" dirty="0"/>
           </a:p>
         </p:txBody>
       </p:sp>
@@ -2762,31 +2762,31 @@
         </p:nvSpPr>
         <p:spPr>
           <a:xfrm>
-            <a:off x="5029200" y="2743200"/>
-            <a:ext cx="1828800" cy="914400"/>
-          </a:xfrm>
-          <a:prstGeom prst="rect">
-            <a:avLst/>
-          </a:prstGeom>
-          <a:noFill/>
-          <a:ln/>
-        </p:spPr>
-        <p:txBody>
-          <a:bodyPr wrap="square" rtlCol="0" anchor="ctr"/>
-          <a:lstStyle/>
-          <a:p>
-            <a:pPr indent="0" marL="0">
-              <a:buNone/>
-            </a:pPr>
-            <a:r>
-              <a:rPr lang="en-US" sz="4000" b="1" dirty="0">
+            <a:off x="4846320" y="2926080"/>
+            <a:ext cx="2011680" cy="731520"/>
+          </a:xfrm>
+          <a:prstGeom prst="rect">
+            <a:avLst/>
+          </a:prstGeom>
+          <a:noFill/>
+          <a:ln/>
+        </p:spPr>
+        <p:txBody>
+          <a:bodyPr wrap="square" rtlCol="0" anchor="ctr"/>
+          <a:lstStyle/>
+          <a:p>
+            <a:pPr indent="0" marL="0">
+              <a:buNone/>
+            </a:pPr>
+            <a:r>
+              <a:rPr lang="en-US" sz="3200" b="1" dirty="0">
                 <a:solidFill>
                   <a:srgbClr val="0A0A0B"/>
                 </a:solidFill>
               </a:rPr>
               <a:t>TRAE IDE</a:t>
             </a:r>
-            <a:endParaRPr lang="en-US" sz="4000" dirty="0"/>
+            <a:endParaRPr lang="en-US" sz="3200" dirty="0"/>
           </a:p>
         </p:txBody>
       </p:sp>
@@ -2798,31 +2798,31 @@
         </p:nvSpPr>
         <p:spPr>
           <a:xfrm>
-            <a:off x="5029200" y="3840480"/>
-            <a:ext cx="1828800" cy="457200"/>
-          </a:xfrm>
-          <a:prstGeom prst="rect">
-            <a:avLst/>
-          </a:prstGeom>
-          <a:noFill/>
-          <a:ln/>
-        </p:spPr>
-        <p:txBody>
-          <a:bodyPr wrap="square" rtlCol="0" anchor="ctr"/>
-          <a:lstStyle/>
-          <a:p>
-            <a:pPr indent="0" marL="0">
-              <a:buNone/>
-            </a:pPr>
-            <a:r>
-              <a:rPr lang="en-US" sz="1600" dirty="0">
+            <a:off x="4846320" y="3749040"/>
+            <a:ext cx="2011680" cy="365760"/>
+          </a:xfrm>
+          <a:prstGeom prst="rect">
+            <a:avLst/>
+          </a:prstGeom>
+          <a:noFill/>
+          <a:ln/>
+        </p:spPr>
+        <p:txBody>
+          <a:bodyPr wrap="square" rtlCol="0" anchor="ctr"/>
+          <a:lstStyle/>
+          <a:p>
+            <a:pPr indent="0" marL="0">
+              <a:buNone/>
+            </a:pPr>
+            <a:r>
+              <a:rPr lang="en-US" sz="1400" dirty="0">
                 <a:solidFill>
                   <a:srgbClr val="555555"/>
                 </a:solidFill>
               </a:rPr>
               <a:t>闭关产出</a:t>
             </a:r>
-            <a:endParaRPr lang="en-US" sz="1600" dirty="0"/>
+            <a:endParaRPr lang="en-US" sz="1400" dirty="0"/>
           </a:p>
         </p:txBody>
       </p:sp>
@@ -2834,31 +2834,31 @@
         </p:nvSpPr>
         <p:spPr>
           <a:xfrm>
-            <a:off x="5029200" y="4297680"/>
-            <a:ext cx="1828800" cy="457200"/>
-          </a:xfrm>
-          <a:prstGeom prst="rect">
-            <a:avLst/>
-          </a:prstGeom>
-          <a:noFill/>
-          <a:ln/>
-        </p:spPr>
-        <p:txBody>
-          <a:bodyPr wrap="square" rtlCol="0" anchor="ctr"/>
-          <a:lstStyle/>
-          <a:p>
-            <a:pPr indent="0" marL="0">
-              <a:buNone/>
-            </a:pPr>
-            <a:r>
-              <a:rPr lang="en-US" sz="1200" dirty="0">
+            <a:off x="4846320" y="4114800"/>
+            <a:ext cx="2011680" cy="365760"/>
+          </a:xfrm>
+          <a:prstGeom prst="rect">
+            <a:avLst/>
+          </a:prstGeom>
+          <a:noFill/>
+          <a:ln/>
+        </p:spPr>
+        <p:txBody>
+          <a:bodyPr wrap="square" rtlCol="0" anchor="ctr"/>
+          <a:lstStyle/>
+          <a:p>
+            <a:pPr indent="0" marL="0">
+              <a:buNone/>
+            </a:pPr>
+            <a:r>
+              <a:rPr lang="en-US" sz="1000" dirty="0">
                 <a:solidFill>
                   <a:srgbClr val="555555"/>
                 </a:solidFill>
               </a:rPr>
               <a:t>2024.11.15</a:t>
             </a:r>
-            <a:endParaRPr lang="en-US" sz="1200" dirty="0"/>
+            <a:endParaRPr lang="en-US" sz="1000" dirty="0"/>
           </a:p>
         </p:txBody>
       </p:sp>
@@ -2870,31 +2870,31 @@
         </p:nvSpPr>
         <p:spPr>
           <a:xfrm>
-            <a:off x="7315200" y="2743200"/>
-            <a:ext cx="1828800" cy="914400"/>
-          </a:xfrm>
-          <a:prstGeom prst="rect">
-            <a:avLst/>
-          </a:prstGeom>
-          <a:noFill/>
-          <a:ln/>
-        </p:spPr>
-        <p:txBody>
-          <a:bodyPr wrap="square" rtlCol="0" anchor="ctr"/>
-          <a:lstStyle/>
-          <a:p>
-            <a:pPr indent="0" marL="0">
-              <a:buNone/>
-            </a:pPr>
-            <a:r>
-              <a:rPr lang="en-US" sz="4000" b="1" dirty="0">
+            <a:off x="7040880" y="2926080"/>
+            <a:ext cx="2011680" cy="731520"/>
+          </a:xfrm>
+          <a:prstGeom prst="rect">
+            <a:avLst/>
+          </a:prstGeom>
+          <a:noFill/>
+          <a:ln/>
+        </p:spPr>
+        <p:txBody>
+          <a:bodyPr wrap="square" rtlCol="0" anchor="ctr"/>
+          <a:lstStyle/>
+          <a:p>
+            <a:pPr indent="0" marL="0">
+              <a:buNone/>
+            </a:pPr>
+            <a:r>
+              <a:rPr lang="en-US" sz="3200" b="1" dirty="0">
                 <a:solidFill>
                   <a:srgbClr val="0A0A0B"/>
                 </a:solidFill>
               </a:rPr>
               <a:t>SOLO 独立版</a:t>
             </a:r>
-            <a:endParaRPr lang="en-US" sz="4000" dirty="0"/>
+            <a:endParaRPr lang="en-US" sz="3200" dirty="0"/>
           </a:p>
         </p:txBody>
       </p:sp>
@@ -2906,31 +2906,31 @@
         </p:nvSpPr>
         <p:spPr>
           <a:xfrm>
-            <a:off x="7315200" y="3840480"/>
-            <a:ext cx="1828800" cy="457200"/>
-          </a:xfrm>
-          <a:prstGeom prst="rect">
-            <a:avLst/>
-          </a:prstGeom>
-          <a:noFill/>
-          <a:ln/>
-        </p:spPr>
-        <p:txBody>
-          <a:bodyPr wrap="square" rtlCol="0" anchor="ctr"/>
-          <a:lstStyle/>
-          <a:p>
-            <a:pPr indent="0" marL="0">
-              <a:buNone/>
-            </a:pPr>
-            <a:r>
-              <a:rPr lang="en-US" sz="1600" dirty="0">
+            <a:off x="7040880" y="3749040"/>
+            <a:ext cx="2011680" cy="365760"/>
+          </a:xfrm>
+          <a:prstGeom prst="rect">
+            <a:avLst/>
+          </a:prstGeom>
+          <a:noFill/>
+          <a:ln/>
+        </p:spPr>
+        <p:txBody>
+          <a:bodyPr wrap="square" rtlCol="0" anchor="ctr"/>
+          <a:lstStyle/>
+          <a:p>
+            <a:pPr indent="0" marL="0">
+              <a:buNone/>
+            </a:pPr>
+            <a:r>
+              <a:rPr lang="en-US" sz="1400" dirty="0">
                 <a:solidFill>
                   <a:srgbClr val="555555"/>
                 </a:solidFill>
               </a:rPr>
               <a:t>全新产出</a:t>
             </a:r>
-            <a:endParaRPr lang="en-US" sz="1600" dirty="0"/>
+            <a:endParaRPr lang="en-US" sz="1400" dirty="0"/>
           </a:p>
         </p:txBody>
       </p:sp>
@@ -2942,31 +2942,31 @@
         </p:nvSpPr>
         <p:spPr>
           <a:xfrm>
-            <a:off x="7315200" y="4297680"/>
-            <a:ext cx="1828800" cy="457200"/>
-          </a:xfrm>
-          <a:prstGeom prst="rect">
-            <a:avLst/>
-          </a:prstGeom>
-          <a:noFill/>
-          <a:ln/>
-        </p:spPr>
-        <p:txBody>
-          <a:bodyPr wrap="square" rtlCol="0" anchor="ctr"/>
-          <a:lstStyle/>
-          <a:p>
-            <a:pPr indent="0" marL="0">
-              <a:buNone/>
-            </a:pPr>
-            <a:r>
-              <a:rPr lang="en-US" sz="1200" dirty="0">
+            <a:off x="7040880" y="4114800"/>
+            <a:ext cx="2011680" cy="365760"/>
+          </a:xfrm>
+          <a:prstGeom prst="rect">
+            <a:avLst/>
+          </a:prstGeom>
+          <a:noFill/>
+          <a:ln/>
+        </p:spPr>
+        <p:txBody>
+          <a:bodyPr wrap="square" rtlCol="0" anchor="ctr"/>
+          <a:lstStyle/>
+          <a:p>
+            <a:pPr indent="0" marL="0">
+              <a:buNone/>
+            </a:pPr>
+            <a:r>
+              <a:rPr lang="en-US" sz="1000" dirty="0">
                 <a:solidFill>
                   <a:srgbClr val="555555"/>
                 </a:solidFill>
               </a:rPr>
               <a:t>2026年初 闭关</a:t>
             </a:r>
-            <a:endParaRPr lang="en-US" sz="1200" dirty="0"/>
+            <a:endParaRPr lang="en-US" sz="1000" dirty="0"/>
           </a:p>
         </p:txBody>
       </p:sp>
@@ -3186,59 +3186,59 @@
         </p:nvSpPr>
         <p:spPr>
           <a:xfrm>
-            <a:off x="457200" y="2743200"/>
-            <a:ext cx="5029200" cy="1828800"/>
-          </a:xfrm>
-          <a:prstGeom prst="rect">
-            <a:avLst/>
-          </a:prstGeom>
-          <a:noFill/>
-          <a:ln/>
-        </p:spPr>
-        <p:txBody>
-          <a:bodyPr wrap="square" rtlCol="0" anchor="ctr"/>
-          <a:lstStyle/>
-          <a:p>
-            <a:pPr indent="0" marL="0">
-              <a:buNone/>
-            </a:pPr>
-            <a:r>
-              <a:rPr lang="en-US" sz="2000" dirty="0">
+            <a:off x="457200" y="2286000"/>
+            <a:ext cx="7772400" cy="1371600"/>
+          </a:xfrm>
+          <a:prstGeom prst="rect">
+            <a:avLst/>
+          </a:prstGeom>
+          <a:noFill/>
+          <a:ln/>
+        </p:spPr>
+        <p:txBody>
+          <a:bodyPr wrap="square" rtlCol="0" anchor="ctr"/>
+          <a:lstStyle/>
+          <a:p>
+            <a:pPr indent="0" marL="0">
+              <a:buNone/>
+            </a:pPr>
+            <a:r>
+              <a:rPr lang="en-US" sz="1800" dirty="0">
                 <a:solidFill>
                   <a:srgbClr val="555555"/>
                 </a:solidFill>
               </a:rPr>
               <a:t>当时认为 Builder 只是吸引尝鲜，Tab Tab 才是过日子的惊喜感。虽然知道未来是 Agent（自主理解、调用工具、完成任务），但觉得这一天还很远。</a:t>
             </a:r>
-            <a:endParaRPr lang="en-US" sz="2000" dirty="0"/>
-          </a:p>
-          <a:p>
-            <a:pPr indent="0" marL="0">
-              <a:buNone/>
-            </a:pPr>
-            <a:r>
-              <a:rPr lang="en-US" sz="2000" dirty="0">
+            <a:endParaRPr lang="en-US" sz="1800" dirty="0"/>
+          </a:p>
+          <a:p>
+            <a:pPr indent="0" marL="0">
+              <a:buNone/>
+            </a:pPr>
+            <a:r>
+              <a:rPr lang="en-US" sz="1800" dirty="0">
                 <a:solidFill>
                   <a:srgbClr val="555555"/>
                 </a:solidFill>
               </a:rPr>
               <a:t>        </a:t>
             </a:r>
-            <a:endParaRPr lang="en-US" sz="2000" dirty="0"/>
-          </a:p>
-          <a:p>
-            <a:pPr indent="0" marL="0">
-              <a:buNone/>
-            </a:pPr>
-            <a:r>
-              <a:rPr lang="en-US" sz="2000" dirty="0">
+            <a:endParaRPr lang="en-US" sz="1800" dirty="0"/>
+          </a:p>
+          <a:p>
+            <a:pPr indent="0" marL="0">
+              <a:buNone/>
+            </a:pPr>
+            <a:r>
+              <a:rPr lang="en-US" sz="1800" dirty="0">
                 <a:solidFill>
                   <a:srgbClr val="555555"/>
                 </a:solidFill>
               </a:rPr>
               <a:t>          用 Agent 做长时间异步并行、在严肃场景中深度使用已成共识。比如社区 Expert 全年用 Agent 写了 30 万行代码，但只 Tab Tab 了 12 次。直接进入了第三阶段。</a:t>
             </a:r>
-            <a:endParaRPr lang="en-US" sz="2000" dirty="0"/>
+            <a:endParaRPr lang="en-US" sz="1800" dirty="0"/>
           </a:p>
         </p:txBody>
       </p:sp>
@@ -3354,31 +3354,31 @@
         </p:nvSpPr>
         <p:spPr>
           <a:xfrm>
-            <a:off x="457200" y="2743200"/>
-            <a:ext cx="5029200" cy="1828800"/>
-          </a:xfrm>
-          <a:prstGeom prst="rect">
-            <a:avLst/>
-          </a:prstGeom>
-          <a:noFill/>
-          <a:ln/>
-        </p:spPr>
-        <p:txBody>
-          <a:bodyPr wrap="square" rtlCol="0" anchor="ctr"/>
-          <a:lstStyle/>
-          <a:p>
-            <a:pPr indent="0" marL="0">
-              <a:buNone/>
-            </a:pPr>
-            <a:r>
-              <a:rPr lang="en-US" sz="2000" dirty="0">
+            <a:off x="457200" y="2286000"/>
+            <a:ext cx="7772400" cy="1371600"/>
+          </a:xfrm>
+          <a:prstGeom prst="rect">
+            <a:avLst/>
+          </a:prstGeom>
+          <a:noFill/>
+          <a:ln/>
+        </p:spPr>
+        <p:txBody>
+          <a:bodyPr wrap="square" rtlCol="0" anchor="ctr"/>
+          <a:lstStyle/>
+          <a:p>
+            <a:pPr indent="0" marL="0">
+              <a:buNone/>
+            </a:pPr>
+            <a:r>
+              <a:rPr lang="en-US" sz="1800" dirty="0">
                 <a:solidFill>
                   <a:srgbClr val="555555"/>
                 </a:solidFill>
               </a:rPr>
               <a:t>在前线看到了什么？我们把自己作为最佳实践，吃自己的狗粮。</a:t>
             </a:r>
-            <a:endParaRPr lang="en-US" sz="2000" dirty="0"/>
+            <a:endParaRPr lang="en-US" sz="1800" dirty="0"/>
           </a:p>
         </p:txBody>
       </p:sp>
@@ -3494,31 +3494,31 @@
         </p:nvSpPr>
         <p:spPr>
           <a:xfrm>
-            <a:off x="457200" y="2743200"/>
-            <a:ext cx="1828800" cy="914400"/>
-          </a:xfrm>
-          <a:prstGeom prst="rect">
-            <a:avLst/>
-          </a:prstGeom>
-          <a:noFill/>
-          <a:ln/>
-        </p:spPr>
-        <p:txBody>
-          <a:bodyPr wrap="square" rtlCol="0" anchor="ctr"/>
-          <a:lstStyle/>
-          <a:p>
-            <a:pPr indent="0" marL="0">
-              <a:buNone/>
-            </a:pPr>
-            <a:r>
-              <a:rPr lang="en-US" sz="4000" b="1" dirty="0">
+            <a:off x="457200" y="2926080"/>
+            <a:ext cx="2011680" cy="731520"/>
+          </a:xfrm>
+          <a:prstGeom prst="rect">
+            <a:avLst/>
+          </a:prstGeom>
+          <a:noFill/>
+          <a:ln/>
+        </p:spPr>
+        <p:txBody>
+          <a:bodyPr wrap="square" rtlCol="0" anchor="ctr"/>
+          <a:lstStyle/>
+          <a:p>
+            <a:pPr indent="0" marL="0">
+              <a:buNone/>
+            </a:pPr>
+            <a:r>
+              <a:rPr lang="en-US" sz="3200" b="1" dirty="0">
                 <a:solidFill>
                   <a:srgbClr val="F1EFEA"/>
                 </a:solidFill>
               </a:rPr>
               <a:t>100万+</a:t>
             </a:r>
-            <a:endParaRPr lang="en-US" sz="4000" dirty="0"/>
+            <a:endParaRPr lang="en-US" sz="3200" dirty="0"/>
           </a:p>
         </p:txBody>
       </p:sp>
@@ -3530,31 +3530,31 @@
         </p:nvSpPr>
         <p:spPr>
           <a:xfrm>
-            <a:off x="457200" y="3840480"/>
-            <a:ext cx="1828800" cy="457200"/>
-          </a:xfrm>
-          <a:prstGeom prst="rect">
-            <a:avLst/>
-          </a:prstGeom>
-          <a:noFill/>
-          <a:ln/>
-        </p:spPr>
-        <p:txBody>
-          <a:bodyPr wrap="square" rtlCol="0" anchor="ctr"/>
-          <a:lstStyle/>
-          <a:p>
-            <a:pPr indent="0" marL="0">
-              <a:buNone/>
-            </a:pPr>
-            <a:r>
-              <a:rPr lang="en-US" sz="1600" dirty="0">
+            <a:off x="457200" y="3749040"/>
+            <a:ext cx="2011680" cy="365760"/>
+          </a:xfrm>
+          <a:prstGeom prst="rect">
+            <a:avLst/>
+          </a:prstGeom>
+          <a:noFill/>
+          <a:ln/>
+        </p:spPr>
+        <p:txBody>
+          <a:bodyPr wrap="square" rtlCol="0" anchor="ctr"/>
+          <a:lstStyle/>
+          <a:p>
+            <a:pPr indent="0" marL="0">
+              <a:buNone/>
+            </a:pPr>
+            <a:r>
+              <a:rPr lang="en-US" sz="1400" dirty="0">
                 <a:solidFill>
                   <a:srgbClr val="CCCCCC"/>
                 </a:solidFill>
               </a:rPr>
               <a:t>产出代码行数</a:t>
             </a:r>
-            <a:endParaRPr lang="en-US" sz="1600" dirty="0"/>
+            <a:endParaRPr lang="en-US" sz="1400" dirty="0"/>
           </a:p>
         </p:txBody>
       </p:sp>
@@ -3566,31 +3566,31 @@
         </p:nvSpPr>
         <p:spPr>
           <a:xfrm>
-            <a:off x="2743200" y="2743200"/>
-            <a:ext cx="1828800" cy="914400"/>
-          </a:xfrm>
-          <a:prstGeom prst="rect">
-            <a:avLst/>
-          </a:prstGeom>
-          <a:noFill/>
-          <a:ln/>
-        </p:spPr>
-        <p:txBody>
-          <a:bodyPr wrap="square" rtlCol="0" anchor="ctr"/>
-          <a:lstStyle/>
-          <a:p>
-            <a:pPr indent="0" marL="0">
-              <a:buNone/>
-            </a:pPr>
-            <a:r>
-              <a:rPr lang="en-US" sz="4000" b="1" dirty="0">
+            <a:off x="2651760" y="2926080"/>
+            <a:ext cx="2011680" cy="731520"/>
+          </a:xfrm>
+          <a:prstGeom prst="rect">
+            <a:avLst/>
+          </a:prstGeom>
+          <a:noFill/>
+          <a:ln/>
+        </p:spPr>
+        <p:txBody>
+          <a:bodyPr wrap="square" rtlCol="0" anchor="ctr"/>
+          <a:lstStyle/>
+          <a:p>
+            <a:pPr indent="0" marL="0">
+              <a:buNone/>
+            </a:pPr>
+            <a:r>
+              <a:rPr lang="en-US" sz="3200" b="1" dirty="0">
                 <a:solidFill>
                   <a:srgbClr val="F1EFEA"/>
                 </a:solidFill>
               </a:rPr>
               <a:t>9,000+</a:t>
             </a:r>
-            <a:endParaRPr lang="en-US" sz="4000" dirty="0"/>
+            <a:endParaRPr lang="en-US" sz="3200" dirty="0"/>
           </a:p>
         </p:txBody>
       </p:sp>
@@ -3602,31 +3602,31 @@
         </p:nvSpPr>
         <p:spPr>
           <a:xfrm>
-            <a:off x="2743200" y="3840480"/>
-            <a:ext cx="1828800" cy="457200"/>
-          </a:xfrm>
-          <a:prstGeom prst="rect">
-            <a:avLst/>
-          </a:prstGeom>
-          <a:noFill/>
-          <a:ln/>
-        </p:spPr>
-        <p:txBody>
-          <a:bodyPr wrap="square" rtlCol="0" anchor="ctr"/>
-          <a:lstStyle/>
-          <a:p>
-            <a:pPr indent="0" marL="0">
-              <a:buNone/>
-            </a:pPr>
-            <a:r>
-              <a:rPr lang="en-US" sz="1600" dirty="0">
+            <a:off x="2651760" y="3749040"/>
+            <a:ext cx="2011680" cy="365760"/>
+          </a:xfrm>
+          <a:prstGeom prst="rect">
+            <a:avLst/>
+          </a:prstGeom>
+          <a:noFill/>
+          <a:ln/>
+        </p:spPr>
+        <p:txBody>
+          <a:bodyPr wrap="square" rtlCol="0" anchor="ctr"/>
+          <a:lstStyle/>
+          <a:p>
+            <a:pPr indent="0" marL="0">
+              <a:buNone/>
+            </a:pPr>
+            <a:r>
+              <a:rPr lang="en-US" sz="1400" dirty="0">
                 <a:solidFill>
                   <a:srgbClr val="CCCCCC"/>
                 </a:solidFill>
               </a:rPr>
               <a:t>总提交次数</a:t>
             </a:r>
-            <a:endParaRPr lang="en-US" sz="1600" dirty="0"/>
+            <a:endParaRPr lang="en-US" sz="1400" dirty="0"/>
           </a:p>
         </p:txBody>
       </p:sp>
@@ -3638,31 +3638,31 @@
         </p:nvSpPr>
         <p:spPr>
           <a:xfrm>
-            <a:off x="5029200" y="2743200"/>
-            <a:ext cx="1828800" cy="914400"/>
-          </a:xfrm>
-          <a:prstGeom prst="rect">
-            <a:avLst/>
-          </a:prstGeom>
-          <a:noFill/>
-          <a:ln/>
-        </p:spPr>
-        <p:txBody>
-          <a:bodyPr wrap="square" rtlCol="0" anchor="ctr"/>
-          <a:lstStyle/>
-          <a:p>
-            <a:pPr indent="0" marL="0">
-              <a:buNone/>
-            </a:pPr>
-            <a:r>
-              <a:rPr lang="en-US" sz="4000" b="1" dirty="0">
+            <a:off x="4846320" y="2926080"/>
+            <a:ext cx="2011680" cy="731520"/>
+          </a:xfrm>
+          <a:prstGeom prst="rect">
+            <a:avLst/>
+          </a:prstGeom>
+          <a:noFill/>
+          <a:ln/>
+        </p:spPr>
+        <p:txBody>
+          <a:bodyPr wrap="square" rtlCol="0" anchor="ctr"/>
+          <a:lstStyle/>
+          <a:p>
+            <a:pPr indent="0" marL="0">
+              <a:buNone/>
+            </a:pPr>
+            <a:r>
+              <a:rPr lang="en-US" sz="3200" b="1" dirty="0">
                 <a:solidFill>
                   <a:srgbClr val="F1EFEA"/>
                 </a:solidFill>
               </a:rPr>
               <a:t>93%</a:t>
             </a:r>
-            <a:endParaRPr lang="en-US" sz="4000" dirty="0"/>
+            <a:endParaRPr lang="en-US" sz="3200" dirty="0"/>
           </a:p>
         </p:txBody>
       </p:sp>
@@ -3674,31 +3674,31 @@
         </p:nvSpPr>
         <p:spPr>
           <a:xfrm>
-            <a:off x="5029200" y="3840480"/>
-            <a:ext cx="1828800" cy="457200"/>
-          </a:xfrm>
-          <a:prstGeom prst="rect">
-            <a:avLst/>
-          </a:prstGeom>
-          <a:noFill/>
-          <a:ln/>
-        </p:spPr>
-        <p:txBody>
-          <a:bodyPr wrap="square" rtlCol="0" anchor="ctr"/>
-          <a:lstStyle/>
-          <a:p>
-            <a:pPr indent="0" marL="0">
-              <a:buNone/>
-            </a:pPr>
-            <a:r>
-              <a:rPr lang="en-US" sz="1600" dirty="0">
+            <a:off x="4846320" y="3749040"/>
+            <a:ext cx="2011680" cy="365760"/>
+          </a:xfrm>
+          <a:prstGeom prst="rect">
+            <a:avLst/>
+          </a:prstGeom>
+          <a:noFill/>
+          <a:ln/>
+        </p:spPr>
+        <p:txBody>
+          <a:bodyPr wrap="square" rtlCol="0" anchor="ctr"/>
+          <a:lstStyle/>
+          <a:p>
+            <a:pPr indent="0" marL="0">
+              <a:buNone/>
+            </a:pPr>
+            <a:r>
+              <a:rPr lang="en-US" sz="1400" dirty="0">
                 <a:solidFill>
                   <a:srgbClr val="CCCCCC"/>
                 </a:solidFill>
               </a:rPr>
               <a:t>AI 代码贡献率</a:t>
             </a:r>
-            <a:endParaRPr lang="en-US" sz="1600" dirty="0"/>
+            <a:endParaRPr lang="en-US" sz="1400" dirty="0"/>
           </a:p>
         </p:txBody>
       </p:sp>
@@ -3710,31 +3710,31 @@
         </p:nvSpPr>
         <p:spPr>
           <a:xfrm>
-            <a:off x="5029200" y="4297680"/>
-            <a:ext cx="1828800" cy="457200"/>
-          </a:xfrm>
-          <a:prstGeom prst="rect">
-            <a:avLst/>
-          </a:prstGeom>
-          <a:noFill/>
-          <a:ln/>
-        </p:spPr>
-        <p:txBody>
-          <a:bodyPr wrap="square" rtlCol="0" anchor="ctr"/>
-          <a:lstStyle/>
-          <a:p>
-            <a:pPr indent="0" marL="0">
-              <a:buNone/>
-            </a:pPr>
-            <a:r>
-              <a:rPr lang="en-US" sz="1200" dirty="0">
+            <a:off x="4846320" y="4114800"/>
+            <a:ext cx="2011680" cy="365760"/>
+          </a:xfrm>
+          <a:prstGeom prst="rect">
+            <a:avLst/>
+          </a:prstGeom>
+          <a:noFill/>
+          <a:ln/>
+        </p:spPr>
+        <p:txBody>
+          <a:bodyPr wrap="square" rtlCol="0" anchor="ctr"/>
+          <a:lstStyle/>
+          <a:p>
+            <a:pPr indent="0" marL="0">
+              <a:buNone/>
+            </a:pPr>
+            <a:r>
+              <a:rPr lang="en-US" sz="1000" dirty="0">
                 <a:solidFill>
                   <a:srgbClr val="CCCCCC"/>
                 </a:solidFill>
               </a:rPr>
               <a:t>半年后可能就是整个行业的常态</a:t>
             </a:r>
-            <a:endParaRPr lang="en-US" sz="1200" dirty="0"/>
+            <a:endParaRPr lang="en-US" sz="1000" dirty="0"/>
           </a:p>
         </p:txBody>
       </p:sp>
@@ -3850,31 +3850,31 @@
         </p:nvSpPr>
         <p:spPr>
           <a:xfrm>
-            <a:off x="457200" y="2743200"/>
-            <a:ext cx="5029200" cy="1828800"/>
-          </a:xfrm>
-          <a:prstGeom prst="rect">
-            <a:avLst/>
-          </a:prstGeom>
-          <a:noFill/>
-          <a:ln/>
-        </p:spPr>
-        <p:txBody>
-          <a:bodyPr wrap="square" rtlCol="0" anchor="ctr"/>
-          <a:lstStyle/>
-          <a:p>
-            <a:pPr indent="0" marL="0">
-              <a:buNone/>
-            </a:pPr>
-            <a:r>
-              <a:rPr lang="en-US" sz="2000" dirty="0">
+            <a:off x="457200" y="2286000"/>
+            <a:ext cx="7772400" cy="1371600"/>
+          </a:xfrm>
+          <a:prstGeom prst="rect">
+            <a:avLst/>
+          </a:prstGeom>
+          <a:noFill/>
+          <a:ln/>
+        </p:spPr>
+        <p:txBody>
+          <a:bodyPr wrap="square" rtlCol="0" anchor="ctr"/>
+          <a:lstStyle/>
+          <a:p>
+            <a:pPr indent="0" marL="0">
+              <a:buNone/>
+            </a:pPr>
+            <a:r>
+              <a:rPr lang="en-US" sz="1800" dirty="0">
                 <a:solidFill>
                   <a:srgbClr val="555555"/>
                 </a:solidFill>
               </a:rPr>
               <a:t>我们将团队的“隐性知识”沉淀为 AI 能读懂的 Skill 文件。那些只存在老员工脑子里的模块设计取舍、隐性耦合，现在变成了 AI 可以准确执行的标准。</a:t>
             </a:r>
-            <a:endParaRPr lang="en-US" sz="2000" dirty="0"/>
+            <a:endParaRPr lang="en-US" sz="1800" dirty="0"/>
           </a:p>
         </p:txBody>
       </p:sp>
@@ -4050,31 +4050,31 @@
         </p:nvSpPr>
         <p:spPr>
           <a:xfrm>
-            <a:off x="457200" y="2743200"/>
-            <a:ext cx="5029200" cy="1828800"/>
-          </a:xfrm>
-          <a:prstGeom prst="rect">
-            <a:avLst/>
-          </a:prstGeom>
-          <a:noFill/>
-          <a:ln/>
-        </p:spPr>
-        <p:txBody>
-          <a:bodyPr wrap="square" rtlCol="0" anchor="ctr"/>
-          <a:lstStyle/>
-          <a:p>
-            <a:pPr indent="0" marL="0">
-              <a:buNone/>
-            </a:pPr>
-            <a:r>
-              <a:rPr lang="en-US" sz="2000" dirty="0">
+            <a:off x="457200" y="2286000"/>
+            <a:ext cx="7772400" cy="1371600"/>
+          </a:xfrm>
+          <a:prstGeom prst="rect">
+            <a:avLst/>
+          </a:prstGeom>
+          <a:noFill/>
+          <a:ln/>
+        </p:spPr>
+        <p:txBody>
+          <a:bodyPr wrap="square" rtlCol="0" anchor="ctr"/>
+          <a:lstStyle/>
+          <a:p>
+            <a:pPr indent="0" marL="0">
+              <a:buNone/>
+            </a:pPr>
+            <a:r>
+              <a:rPr lang="en-US" sz="1800" dirty="0">
                 <a:solidFill>
                   <a:srgbClr val="555555"/>
                 </a:solidFill>
               </a:rPr>
               <a:t>AI 让写代码快了一个数量级，但产出量大了，Review 成为瓶颈。上下游衔接成本上升，交付周期并未同比例缩短。</a:t>
             </a:r>
-            <a:endParaRPr lang="en-US" sz="2000" dirty="0"/>
+            <a:endParaRPr lang="en-US" sz="1800" dirty="0"/>
           </a:p>
         </p:txBody>
       </p:sp>
@@ -4250,31 +4250,31 @@
         </p:nvSpPr>
         <p:spPr>
           <a:xfrm>
-            <a:off x="457200" y="2743200"/>
-            <a:ext cx="5029200" cy="1828800"/>
-          </a:xfrm>
-          <a:prstGeom prst="rect">
-            <a:avLst/>
-          </a:prstGeom>
-          <a:noFill/>
-          <a:ln/>
-        </p:spPr>
-        <p:txBody>
-          <a:bodyPr wrap="square" rtlCol="0" anchor="ctr"/>
-          <a:lstStyle/>
-          <a:p>
-            <a:pPr indent="0" marL="0">
-              <a:buNone/>
-            </a:pPr>
-            <a:r>
-              <a:rPr lang="en-US" sz="2000" dirty="0">
+            <a:off x="457200" y="2286000"/>
+            <a:ext cx="7772400" cy="1371600"/>
+          </a:xfrm>
+          <a:prstGeom prst="rect">
+            <a:avLst/>
+          </a:prstGeom>
+          <a:noFill/>
+          <a:ln/>
+        </p:spPr>
+        <p:txBody>
+          <a:bodyPr wrap="square" rtlCol="0" anchor="ctr"/>
+          <a:lstStyle/>
+          <a:p>
+            <a:pPr indent="0" marL="0">
+              <a:buNone/>
+            </a:pPr>
+            <a:r>
+              <a:rPr lang="en-US" sz="1800" dirty="0">
                 <a:solidFill>
                   <a:srgbClr val="CCCCCC"/>
                 </a:solidFill>
               </a:rPr>
               <a:t>基于一线的实践经验，我们看到了 AI Coding 正在发生的质变。</a:t>
             </a:r>
-            <a:endParaRPr lang="en-US" sz="2000" dirty="0"/>
+            <a:endParaRPr lang="en-US" sz="1800" dirty="0"/>
           </a:p>
         </p:txBody>
       </p:sp>

</xml_diff>

<commit_message>
refactor: completely rebuild pptx generation script to support grid and split layouts
</commit_message>
<xml_diff>
--- a/SOLO-0408-直播/ppt/SOLO_0418_直播.pptx
+++ b/SOLO-0408-直播/ppt/SOLO_0418_直播.pptx
@@ -1836,7 +1836,7 @@
     <p:bg>
       <p:bgPr>
         <a:solidFill>
-          <a:srgbClr val="0A0A0B"/>
+          <a:srgbClr val="1E1E1E"/>
         </a:solidFill>
       </p:bgPr>
     </p:bg>
@@ -1862,7 +1862,121 @@
         </p:nvSpPr>
         <p:spPr>
           <a:xfrm>
-            <a:off x="457200" y="457200"/>
+            <a:off x="457200" y="274320"/>
+            <a:ext cx="3657600" cy="274320"/>
+          </a:xfrm>
+          <a:prstGeom prst="rect">
+            <a:avLst/>
+          </a:prstGeom>
+          <a:noFill/>
+          <a:ln/>
+        </p:spPr>
+        <p:txBody>
+          <a:bodyPr wrap="square" rtlCol="0" anchor="ctr"/>
+          <a:lstStyle/>
+          <a:p>
+            <a:pPr indent="0" marL="0">
+              <a:buNone/>
+            </a:pPr>
+            <a:r>
+              <a:rPr lang="en-US" sz="1000" dirty="0">
+                <a:solidFill>
+                  <a:srgbClr val="A0A0A0"/>
+                </a:solidFill>
+                <a:latin typeface="Courier New" pitchFamily="34" charset="0"/>
+                <a:ea typeface="Courier New" pitchFamily="34" charset="-122"/>
+                <a:cs typeface="Courier New" pitchFamily="34" charset="-120"/>
+              </a:rPr>
+              <a:t>SOLO 0418 直播 · 天猪</a:t>
+            </a:r>
+            <a:endParaRPr lang="en-US" sz="1000" dirty="0"/>
+          </a:p>
+        </p:txBody>
+      </p:sp>
+      <p:sp>
+        <p:nvSpPr>
+          <p:cNvPr id="3" name="Text 1"/>
+          <p:cNvSpPr/>
+          <p:nvPr/>
+        </p:nvSpPr>
+        <p:spPr>
+          <a:xfrm>
+            <a:off x="5029200" y="274320"/>
+            <a:ext cx="3657600" cy="274320"/>
+          </a:xfrm>
+          <a:prstGeom prst="rect">
+            <a:avLst/>
+          </a:prstGeom>
+          <a:noFill/>
+          <a:ln/>
+        </p:spPr>
+        <p:txBody>
+          <a:bodyPr wrap="square" rtlCol="0" anchor="ctr"/>
+          <a:lstStyle/>
+          <a:p>
+            <a:pPr algn="r" indent="0" marL="0">
+              <a:buNone/>
+            </a:pPr>
+            <a:r>
+              <a:rPr lang="en-US" sz="1000" dirty="0">
+                <a:solidFill>
+                  <a:srgbClr val="A0A0A0"/>
+                </a:solidFill>
+                <a:latin typeface="Courier New" pitchFamily="34" charset="0"/>
+                <a:ea typeface="Courier New" pitchFamily="34" charset="-122"/>
+                <a:cs typeface="Courier New" pitchFamily="34" charset="-120"/>
+              </a:rPr>
+              <a:t>ACT 0 · 01 / 12</a:t>
+            </a:r>
+            <a:endParaRPr lang="en-US" sz="1000" dirty="0"/>
+          </a:p>
+        </p:txBody>
+      </p:sp>
+      <p:sp>
+        <p:nvSpPr>
+          <p:cNvPr id="4" name="Text 2"/>
+          <p:cNvSpPr/>
+          <p:nvPr/>
+        </p:nvSpPr>
+        <p:spPr>
+          <a:xfrm>
+            <a:off x="457200" y="1828800"/>
+            <a:ext cx="8229600" cy="1097280"/>
+          </a:xfrm>
+          <a:prstGeom prst="rect">
+            <a:avLst/>
+          </a:prstGeom>
+          <a:noFill/>
+          <a:ln/>
+        </p:spPr>
+        <p:txBody>
+          <a:bodyPr wrap="square" rtlCol="0" anchor="t"/>
+          <a:lstStyle/>
+          <a:p>
+            <a:pPr algn="ctr" indent="0" marL="0">
+              <a:buNone/>
+            </a:pPr>
+            <a:r>
+              <a:rPr lang="en-US" sz="5400" b="1" dirty="0">
+                <a:solidFill>
+                  <a:srgbClr val="F9F9F7"/>
+                </a:solidFill>
+              </a:rPr>
+              <a:t>SOLO 独立版</a:t>
+            </a:r>
+            <a:endParaRPr lang="en-US" sz="5400" dirty="0"/>
+          </a:p>
+        </p:txBody>
+      </p:sp>
+      <p:sp>
+        <p:nvSpPr>
+          <p:cNvPr id="5" name="Text 3"/>
+          <p:cNvSpPr/>
+          <p:nvPr/>
+        </p:nvSpPr>
+        <p:spPr>
+          <a:xfrm>
+            <a:off x="457200" y="3017520"/>
             <a:ext cx="8229600" cy="457200"/>
           </a:xfrm>
           <a:prstGeom prst="rect">
@@ -1875,90 +1989,54 @@
           <a:bodyPr wrap="square" rtlCol="0" anchor="ctr"/>
           <a:lstStyle/>
           <a:p>
-            <a:pPr indent="0" marL="0">
-              <a:buNone/>
-            </a:pPr>
-            <a:r>
-              <a:rPr lang="en-US" sz="1400" spc="200" kern="0" dirty="0">
-                <a:solidFill>
-                  <a:srgbClr val="CCCCCC"/>
-                </a:solidFill>
-              </a:rPr>
-              <a:t>SOLO 独立版发布</a:t>
-            </a:r>
-            <a:endParaRPr lang="en-US" sz="1400" dirty="0"/>
-          </a:p>
-        </p:txBody>
-      </p:sp>
-      <p:sp>
-        <p:nvSpPr>
-          <p:cNvPr id="3" name="Text 1"/>
-          <p:cNvSpPr/>
-          <p:nvPr/>
-        </p:nvSpPr>
-        <p:spPr>
-          <a:xfrm>
-            <a:off x="457200" y="1097280"/>
-            <a:ext cx="8229600" cy="1371600"/>
-          </a:xfrm>
-          <a:prstGeom prst="rect">
-            <a:avLst/>
-          </a:prstGeom>
-          <a:noFill/>
-          <a:ln/>
-        </p:spPr>
-        <p:txBody>
-          <a:bodyPr wrap="square" rtlCol="0" anchor="ctr"/>
-          <a:lstStyle/>
-          <a:p>
-            <a:pPr indent="0" marL="0">
-              <a:buNone/>
-            </a:pPr>
-            <a:r>
-              <a:rPr lang="en-US" sz="4800" b="1" dirty="0">
-                <a:solidFill>
-                  <a:srgbClr val="F1EFEA"/>
-                </a:solidFill>
-              </a:rPr>
-              <a:t>SOLO 独立版</a:t>
-            </a:r>
-            <a:endParaRPr lang="en-US" sz="4800" dirty="0"/>
-          </a:p>
-        </p:txBody>
-      </p:sp>
-      <p:sp>
-        <p:nvSpPr>
-          <p:cNvPr id="4" name="Text 2"/>
-          <p:cNvSpPr/>
-          <p:nvPr/>
-        </p:nvSpPr>
-        <p:spPr>
-          <a:xfrm>
-            <a:off x="457200" y="2286000"/>
-            <a:ext cx="7772400" cy="1371600"/>
-          </a:xfrm>
-          <a:prstGeom prst="rect">
-            <a:avLst/>
-          </a:prstGeom>
-          <a:noFill/>
-          <a:ln/>
-        </p:spPr>
-        <p:txBody>
-          <a:bodyPr wrap="square" rtlCol="0" anchor="ctr"/>
-          <a:lstStyle/>
-          <a:p>
-            <a:pPr indent="0" marL="0">
-              <a:buNone/>
-            </a:pPr>
-            <a:r>
-              <a:rPr lang="en-US" sz="1800" dirty="0">
-                <a:solidFill>
-                  <a:srgbClr val="CCCCCC"/>
+            <a:pPr algn="ctr" indent="0" marL="0">
+              <a:buNone/>
+            </a:pPr>
+            <a:r>
+              <a:rPr lang="en-US" sz="2400" dirty="0">
+                <a:solidFill>
+                  <a:srgbClr val="A0A0A0"/>
+                </a:solidFill>
+              </a:rPr>
+              <a:t>探索 AI Coding 的第三阶段：AI 自主编程</a:t>
+            </a:r>
+            <a:endParaRPr lang="en-US" sz="2400" dirty="0"/>
+          </a:p>
+        </p:txBody>
+      </p:sp>
+      <p:sp>
+        <p:nvSpPr>
+          <p:cNvPr id="6" name="Text 4"/>
+          <p:cNvSpPr/>
+          <p:nvPr/>
+        </p:nvSpPr>
+        <p:spPr>
+          <a:xfrm>
+            <a:off x="1371600" y="3657600"/>
+            <a:ext cx="6400800" cy="914400"/>
+          </a:xfrm>
+          <a:prstGeom prst="rect">
+            <a:avLst/>
+          </a:prstGeom>
+          <a:noFill/>
+          <a:ln/>
+        </p:spPr>
+        <p:txBody>
+          <a:bodyPr wrap="square" rtlCol="0" anchor="t"/>
+          <a:lstStyle/>
+          <a:p>
+            <a:pPr algn="ctr" indent="0" marL="0">
+              <a:buNone/>
+            </a:pPr>
+            <a:r>
+              <a:rPr lang="en-US" sz="2000" dirty="0">
+                <a:solidFill>
+                  <a:srgbClr val="A0A0A0"/>
                 </a:solidFill>
               </a:rPr>
               <a:t>随着大模型能力的极大提升，AI 已经从编程扩展到各个领域。今天，我们正式推出 SOLO 独立版。</a:t>
             </a:r>
-            <a:endParaRPr lang="en-US" sz="1800" dirty="0"/>
+            <a:endParaRPr lang="en-US" sz="2000" dirty="0"/>
           </a:p>
         </p:txBody>
       </p:sp>
@@ -1976,7 +2054,7 @@
     <p:bg>
       <p:bgPr>
         <a:solidFill>
-          <a:srgbClr val="F1EFEA"/>
+          <a:srgbClr val="F9F9F7"/>
         </a:solidFill>
       </p:bgPr>
     </p:bg>
@@ -2002,26 +2080,104 @@
         </p:nvSpPr>
         <p:spPr>
           <a:xfrm>
-            <a:off x="457200" y="457200"/>
-            <a:ext cx="8229600" cy="457200"/>
-          </a:xfrm>
-          <a:prstGeom prst="rect">
-            <a:avLst/>
-          </a:prstGeom>
-          <a:noFill/>
-          <a:ln/>
-        </p:spPr>
-        <p:txBody>
-          <a:bodyPr wrap="square" rtlCol="0" anchor="ctr"/>
-          <a:lstStyle/>
-          <a:p>
-            <a:pPr indent="0" marL="0">
-              <a:buNone/>
-            </a:pPr>
-            <a:r>
-              <a:rPr lang="en-US" sz="1400" spc="200" kern="0" dirty="0">
-                <a:solidFill>
-                  <a:srgbClr val="555555"/>
+            <a:off x="457200" y="274320"/>
+            <a:ext cx="3657600" cy="274320"/>
+          </a:xfrm>
+          <a:prstGeom prst="rect">
+            <a:avLst/>
+          </a:prstGeom>
+          <a:noFill/>
+          <a:ln/>
+        </p:spPr>
+        <p:txBody>
+          <a:bodyPr wrap="square" rtlCol="0" anchor="ctr"/>
+          <a:lstStyle/>
+          <a:p>
+            <a:pPr indent="0" marL="0">
+              <a:buNone/>
+            </a:pPr>
+            <a:r>
+              <a:rPr lang="en-US" sz="1000" dirty="0">
+                <a:solidFill>
+                  <a:srgbClr val="666666"/>
+                </a:solidFill>
+                <a:latin typeface="Courier New" pitchFamily="34" charset="0"/>
+                <a:ea typeface="Courier New" pitchFamily="34" charset="-122"/>
+                <a:cs typeface="Courier New" pitchFamily="34" charset="-120"/>
+              </a:rPr>
+              <a:t>趋势 1 · 场景泛化</a:t>
+            </a:r>
+            <a:endParaRPr lang="en-US" sz="1000" dirty="0"/>
+          </a:p>
+        </p:txBody>
+      </p:sp>
+      <p:sp>
+        <p:nvSpPr>
+          <p:cNvPr id="3" name="Text 1"/>
+          <p:cNvSpPr/>
+          <p:nvPr/>
+        </p:nvSpPr>
+        <p:spPr>
+          <a:xfrm>
+            <a:off x="5029200" y="274320"/>
+            <a:ext cx="3657600" cy="274320"/>
+          </a:xfrm>
+          <a:prstGeom prst="rect">
+            <a:avLst/>
+          </a:prstGeom>
+          <a:noFill/>
+          <a:ln/>
+        </p:spPr>
+        <p:txBody>
+          <a:bodyPr wrap="square" rtlCol="0" anchor="ctr"/>
+          <a:lstStyle/>
+          <a:p>
+            <a:pPr algn="r" indent="0" marL="0">
+              <a:buNone/>
+            </a:pPr>
+            <a:r>
+              <a:rPr lang="en-US" sz="1000" dirty="0">
+                <a:solidFill>
+                  <a:srgbClr val="666666"/>
+                </a:solidFill>
+                <a:latin typeface="Courier New" pitchFamily="34" charset="0"/>
+                <a:ea typeface="Courier New" pitchFamily="34" charset="-122"/>
+                <a:cs typeface="Courier New" pitchFamily="34" charset="-120"/>
+              </a:rPr>
+              <a:t>ACT III · 10 / 12</a:t>
+            </a:r>
+            <a:endParaRPr lang="en-US" sz="1000" dirty="0"/>
+          </a:p>
+        </p:txBody>
+      </p:sp>
+      <p:sp>
+        <p:nvSpPr>
+          <p:cNvPr id="4" name="Text 2"/>
+          <p:cNvSpPr/>
+          <p:nvPr/>
+        </p:nvSpPr>
+        <p:spPr>
+          <a:xfrm>
+            <a:off x="457200" y="914400"/>
+            <a:ext cx="8229600" cy="274320"/>
+          </a:xfrm>
+          <a:prstGeom prst="rect">
+            <a:avLst/>
+          </a:prstGeom>
+          <a:noFill/>
+          <a:ln/>
+        </p:spPr>
+        <p:txBody>
+          <a:bodyPr wrap="square" rtlCol="0" anchor="ctr"/>
+          <a:lstStyle/>
+          <a:p>
+            <a:pPr indent="0" marL="0">
+              <a:buNone/>
+            </a:pPr>
+            <a:r>
+              <a:rPr lang="en-US" sz="1400" b="1" dirty="0">
+                <a:solidFill>
+                  <a:srgbClr val="0F52BA"/>
                 </a:solidFill>
               </a:rPr>
               <a:t>More Than Coding</a:t>
@@ -2032,101 +2188,217 @@
       </p:sp>
       <p:sp>
         <p:nvSpPr>
-          <p:cNvPr id="3" name="Text 1"/>
-          <p:cNvSpPr/>
-          <p:nvPr/>
-        </p:nvSpPr>
-        <p:spPr>
-          <a:xfrm>
-            <a:off x="457200" y="1097280"/>
-            <a:ext cx="8229600" cy="1371600"/>
-          </a:xfrm>
-          <a:prstGeom prst="rect">
-            <a:avLst/>
-          </a:prstGeom>
-          <a:noFill/>
-          <a:ln/>
-        </p:spPr>
-        <p:txBody>
-          <a:bodyPr wrap="square" rtlCol="0" anchor="ctr"/>
-          <a:lstStyle/>
-          <a:p>
-            <a:pPr indent="0" marL="0">
-              <a:buNone/>
-            </a:pPr>
-            <a:r>
-              <a:rPr lang="en-US" sz="4800" b="1" dirty="0">
-                <a:solidFill>
-                  <a:srgbClr val="0A0A0B"/>
+          <p:cNvPr id="5" name="Text 3"/>
+          <p:cNvSpPr/>
+          <p:nvPr/>
+        </p:nvSpPr>
+        <p:spPr>
+          <a:xfrm>
+            <a:off x="457200" y="1280160"/>
+            <a:ext cx="8229600" cy="1097280"/>
+          </a:xfrm>
+          <a:prstGeom prst="rect">
+            <a:avLst/>
+          </a:prstGeom>
+          <a:noFill/>
+          <a:ln/>
+        </p:spPr>
+        <p:txBody>
+          <a:bodyPr wrap="square" rtlCol="0" anchor="t"/>
+          <a:lstStyle/>
+          <a:p>
+            <a:pPr algn="l" indent="0" marL="0">
+              <a:buNone/>
+            </a:pPr>
+            <a:r>
+              <a:rPr lang="en-US" sz="3600" b="1" dirty="0">
+                <a:solidFill>
+                  <a:srgbClr val="1E1E1E"/>
                 </a:solidFill>
               </a:rPr>
               <a:t>AI Coding 正在成为基础设施</a:t>
             </a:r>
-            <a:endParaRPr lang="en-US" sz="4800" dirty="0"/>
-          </a:p>
-        </p:txBody>
-      </p:sp>
-      <p:sp>
-        <p:nvSpPr>
-          <p:cNvPr id="4" name="Text 2"/>
-          <p:cNvSpPr/>
-          <p:nvPr/>
-        </p:nvSpPr>
-        <p:spPr>
-          <a:xfrm>
-            <a:off x="457200" y="2286000"/>
-            <a:ext cx="7772400" cy="1371600"/>
-          </a:xfrm>
-          <a:prstGeom prst="rect">
-            <a:avLst/>
-          </a:prstGeom>
-          <a:noFill/>
-          <a:ln/>
-        </p:spPr>
-        <p:txBody>
-          <a:bodyPr wrap="square" rtlCol="0" anchor="ctr"/>
-          <a:lstStyle/>
-          <a:p>
-            <a:pPr indent="0" marL="0">
-              <a:buNone/>
-            </a:pPr>
-            <a:r>
-              <a:rPr lang="en-US" sz="1800" dirty="0">
-                <a:solidFill>
-                  <a:srgbClr val="555555"/>
+            <a:endParaRPr lang="en-US" sz="3600" dirty="0"/>
+          </a:p>
+        </p:txBody>
+      </p:sp>
+      <p:sp>
+        <p:nvSpPr>
+          <p:cNvPr id="6" name="Text 4"/>
+          <p:cNvSpPr/>
+          <p:nvPr/>
+        </p:nvSpPr>
+        <p:spPr>
+          <a:xfrm>
+            <a:off x="457200" y="2743200"/>
+            <a:ext cx="3657600" cy="457200"/>
+          </a:xfrm>
+          <a:prstGeom prst="rect">
+            <a:avLst/>
+          </a:prstGeom>
+          <a:noFill/>
+          <a:ln/>
+        </p:spPr>
+        <p:txBody>
+          <a:bodyPr wrap="square" rtlCol="0" anchor="ctr"/>
+          <a:lstStyle/>
+          <a:p>
+            <a:pPr indent="0" marL="0">
+              <a:buNone/>
+            </a:pPr>
+            <a:r>
+              <a:rPr lang="en-US" sz="2000" b="1" dirty="0">
+                <a:solidFill>
+                  <a:srgbClr val="1E1E1E"/>
+                </a:solidFill>
+              </a:rPr>
+              <a:t>纵向：研发链条延伸</a:t>
+            </a:r>
+            <a:endParaRPr lang="en-US" sz="2000" dirty="0"/>
+          </a:p>
+        </p:txBody>
+      </p:sp>
+      <p:sp>
+        <p:nvSpPr>
+          <p:cNvPr id="7" name="Text 5"/>
+          <p:cNvSpPr/>
+          <p:nvPr/>
+        </p:nvSpPr>
+        <p:spPr>
+          <a:xfrm>
+            <a:off x="457200" y="3291840"/>
+            <a:ext cx="3840480" cy="1828800"/>
+          </a:xfrm>
+          <a:prstGeom prst="rect">
+            <a:avLst/>
+          </a:prstGeom>
+          <a:noFill/>
+          <a:ln/>
+        </p:spPr>
+        <p:txBody>
+          <a:bodyPr wrap="square" rtlCol="0" anchor="t"/>
+          <a:lstStyle/>
+          <a:p>
+            <a:pPr indent="0" marL="0">
+              <a:buNone/>
+            </a:pPr>
+            <a:r>
+              <a:rPr lang="en-US" sz="1600" dirty="0">
+                <a:solidFill>
+                  <a:srgbClr val="666666"/>
                 </a:solidFill>
               </a:rPr>
               <a:t>从需求分析、交互设计、编码研发，到质量保障、线上运维。整条链路上的角色都在从中受益，不再只是程序员的专属。</a:t>
             </a:r>
-            <a:endParaRPr lang="en-US" sz="1800" dirty="0"/>
-          </a:p>
-          <a:p>
-            <a:pPr indent="0" marL="0">
-              <a:buNone/>
-            </a:pPr>
-            <a:r>
-              <a:rPr lang="en-US" sz="1800" dirty="0">
-                <a:solidFill>
-                  <a:srgbClr val="555555"/>
-                </a:solidFill>
-              </a:rPr>
-              <a:t>        </a:t>
-            </a:r>
-            <a:endParaRPr lang="en-US" sz="1800" dirty="0"/>
-          </a:p>
-          <a:p>
-            <a:pPr indent="0" marL="0">
-              <a:buNone/>
-            </a:pPr>
-            <a:r>
-              <a:rPr lang="en-US" sz="1800" dirty="0">
-                <a:solidFill>
-                  <a:srgbClr val="555555"/>
-                </a:solidFill>
-              </a:rPr>
-              <a:t>          技术调研、写设计文档、整理会议纪要，甚至管理本地知识库。AI 的价值远不止于写代码。这也是 SOLO 提供 Work 模式的原因。</a:t>
-            </a:r>
-            <a:endParaRPr lang="en-US" sz="1800" dirty="0"/>
+            <a:endParaRPr lang="en-US" sz="1600" dirty="0"/>
+          </a:p>
+        </p:txBody>
+      </p:sp>
+      <p:sp>
+        <p:nvSpPr>
+          <p:cNvPr id="8" name="Text 6"/>
+          <p:cNvSpPr/>
+          <p:nvPr/>
+        </p:nvSpPr>
+        <p:spPr>
+          <a:xfrm>
+            <a:off x="4572000" y="2743200"/>
+            <a:ext cx="3657600" cy="457200"/>
+          </a:xfrm>
+          <a:prstGeom prst="rect">
+            <a:avLst/>
+          </a:prstGeom>
+          <a:noFill/>
+          <a:ln/>
+        </p:spPr>
+        <p:txBody>
+          <a:bodyPr wrap="square" rtlCol="0" anchor="ctr"/>
+          <a:lstStyle/>
+          <a:p>
+            <a:pPr indent="0" marL="0">
+              <a:buNone/>
+            </a:pPr>
+            <a:r>
+              <a:rPr lang="en-US" sz="2000" b="1" dirty="0">
+                <a:solidFill>
+                  <a:srgbClr val="1E1E1E"/>
+                </a:solidFill>
+              </a:rPr>
+              <a:t>横向：使用场景拓宽</a:t>
+            </a:r>
+            <a:endParaRPr lang="en-US" sz="2000" dirty="0"/>
+          </a:p>
+        </p:txBody>
+      </p:sp>
+      <p:sp>
+        <p:nvSpPr>
+          <p:cNvPr id="9" name="Text 7"/>
+          <p:cNvSpPr/>
+          <p:nvPr/>
+        </p:nvSpPr>
+        <p:spPr>
+          <a:xfrm>
+            <a:off x="4572000" y="3291840"/>
+            <a:ext cx="3840480" cy="1828800"/>
+          </a:xfrm>
+          <a:prstGeom prst="rect">
+            <a:avLst/>
+          </a:prstGeom>
+          <a:noFill/>
+          <a:ln/>
+        </p:spPr>
+        <p:txBody>
+          <a:bodyPr wrap="square" rtlCol="0" anchor="t"/>
+          <a:lstStyle/>
+          <a:p>
+            <a:pPr indent="0" marL="0">
+              <a:buNone/>
+            </a:pPr>
+            <a:r>
+              <a:rPr lang="en-US" sz="1600" dirty="0">
+                <a:solidFill>
+                  <a:srgbClr val="666666"/>
+                </a:solidFill>
+              </a:rPr>
+              <a:t>技术调研、写设计文档、整理会议纪要，甚至管理本地知识库。AI 的价值远不止于写代码。这也是 SOLO 提供 Work 模式的原因。</a:t>
+            </a:r>
+            <a:endParaRPr lang="en-US" sz="1600" dirty="0"/>
+          </a:p>
+        </p:txBody>
+      </p:sp>
+      <p:sp>
+        <p:nvSpPr>
+          <p:cNvPr id="10" name="Text 8"/>
+          <p:cNvSpPr/>
+          <p:nvPr/>
+        </p:nvSpPr>
+        <p:spPr>
+          <a:xfrm>
+            <a:off x="457200" y="4663440"/>
+            <a:ext cx="3657600" cy="274320"/>
+          </a:xfrm>
+          <a:prstGeom prst="rect">
+            <a:avLst/>
+          </a:prstGeom>
+          <a:noFill/>
+          <a:ln/>
+        </p:spPr>
+        <p:txBody>
+          <a:bodyPr wrap="square" rtlCol="0" anchor="ctr"/>
+          <a:lstStyle/>
+          <a:p>
+            <a:pPr indent="0" marL="0">
+              <a:buNone/>
+            </a:pPr>
+            <a:r>
+              <a:rPr lang="en-US" sz="1000" dirty="0">
+                <a:solidFill>
+                  <a:srgbClr val="666666"/>
+                </a:solidFill>
+              </a:rPr>
+              <a:t>More Than Coding</a:t>
+            </a:r>
+            <a:endParaRPr lang="en-US" sz="1000" dirty="0"/>
           </a:p>
         </p:txBody>
       </p:sp>
@@ -2144,7 +2416,7 @@
     <p:bg>
       <p:bgPr>
         <a:solidFill>
-          <a:srgbClr val="0A0A0B"/>
+          <a:srgbClr val="1E1E1E"/>
         </a:solidFill>
       </p:bgPr>
     </p:bg>
@@ -2170,26 +2442,104 @@
         </p:nvSpPr>
         <p:spPr>
           <a:xfrm>
-            <a:off x="457200" y="457200"/>
-            <a:ext cx="8229600" cy="457200"/>
-          </a:xfrm>
-          <a:prstGeom prst="rect">
-            <a:avLst/>
-          </a:prstGeom>
-          <a:noFill/>
-          <a:ln/>
-        </p:spPr>
-        <p:txBody>
-          <a:bodyPr wrap="square" rtlCol="0" anchor="ctr"/>
-          <a:lstStyle/>
-          <a:p>
-            <a:pPr indent="0" marL="0">
-              <a:buNone/>
-            </a:pPr>
-            <a:r>
-              <a:rPr lang="en-US" sz="1400" spc="200" kern="0" dirty="0">
-                <a:solidFill>
-                  <a:srgbClr val="CCCCCC"/>
+            <a:off x="457200" y="274320"/>
+            <a:ext cx="3657600" cy="274320"/>
+          </a:xfrm>
+          <a:prstGeom prst="rect">
+            <a:avLst/>
+          </a:prstGeom>
+          <a:noFill/>
+          <a:ln/>
+        </p:spPr>
+        <p:txBody>
+          <a:bodyPr wrap="square" rtlCol="0" anchor="ctr"/>
+          <a:lstStyle/>
+          <a:p>
+            <a:pPr indent="0" marL="0">
+              <a:buNone/>
+            </a:pPr>
+            <a:r>
+              <a:rPr lang="en-US" sz="1000" dirty="0">
+                <a:solidFill>
+                  <a:srgbClr val="A0A0A0"/>
+                </a:solidFill>
+                <a:latin typeface="Courier New" pitchFamily="34" charset="0"/>
+                <a:ea typeface="Courier New" pitchFamily="34" charset="-122"/>
+                <a:cs typeface="Courier New" pitchFamily="34" charset="-120"/>
+              </a:rPr>
+              <a:t>趋势 2 · 协作模式</a:t>
+            </a:r>
+            <a:endParaRPr lang="en-US" sz="1000" dirty="0"/>
+          </a:p>
+        </p:txBody>
+      </p:sp>
+      <p:sp>
+        <p:nvSpPr>
+          <p:cNvPr id="3" name="Text 1"/>
+          <p:cNvSpPr/>
+          <p:nvPr/>
+        </p:nvSpPr>
+        <p:spPr>
+          <a:xfrm>
+            <a:off x="5029200" y="274320"/>
+            <a:ext cx="3657600" cy="274320"/>
+          </a:xfrm>
+          <a:prstGeom prst="rect">
+            <a:avLst/>
+          </a:prstGeom>
+          <a:noFill/>
+          <a:ln/>
+        </p:spPr>
+        <p:txBody>
+          <a:bodyPr wrap="square" rtlCol="0" anchor="ctr"/>
+          <a:lstStyle/>
+          <a:p>
+            <a:pPr algn="r" indent="0" marL="0">
+              <a:buNone/>
+            </a:pPr>
+            <a:r>
+              <a:rPr lang="en-US" sz="1000" dirty="0">
+                <a:solidFill>
+                  <a:srgbClr val="A0A0A0"/>
+                </a:solidFill>
+                <a:latin typeface="Courier New" pitchFamily="34" charset="0"/>
+                <a:ea typeface="Courier New" pitchFamily="34" charset="-122"/>
+                <a:cs typeface="Courier New" pitchFamily="34" charset="-120"/>
+              </a:rPr>
+              <a:t>ACT III · 11 / 12</a:t>
+            </a:r>
+            <a:endParaRPr lang="en-US" sz="1000" dirty="0"/>
+          </a:p>
+        </p:txBody>
+      </p:sp>
+      <p:sp>
+        <p:nvSpPr>
+          <p:cNvPr id="4" name="Text 2"/>
+          <p:cNvSpPr/>
+          <p:nvPr/>
+        </p:nvSpPr>
+        <p:spPr>
+          <a:xfrm>
+            <a:off x="457200" y="914400"/>
+            <a:ext cx="8229600" cy="274320"/>
+          </a:xfrm>
+          <a:prstGeom prst="rect">
+            <a:avLst/>
+          </a:prstGeom>
+          <a:noFill/>
+          <a:ln/>
+        </p:spPr>
+        <p:txBody>
+          <a:bodyPr wrap="square" rtlCol="0" anchor="ctr"/>
+          <a:lstStyle/>
+          <a:p>
+            <a:pPr indent="0" marL="0">
+              <a:buNone/>
+            </a:pPr>
+            <a:r>
+              <a:rPr lang="en-US" sz="1400" b="1" dirty="0">
+                <a:solidFill>
+                  <a:srgbClr val="8AB4F8"/>
                 </a:solidFill>
               </a:rPr>
               <a:t>从执行者到决策者</a:t>
@@ -2200,59 +2550,59 @@
       </p:sp>
       <p:sp>
         <p:nvSpPr>
-          <p:cNvPr id="3" name="Text 1"/>
-          <p:cNvSpPr/>
-          <p:nvPr/>
-        </p:nvSpPr>
-        <p:spPr>
-          <a:xfrm>
-            <a:off x="457200" y="1097280"/>
-            <a:ext cx="8229600" cy="1371600"/>
-          </a:xfrm>
-          <a:prstGeom prst="rect">
-            <a:avLst/>
-          </a:prstGeom>
-          <a:noFill/>
-          <a:ln/>
-        </p:spPr>
-        <p:txBody>
-          <a:bodyPr wrap="square" rtlCol="0" anchor="ctr"/>
-          <a:lstStyle/>
-          <a:p>
-            <a:pPr indent="0" marL="0">
-              <a:buNone/>
-            </a:pPr>
-            <a:r>
-              <a:rPr lang="en-US" sz="4800" b="1" dirty="0">
-                <a:solidFill>
-                  <a:srgbClr val="F1EFEA"/>
+          <p:cNvPr id="5" name="Text 3"/>
+          <p:cNvSpPr/>
+          <p:nvPr/>
+        </p:nvSpPr>
+        <p:spPr>
+          <a:xfrm>
+            <a:off x="457200" y="1280160"/>
+            <a:ext cx="8229600" cy="1097280"/>
+          </a:xfrm>
+          <a:prstGeom prst="rect">
+            <a:avLst/>
+          </a:prstGeom>
+          <a:noFill/>
+          <a:ln/>
+        </p:spPr>
+        <p:txBody>
+          <a:bodyPr wrap="square" rtlCol="0" anchor="t"/>
+          <a:lstStyle/>
+          <a:p>
+            <a:pPr algn="l" indent="0" marL="0">
+              <a:buNone/>
+            </a:pPr>
+            <a:r>
+              <a:rPr lang="en-US" sz="3600" b="1" dirty="0">
+                <a:solidFill>
+                  <a:srgbClr val="F9F9F7"/>
                 </a:solidFill>
               </a:rPr>
               <a:t>角色定位与思维方式的升级</a:t>
             </a:r>
-            <a:endParaRPr lang="en-US" sz="4800" dirty="0"/>
-          </a:p>
-        </p:txBody>
-      </p:sp>
-      <p:sp>
-        <p:nvSpPr>
-          <p:cNvPr id="4" name="Text 2"/>
-          <p:cNvSpPr/>
-          <p:nvPr/>
-        </p:nvSpPr>
-        <p:spPr>
-          <a:xfrm>
-            <a:off x="457200" y="2286000"/>
-            <a:ext cx="7772400" cy="1371600"/>
-          </a:xfrm>
-          <a:prstGeom prst="rect">
-            <a:avLst/>
-          </a:prstGeom>
-          <a:noFill/>
-          <a:ln/>
-        </p:spPr>
-        <p:txBody>
-          <a:bodyPr wrap="square" rtlCol="0" anchor="ctr"/>
+            <a:endParaRPr lang="en-US" sz="3600" dirty="0"/>
+          </a:p>
+        </p:txBody>
+      </p:sp>
+      <p:sp>
+        <p:nvSpPr>
+          <p:cNvPr id="6" name="Text 4"/>
+          <p:cNvSpPr/>
+          <p:nvPr/>
+        </p:nvSpPr>
+        <p:spPr>
+          <a:xfrm>
+            <a:off x="457200" y="2377440"/>
+            <a:ext cx="4114800" cy="2286000"/>
+          </a:xfrm>
+          <a:prstGeom prst="rect">
+            <a:avLst/>
+          </a:prstGeom>
+          <a:noFill/>
+          <a:ln/>
+        </p:spPr>
+        <p:txBody>
+          <a:bodyPr wrap="square" rtlCol="0" anchor="t"/>
           <a:lstStyle/>
           <a:p>
             <a:pPr indent="0" marL="0">
@@ -2261,54 +2611,18 @@
             <a:r>
               <a:rPr lang="en-US" sz="1800" dirty="0">
                 <a:solidFill>
-                  <a:srgbClr val="CCCCCC"/>
+                  <a:srgbClr val="A0A0A0"/>
                 </a:solidFill>
               </a:rPr>
               <a:t>过去你是 In the Loop，每一行代码都经过你的手；现在你要学会 On the Loop，设定约束、委派任务、审查结果。</a:t>
             </a:r>
             <a:endParaRPr lang="en-US" sz="1800" dirty="0"/>
-          </a:p>
-        </p:txBody>
-      </p:sp>
-      <p:sp>
-        <p:nvSpPr>
-          <p:cNvPr id="5" name="Text 3"/>
-          <p:cNvSpPr/>
-          <p:nvPr/>
-        </p:nvSpPr>
-        <p:spPr>
-          <a:xfrm>
-            <a:off x="457200" y="3200400"/>
-            <a:ext cx="7315200" cy="1371600"/>
-          </a:xfrm>
-          <a:prstGeom prst="rect">
-            <a:avLst/>
-          </a:prstGeom>
-          <a:noFill/>
-          <a:ln/>
-        </p:spPr>
-        <p:txBody>
-          <a:bodyPr wrap="square" rtlCol="0" anchor="ctr"/>
-          <a:lstStyle/>
-          <a:p>
-            <a:pPr indent="0" marL="0">
-              <a:buNone/>
-            </a:pPr>
-            <a:r>
-              <a:rPr lang="en-US" sz="2800" i="1" dirty="0">
-                <a:solidFill>
-                  <a:srgbClr val="F1EFEA"/>
-                </a:solidFill>
-              </a:rPr>
-              <a:t>"从命令式到声明式。你不再告诉 AI“怎么做”，而是声明“什么该是对的”，Agent 会持续保证它。"</a:t>
-            </a:r>
-            <a:endParaRPr lang="en-US" sz="2800" dirty="0"/>
           </a:p>
         </p:txBody>
       </p:sp>
       <p:pic>
         <p:nvPicPr>
-          <p:cNvPr id="6" name="Image 0" descr="/workspace/SOLO-0408-直播/ppt/images/04-slide-image.png">    </p:cNvPr>
+          <p:cNvPr id="7" name="Image 0" descr="/workspace/SOLO-0408-直播/ppt/images/04-slide-image.png">    </p:cNvPr>
           <p:cNvPicPr>
             <a:picLocks noChangeAspect="1"/>
           </p:cNvPicPr>
@@ -2322,14 +2636,50 @@
         </p:blipFill>
         <p:spPr>
           <a:xfrm>
-            <a:off x="5029200" y="1371600"/>
-            <a:ext cx="3840480" cy="2157984"/>
+            <a:off x="4754880" y="1097280"/>
+            <a:ext cx="3931920" cy="2194560"/>
           </a:xfrm>
           <a:prstGeom prst="rect">
             <a:avLst/>
           </a:prstGeom>
         </p:spPr>
       </p:pic>
+      <p:sp>
+        <p:nvSpPr>
+          <p:cNvPr id="8" name="Text 5"/>
+          <p:cNvSpPr/>
+          <p:nvPr/>
+        </p:nvSpPr>
+        <p:spPr>
+          <a:xfrm>
+            <a:off x="457200" y="4663440"/>
+            <a:ext cx="3657600" cy="274320"/>
+          </a:xfrm>
+          <a:prstGeom prst="rect">
+            <a:avLst/>
+          </a:prstGeom>
+          <a:noFill/>
+          <a:ln/>
+        </p:spPr>
+        <p:txBody>
+          <a:bodyPr wrap="square" rtlCol="0" anchor="ctr"/>
+          <a:lstStyle/>
+          <a:p>
+            <a:pPr indent="0" marL="0">
+              <a:buNone/>
+            </a:pPr>
+            <a:r>
+              <a:rPr lang="en-US" sz="1000" dirty="0">
+                <a:solidFill>
+                  <a:srgbClr val="A0A0A0"/>
+                </a:solidFill>
+              </a:rPr>
+              <a:t>协作模式的变化</a:t>
+            </a:r>
+            <a:endParaRPr lang="en-US" sz="1000" dirty="0"/>
+          </a:p>
+        </p:txBody>
+      </p:sp>
     </p:spTree>
   </p:cSld>
   <p:clrMapOvr>
@@ -2344,7 +2694,7 @@
     <p:bg>
       <p:bgPr>
         <a:solidFill>
-          <a:srgbClr val="F1EFEA"/>
+          <a:srgbClr val="F9F9F7"/>
         </a:solidFill>
       </p:bgPr>
     </p:bg>
@@ -2370,31 +2720,34 @@
         </p:nvSpPr>
         <p:spPr>
           <a:xfrm>
-            <a:off x="457200" y="457200"/>
-            <a:ext cx="8229600" cy="457200"/>
-          </a:xfrm>
-          <a:prstGeom prst="rect">
-            <a:avLst/>
-          </a:prstGeom>
-          <a:noFill/>
-          <a:ln/>
-        </p:spPr>
-        <p:txBody>
-          <a:bodyPr wrap="square" rtlCol="0" anchor="ctr"/>
-          <a:lstStyle/>
-          <a:p>
-            <a:pPr indent="0" marL="0">
-              <a:buNone/>
-            </a:pPr>
-            <a:r>
-              <a:rPr lang="en-US" sz="1400" spc="200" kern="0" dirty="0">
-                <a:solidFill>
-                  <a:srgbClr val="555555"/>
-                </a:solidFill>
-              </a:rPr>
-              <a:t>未来已来</a:t>
-            </a:r>
-            <a:endParaRPr lang="en-US" sz="1400" dirty="0"/>
+            <a:off x="457200" y="274320"/>
+            <a:ext cx="3657600" cy="274320"/>
+          </a:xfrm>
+          <a:prstGeom prst="rect">
+            <a:avLst/>
+          </a:prstGeom>
+          <a:noFill/>
+          <a:ln/>
+        </p:spPr>
+        <p:txBody>
+          <a:bodyPr wrap="square" rtlCol="0" anchor="ctr"/>
+          <a:lstStyle/>
+          <a:p>
+            <a:pPr indent="0" marL="0">
+              <a:buNone/>
+            </a:pPr>
+            <a:r>
+              <a:rPr lang="en-US" sz="1000" dirty="0">
+                <a:solidFill>
+                  <a:srgbClr val="666666"/>
+                </a:solidFill>
+                <a:latin typeface="Courier New" pitchFamily="34" charset="0"/>
+                <a:ea typeface="Courier New" pitchFamily="34" charset="-122"/>
+                <a:cs typeface="Courier New" pitchFamily="34" charset="-120"/>
+              </a:rPr>
+              <a:t>终极形态</a:t>
+            </a:r>
+            <a:endParaRPr lang="en-US" sz="1000" dirty="0"/>
           </a:p>
         </p:txBody>
       </p:sp>
@@ -2406,67 +2759,106 @@
         </p:nvSpPr>
         <p:spPr>
           <a:xfrm>
-            <a:off x="457200" y="1097280"/>
-            <a:ext cx="8229600" cy="1371600"/>
-          </a:xfrm>
-          <a:prstGeom prst="rect">
-            <a:avLst/>
-          </a:prstGeom>
-          <a:noFill/>
-          <a:ln/>
-        </p:spPr>
-        <p:txBody>
-          <a:bodyPr wrap="square" rtlCol="0" anchor="ctr"/>
-          <a:lstStyle/>
-          <a:p>
-            <a:pPr indent="0" marL="0">
-              <a:buNone/>
-            </a:pPr>
-            <a:r>
-              <a:rPr lang="en-US" sz="4800" b="1" dirty="0">
-                <a:solidFill>
-                  <a:srgbClr val="0A0A0B"/>
+            <a:off x="5029200" y="274320"/>
+            <a:ext cx="3657600" cy="274320"/>
+          </a:xfrm>
+          <a:prstGeom prst="rect">
+            <a:avLst/>
+          </a:prstGeom>
+          <a:noFill/>
+          <a:ln/>
+        </p:spPr>
+        <p:txBody>
+          <a:bodyPr wrap="square" rtlCol="0" anchor="ctr"/>
+          <a:lstStyle/>
+          <a:p>
+            <a:pPr algn="r" indent="0" marL="0">
+              <a:buNone/>
+            </a:pPr>
+            <a:r>
+              <a:rPr lang="en-US" sz="1000" dirty="0">
+                <a:solidFill>
+                  <a:srgbClr val="666666"/>
+                </a:solidFill>
+                <a:latin typeface="Courier New" pitchFamily="34" charset="0"/>
+                <a:ea typeface="Courier New" pitchFamily="34" charset="-122"/>
+                <a:cs typeface="Courier New" pitchFamily="34" charset="-120"/>
+              </a:rPr>
+              <a:t>END · 12 / 12</a:t>
+            </a:r>
+            <a:endParaRPr lang="en-US" sz="1000" dirty="0"/>
+          </a:p>
+        </p:txBody>
+      </p:sp>
+      <p:sp>
+        <p:nvSpPr>
+          <p:cNvPr id="4" name="Text 2"/>
+          <p:cNvSpPr/>
+          <p:nvPr/>
+        </p:nvSpPr>
+        <p:spPr>
+          <a:xfrm>
+            <a:off x="457200" y="1828800"/>
+            <a:ext cx="8229600" cy="1097280"/>
+          </a:xfrm>
+          <a:prstGeom prst="rect">
+            <a:avLst/>
+          </a:prstGeom>
+          <a:noFill/>
+          <a:ln/>
+        </p:spPr>
+        <p:txBody>
+          <a:bodyPr wrap="square" rtlCol="0" anchor="t"/>
+          <a:lstStyle/>
+          <a:p>
+            <a:pPr algn="ctr" indent="0" marL="0">
+              <a:buNone/>
+            </a:pPr>
+            <a:r>
+              <a:rPr lang="en-US" sz="5400" b="1" dirty="0">
+                <a:solidFill>
+                  <a:srgbClr val="1E1E1E"/>
                 </a:solidFill>
               </a:rPr>
               <a:t>自驾式的代码库</a:t>
             </a:r>
-            <a:endParaRPr lang="en-US" sz="4800" dirty="0"/>
-          </a:p>
-        </p:txBody>
-      </p:sp>
-      <p:sp>
-        <p:nvSpPr>
-          <p:cNvPr id="4" name="Text 2"/>
-          <p:cNvSpPr/>
-          <p:nvPr/>
-        </p:nvSpPr>
-        <p:spPr>
-          <a:xfrm>
-            <a:off x="457200" y="2286000"/>
-            <a:ext cx="7772400" cy="1371600"/>
-          </a:xfrm>
-          <a:prstGeom prst="rect">
-            <a:avLst/>
-          </a:prstGeom>
-          <a:noFill/>
-          <a:ln/>
-        </p:spPr>
-        <p:txBody>
-          <a:bodyPr wrap="square" rtlCol="0" anchor="ctr"/>
-          <a:lstStyle/>
-          <a:p>
-            <a:pPr indent="0" marL="0">
-              <a:buNone/>
-            </a:pPr>
-            <a:r>
-              <a:rPr lang="en-US" sz="1800" dirty="0">
-                <a:solidFill>
-                  <a:srgbClr val="555555"/>
+            <a:endParaRPr lang="en-US" sz="5400" dirty="0"/>
+          </a:p>
+        </p:txBody>
+      </p:sp>
+      <p:sp>
+        <p:nvSpPr>
+          <p:cNvPr id="5" name="Text 3"/>
+          <p:cNvSpPr/>
+          <p:nvPr/>
+        </p:nvSpPr>
+        <p:spPr>
+          <a:xfrm>
+            <a:off x="1371600" y="3657600"/>
+            <a:ext cx="6400800" cy="914400"/>
+          </a:xfrm>
+          <a:prstGeom prst="rect">
+            <a:avLst/>
+          </a:prstGeom>
+          <a:noFill/>
+          <a:ln/>
+        </p:spPr>
+        <p:txBody>
+          <a:bodyPr wrap="square" rtlCol="0" anchor="t"/>
+          <a:lstStyle/>
+          <a:p>
+            <a:pPr algn="ctr" indent="0" marL="0">
+              <a:buNone/>
+            </a:pPr>
+            <a:r>
+              <a:rPr lang="en-US" sz="2000" dirty="0">
+                <a:solidFill>
+                  <a:srgbClr val="666666"/>
                 </a:solidFill>
               </a:rPr>
               <a:t>不是取代工程师，而是让每个工程师都能站在更高的抽象层次上思考和创造。</a:t>
             </a:r>
-            <a:endParaRPr lang="en-US" sz="1800" dirty="0"/>
+            <a:endParaRPr lang="en-US" sz="2000" dirty="0"/>
           </a:p>
         </p:txBody>
       </p:sp>
@@ -2484,7 +2876,7 @@
     <p:bg>
       <p:bgPr>
         <a:solidFill>
-          <a:srgbClr val="F1EFEA"/>
+          <a:srgbClr val="F9F9F7"/>
         </a:solidFill>
       </p:bgPr>
     </p:bg>
@@ -2510,26 +2902,104 @@
         </p:nvSpPr>
         <p:spPr>
           <a:xfrm>
-            <a:off x="457200" y="457200"/>
-            <a:ext cx="8229600" cy="457200"/>
-          </a:xfrm>
-          <a:prstGeom prst="rect">
-            <a:avLst/>
-          </a:prstGeom>
-          <a:noFill/>
-          <a:ln/>
-        </p:spPr>
-        <p:txBody>
-          <a:bodyPr wrap="square" rtlCol="0" anchor="ctr"/>
-          <a:lstStyle/>
-          <a:p>
-            <a:pPr indent="0" marL="0">
-              <a:buNone/>
-            </a:pPr>
-            <a:r>
-              <a:rPr lang="en-US" sz="1400" spc="200" kern="0" dirty="0">
-                <a:solidFill>
-                  <a:srgbClr val="555555"/>
+            <a:off x="457200" y="274320"/>
+            <a:ext cx="3657600" cy="274320"/>
+          </a:xfrm>
+          <a:prstGeom prst="rect">
+            <a:avLst/>
+          </a:prstGeom>
+          <a:noFill/>
+          <a:ln/>
+        </p:spPr>
+        <p:txBody>
+          <a:bodyPr wrap="square" rtlCol="0" anchor="ctr"/>
+          <a:lstStyle/>
+          <a:p>
+            <a:pPr indent="0" marL="0">
+              <a:buNone/>
+            </a:pPr>
+            <a:r>
+              <a:rPr lang="en-US" sz="1000" dirty="0">
+                <a:solidFill>
+                  <a:srgbClr val="666666"/>
+                </a:solidFill>
+                <a:latin typeface="Courier New" pitchFamily="34" charset="0"/>
+                <a:ea typeface="Courier New" pitchFamily="34" charset="-122"/>
+                <a:cs typeface="Courier New" pitchFamily="34" charset="-120"/>
+              </a:rPr>
+              <a:t>开场 · 闭关历程</a:t>
+            </a:r>
+            <a:endParaRPr lang="en-US" sz="1000" dirty="0"/>
+          </a:p>
+        </p:txBody>
+      </p:sp>
+      <p:sp>
+        <p:nvSpPr>
+          <p:cNvPr id="3" name="Text 1"/>
+          <p:cNvSpPr/>
+          <p:nvPr/>
+        </p:nvSpPr>
+        <p:spPr>
+          <a:xfrm>
+            <a:off x="5029200" y="274320"/>
+            <a:ext cx="3657600" cy="274320"/>
+          </a:xfrm>
+          <a:prstGeom prst="rect">
+            <a:avLst/>
+          </a:prstGeom>
+          <a:noFill/>
+          <a:ln/>
+        </p:spPr>
+        <p:txBody>
+          <a:bodyPr wrap="square" rtlCol="0" anchor="ctr"/>
+          <a:lstStyle/>
+          <a:p>
+            <a:pPr algn="r" indent="0" marL="0">
+              <a:buNone/>
+            </a:pPr>
+            <a:r>
+              <a:rPr lang="en-US" sz="1000" dirty="0">
+                <a:solidFill>
+                  <a:srgbClr val="666666"/>
+                </a:solidFill>
+                <a:latin typeface="Courier New" pitchFamily="34" charset="0"/>
+                <a:ea typeface="Courier New" pitchFamily="34" charset="-122"/>
+                <a:cs typeface="Courier New" pitchFamily="34" charset="-120"/>
+              </a:rPr>
+              <a:t>ACT I · 02 / 12</a:t>
+            </a:r>
+            <a:endParaRPr lang="en-US" sz="1000" dirty="0"/>
+          </a:p>
+        </p:txBody>
+      </p:sp>
+      <p:sp>
+        <p:nvSpPr>
+          <p:cNvPr id="4" name="Text 2"/>
+          <p:cNvSpPr/>
+          <p:nvPr/>
+        </p:nvSpPr>
+        <p:spPr>
+          <a:xfrm>
+            <a:off x="457200" y="914400"/>
+            <a:ext cx="8229600" cy="274320"/>
+          </a:xfrm>
+          <a:prstGeom prst="rect">
+            <a:avLst/>
+          </a:prstGeom>
+          <a:noFill/>
+          <a:ln/>
+        </p:spPr>
+        <p:txBody>
+          <a:bodyPr wrap="square" rtlCol="0" anchor="ctr"/>
+          <a:lstStyle/>
+          <a:p>
+            <a:pPr indent="0" marL="0">
+              <a:buNone/>
+            </a:pPr>
+            <a:r>
+              <a:rPr lang="en-US" sz="1400" b="1" dirty="0">
+                <a:solidFill>
+                  <a:srgbClr val="0F52BA"/>
                 </a:solidFill>
               </a:rPr>
               <a:t>11月15日的“受难者”</a:t>
@@ -2540,194 +3010,446 @@
       </p:sp>
       <p:sp>
         <p:nvSpPr>
-          <p:cNvPr id="3" name="Text 1"/>
-          <p:cNvSpPr/>
-          <p:nvPr/>
-        </p:nvSpPr>
-        <p:spPr>
-          <a:xfrm>
-            <a:off x="457200" y="1097280"/>
-            <a:ext cx="8229600" cy="1371600"/>
-          </a:xfrm>
-          <a:prstGeom prst="rect">
-            <a:avLst/>
-          </a:prstGeom>
-          <a:noFill/>
-          <a:ln/>
-        </p:spPr>
-        <p:txBody>
-          <a:bodyPr wrap="square" rtlCol="0" anchor="ctr"/>
-          <a:lstStyle/>
-          <a:p>
-            <a:pPr indent="0" marL="0">
-              <a:buNone/>
-            </a:pPr>
-            <a:r>
-              <a:rPr lang="en-US" sz="4800" b="1" dirty="0">
-                <a:solidFill>
-                  <a:srgbClr val="0A0A0B"/>
+          <p:cNvPr id="5" name="Text 3"/>
+          <p:cNvSpPr/>
+          <p:nvPr/>
+        </p:nvSpPr>
+        <p:spPr>
+          <a:xfrm>
+            <a:off x="457200" y="1280160"/>
+            <a:ext cx="8229600" cy="1097280"/>
+          </a:xfrm>
+          <a:prstGeom prst="rect">
+            <a:avLst/>
+          </a:prstGeom>
+          <a:noFill/>
+          <a:ln/>
+        </p:spPr>
+        <p:txBody>
+          <a:bodyPr wrap="square" rtlCol="0" anchor="t"/>
+          <a:lstStyle/>
+          <a:p>
+            <a:pPr algn="l" indent="0" marL="0">
+              <a:buNone/>
+            </a:pPr>
+            <a:r>
+              <a:rPr lang="en-US" sz="3600" b="1" dirty="0">
+                <a:solidFill>
+                  <a:srgbClr val="1E1E1E"/>
                 </a:solidFill>
               </a:rPr>
               <a:t>每年 11 月 15 日的闭关传统，带来了认知与工具的持续进化。</a:t>
             </a:r>
-            <a:endParaRPr lang="en-US" sz="4800" dirty="0"/>
-          </a:p>
-        </p:txBody>
-      </p:sp>
-      <p:sp>
-        <p:nvSpPr>
-          <p:cNvPr id="4" name="Text 2"/>
-          <p:cNvSpPr/>
-          <p:nvPr/>
-        </p:nvSpPr>
-        <p:spPr>
-          <a:xfrm>
-            <a:off x="457200" y="2926080"/>
-            <a:ext cx="2011680" cy="731520"/>
-          </a:xfrm>
-          <a:prstGeom prst="rect">
-            <a:avLst/>
-          </a:prstGeom>
-          <a:noFill/>
-          <a:ln/>
-        </p:spPr>
-        <p:txBody>
-          <a:bodyPr wrap="square" rtlCol="0" anchor="ctr"/>
-          <a:lstStyle/>
-          <a:p>
-            <a:pPr indent="0" marL="0">
-              <a:buNone/>
-            </a:pPr>
-            <a:r>
-              <a:rPr lang="en-US" sz="3200" b="1" dirty="0">
-                <a:solidFill>
-                  <a:srgbClr val="0A0A0B"/>
+            <a:endParaRPr lang="en-US" sz="3600" dirty="0"/>
+          </a:p>
+        </p:txBody>
+      </p:sp>
+      <p:sp>
+        <p:nvSpPr>
+          <p:cNvPr id="6" name="Text 4"/>
+          <p:cNvSpPr/>
+          <p:nvPr/>
+        </p:nvSpPr>
+        <p:spPr>
+          <a:xfrm>
+            <a:off x="457200" y="2560320"/>
+            <a:ext cx="1874520" cy="274320"/>
+          </a:xfrm>
+          <a:prstGeom prst="rect">
+            <a:avLst/>
+          </a:prstGeom>
+          <a:noFill/>
+          <a:ln/>
+        </p:spPr>
+        <p:txBody>
+          <a:bodyPr wrap="square" rtlCol="0" anchor="ctr"/>
+          <a:lstStyle/>
+          <a:p>
+            <a:pPr indent="0" marL="0">
+              <a:buNone/>
+            </a:pPr>
+            <a:r>
+              <a:rPr lang="en-US" sz="1200" b="1" dirty="0">
+                <a:solidFill>
+                  <a:srgbClr val="666666"/>
+                </a:solidFill>
+              </a:rPr>
+              <a:t>加入字节</a:t>
+            </a:r>
+            <a:endParaRPr lang="en-US" sz="1200" dirty="0"/>
+          </a:p>
+        </p:txBody>
+      </p:sp>
+      <p:sp>
+        <p:nvSpPr>
+          <p:cNvPr id="7" name="Text 5"/>
+          <p:cNvSpPr/>
+          <p:nvPr/>
+        </p:nvSpPr>
+        <p:spPr>
+          <a:xfrm>
+            <a:off x="457200" y="2834640"/>
+            <a:ext cx="1874520" cy="731520"/>
+          </a:xfrm>
+          <a:prstGeom prst="rect">
+            <a:avLst/>
+          </a:prstGeom>
+          <a:noFill/>
+          <a:ln/>
+        </p:spPr>
+        <p:txBody>
+          <a:bodyPr wrap="square" rtlCol="0" anchor="ctr"/>
+          <a:lstStyle/>
+          <a:p>
+            <a:pPr indent="0" marL="0">
+              <a:buNone/>
+            </a:pPr>
+            <a:r>
+              <a:rPr lang="en-US" sz="2800" b="1" dirty="0">
+                <a:solidFill>
+                  <a:srgbClr val="1E1E1E"/>
                 </a:solidFill>
               </a:rPr>
               <a:t>2022.11.15</a:t>
             </a:r>
-            <a:endParaRPr lang="en-US" sz="3200" dirty="0"/>
-          </a:p>
-        </p:txBody>
-      </p:sp>
-      <p:sp>
-        <p:nvSpPr>
-          <p:cNvPr id="5" name="Text 3"/>
-          <p:cNvSpPr/>
-          <p:nvPr/>
-        </p:nvSpPr>
-        <p:spPr>
-          <a:xfrm>
-            <a:off x="457200" y="3749040"/>
-            <a:ext cx="2011680" cy="365760"/>
-          </a:xfrm>
-          <a:prstGeom prst="rect">
-            <a:avLst/>
-          </a:prstGeom>
-          <a:noFill/>
-          <a:ln/>
-        </p:spPr>
-        <p:txBody>
-          <a:bodyPr wrap="square" rtlCol="0" anchor="ctr"/>
-          <a:lstStyle/>
-          <a:p>
-            <a:pPr indent="0" marL="0">
-              <a:buNone/>
-            </a:pPr>
-            <a:r>
-              <a:rPr lang="en-US" sz="1400" dirty="0">
-                <a:solidFill>
-                  <a:srgbClr val="555555"/>
-                </a:solidFill>
-              </a:rPr>
-              <a:t>加入字节</a:t>
-            </a:r>
-            <a:endParaRPr lang="en-US" sz="1400" dirty="0"/>
-          </a:p>
-        </p:txBody>
-      </p:sp>
-      <p:sp>
-        <p:nvSpPr>
-          <p:cNvPr id="6" name="Text 4"/>
-          <p:cNvSpPr/>
-          <p:nvPr/>
-        </p:nvSpPr>
-        <p:spPr>
-          <a:xfrm>
-            <a:off x="2651760" y="2926080"/>
-            <a:ext cx="2011680" cy="731520"/>
-          </a:xfrm>
-          <a:prstGeom prst="rect">
-            <a:avLst/>
-          </a:prstGeom>
-          <a:noFill/>
-          <a:ln/>
-        </p:spPr>
-        <p:txBody>
-          <a:bodyPr wrap="square" rtlCol="0" anchor="ctr"/>
-          <a:lstStyle/>
-          <a:p>
-            <a:pPr indent="0" marL="0">
-              <a:buNone/>
-            </a:pPr>
-            <a:r>
-              <a:rPr lang="en-US" sz="3200" b="1" dirty="0">
-                <a:solidFill>
-                  <a:srgbClr val="0A0A0B"/>
+            <a:endParaRPr lang="en-US" sz="2800" dirty="0"/>
+          </a:p>
+        </p:txBody>
+      </p:sp>
+      <p:sp>
+        <p:nvSpPr>
+          <p:cNvPr id="8" name="Text 6"/>
+          <p:cNvSpPr/>
+          <p:nvPr/>
+        </p:nvSpPr>
+        <p:spPr>
+          <a:xfrm>
+            <a:off x="2514600" y="2560320"/>
+            <a:ext cx="1874520" cy="274320"/>
+          </a:xfrm>
+          <a:prstGeom prst="rect">
+            <a:avLst/>
+          </a:prstGeom>
+          <a:noFill/>
+          <a:ln/>
+        </p:spPr>
+        <p:txBody>
+          <a:bodyPr wrap="square" rtlCol="0" anchor="ctr"/>
+          <a:lstStyle/>
+          <a:p>
+            <a:pPr indent="0" marL="0">
+              <a:buNone/>
+            </a:pPr>
+            <a:r>
+              <a:rPr lang="en-US" sz="1200" b="1" dirty="0">
+                <a:solidFill>
+                  <a:srgbClr val="666666"/>
+                </a:solidFill>
+              </a:rPr>
+              <a:t>闭关产出</a:t>
+            </a:r>
+            <a:endParaRPr lang="en-US" sz="1200" dirty="0"/>
+          </a:p>
+        </p:txBody>
+      </p:sp>
+      <p:sp>
+        <p:nvSpPr>
+          <p:cNvPr id="9" name="Text 7"/>
+          <p:cNvSpPr/>
+          <p:nvPr/>
+        </p:nvSpPr>
+        <p:spPr>
+          <a:xfrm>
+            <a:off x="2514600" y="2834640"/>
+            <a:ext cx="1874520" cy="731520"/>
+          </a:xfrm>
+          <a:prstGeom prst="rect">
+            <a:avLst/>
+          </a:prstGeom>
+          <a:noFill/>
+          <a:ln/>
+        </p:spPr>
+        <p:txBody>
+          <a:bodyPr wrap="square" rtlCol="0" anchor="ctr"/>
+          <a:lstStyle/>
+          <a:p>
+            <a:pPr indent="0" marL="0">
+              <a:buNone/>
+            </a:pPr>
+            <a:r>
+              <a:rPr lang="en-US" sz="2800" b="1" dirty="0">
+                <a:solidFill>
+                  <a:srgbClr val="1E1E1E"/>
                 </a:solidFill>
               </a:rPr>
               <a:t>MarsCode Cloud IDE</a:t>
             </a:r>
-            <a:endParaRPr lang="en-US" sz="3200" dirty="0"/>
-          </a:p>
-        </p:txBody>
-      </p:sp>
-      <p:sp>
-        <p:nvSpPr>
-          <p:cNvPr id="7" name="Text 5"/>
-          <p:cNvSpPr/>
-          <p:nvPr/>
-        </p:nvSpPr>
-        <p:spPr>
-          <a:xfrm>
-            <a:off x="2651760" y="3749040"/>
-            <a:ext cx="2011680" cy="365760"/>
-          </a:xfrm>
-          <a:prstGeom prst="rect">
-            <a:avLst/>
-          </a:prstGeom>
-          <a:noFill/>
-          <a:ln/>
-        </p:spPr>
-        <p:txBody>
-          <a:bodyPr wrap="square" rtlCol="0" anchor="ctr"/>
-          <a:lstStyle/>
-          <a:p>
-            <a:pPr indent="0" marL="0">
-              <a:buNone/>
-            </a:pPr>
-            <a:r>
-              <a:rPr lang="en-US" sz="1400" dirty="0">
-                <a:solidFill>
-                  <a:srgbClr val="555555"/>
+            <a:endParaRPr lang="en-US" sz="2800" dirty="0"/>
+          </a:p>
+        </p:txBody>
+      </p:sp>
+      <p:sp>
+        <p:nvSpPr>
+          <p:cNvPr id="10" name="Text 8"/>
+          <p:cNvSpPr/>
+          <p:nvPr/>
+        </p:nvSpPr>
+        <p:spPr>
+          <a:xfrm>
+            <a:off x="2514600" y="3566160"/>
+            <a:ext cx="1874520" cy="274320"/>
+          </a:xfrm>
+          <a:prstGeom prst="rect">
+            <a:avLst/>
+          </a:prstGeom>
+          <a:noFill/>
+          <a:ln/>
+        </p:spPr>
+        <p:txBody>
+          <a:bodyPr wrap="square" rtlCol="0" anchor="ctr"/>
+          <a:lstStyle/>
+          <a:p>
+            <a:pPr indent="0" marL="0">
+              <a:buNone/>
+            </a:pPr>
+            <a:r>
+              <a:rPr lang="en-US" sz="1200" dirty="0">
+                <a:solidFill>
+                  <a:srgbClr val="666666"/>
+                </a:solidFill>
+              </a:rPr>
+              <a:t>2023.11.15</a:t>
+            </a:r>
+            <a:endParaRPr lang="en-US" sz="1200" dirty="0"/>
+          </a:p>
+        </p:txBody>
+      </p:sp>
+      <p:sp>
+        <p:nvSpPr>
+          <p:cNvPr id="11" name="Text 9"/>
+          <p:cNvSpPr/>
+          <p:nvPr/>
+        </p:nvSpPr>
+        <p:spPr>
+          <a:xfrm>
+            <a:off x="4572000" y="2560320"/>
+            <a:ext cx="1874520" cy="274320"/>
+          </a:xfrm>
+          <a:prstGeom prst="rect">
+            <a:avLst/>
+          </a:prstGeom>
+          <a:noFill/>
+          <a:ln/>
+        </p:spPr>
+        <p:txBody>
+          <a:bodyPr wrap="square" rtlCol="0" anchor="ctr"/>
+          <a:lstStyle/>
+          <a:p>
+            <a:pPr indent="0" marL="0">
+              <a:buNone/>
+            </a:pPr>
+            <a:r>
+              <a:rPr lang="en-US" sz="1200" b="1" dirty="0">
+                <a:solidFill>
+                  <a:srgbClr val="666666"/>
                 </a:solidFill>
               </a:rPr>
               <a:t>闭关产出</a:t>
             </a:r>
-            <a:endParaRPr lang="en-US" sz="1400" dirty="0"/>
-          </a:p>
-        </p:txBody>
-      </p:sp>
-      <p:sp>
-        <p:nvSpPr>
-          <p:cNvPr id="8" name="Text 6"/>
-          <p:cNvSpPr/>
-          <p:nvPr/>
-        </p:nvSpPr>
-        <p:spPr>
-          <a:xfrm>
-            <a:off x="2651760" y="4114800"/>
-            <a:ext cx="2011680" cy="365760"/>
+            <a:endParaRPr lang="en-US" sz="1200" dirty="0"/>
+          </a:p>
+        </p:txBody>
+      </p:sp>
+      <p:sp>
+        <p:nvSpPr>
+          <p:cNvPr id="12" name="Text 10"/>
+          <p:cNvSpPr/>
+          <p:nvPr/>
+        </p:nvSpPr>
+        <p:spPr>
+          <a:xfrm>
+            <a:off x="4572000" y="2834640"/>
+            <a:ext cx="1874520" cy="731520"/>
+          </a:xfrm>
+          <a:prstGeom prst="rect">
+            <a:avLst/>
+          </a:prstGeom>
+          <a:noFill/>
+          <a:ln/>
+        </p:spPr>
+        <p:txBody>
+          <a:bodyPr wrap="square" rtlCol="0" anchor="ctr"/>
+          <a:lstStyle/>
+          <a:p>
+            <a:pPr indent="0" marL="0">
+              <a:buNone/>
+            </a:pPr>
+            <a:r>
+              <a:rPr lang="en-US" sz="2800" b="1" dirty="0">
+                <a:solidFill>
+                  <a:srgbClr val="1E1E1E"/>
+                </a:solidFill>
+              </a:rPr>
+              <a:t>TRAE IDE</a:t>
+            </a:r>
+            <a:endParaRPr lang="en-US" sz="2800" dirty="0"/>
+          </a:p>
+        </p:txBody>
+      </p:sp>
+      <p:sp>
+        <p:nvSpPr>
+          <p:cNvPr id="13" name="Text 11"/>
+          <p:cNvSpPr/>
+          <p:nvPr/>
+        </p:nvSpPr>
+        <p:spPr>
+          <a:xfrm>
+            <a:off x="4572000" y="3566160"/>
+            <a:ext cx="1874520" cy="274320"/>
+          </a:xfrm>
+          <a:prstGeom prst="rect">
+            <a:avLst/>
+          </a:prstGeom>
+          <a:noFill/>
+          <a:ln/>
+        </p:spPr>
+        <p:txBody>
+          <a:bodyPr wrap="square" rtlCol="0" anchor="ctr"/>
+          <a:lstStyle/>
+          <a:p>
+            <a:pPr indent="0" marL="0">
+              <a:buNone/>
+            </a:pPr>
+            <a:r>
+              <a:rPr lang="en-US" sz="1200" dirty="0">
+                <a:solidFill>
+                  <a:srgbClr val="666666"/>
+                </a:solidFill>
+              </a:rPr>
+              <a:t>2024.11.15</a:t>
+            </a:r>
+            <a:endParaRPr lang="en-US" sz="1200" dirty="0"/>
+          </a:p>
+        </p:txBody>
+      </p:sp>
+      <p:sp>
+        <p:nvSpPr>
+          <p:cNvPr id="14" name="Text 12"/>
+          <p:cNvSpPr/>
+          <p:nvPr/>
+        </p:nvSpPr>
+        <p:spPr>
+          <a:xfrm>
+            <a:off x="6629400" y="2560320"/>
+            <a:ext cx="1874520" cy="274320"/>
+          </a:xfrm>
+          <a:prstGeom prst="rect">
+            <a:avLst/>
+          </a:prstGeom>
+          <a:noFill/>
+          <a:ln/>
+        </p:spPr>
+        <p:txBody>
+          <a:bodyPr wrap="square" rtlCol="0" anchor="ctr"/>
+          <a:lstStyle/>
+          <a:p>
+            <a:pPr indent="0" marL="0">
+              <a:buNone/>
+            </a:pPr>
+            <a:r>
+              <a:rPr lang="en-US" sz="1200" b="1" dirty="0">
+                <a:solidFill>
+                  <a:srgbClr val="666666"/>
+                </a:solidFill>
+              </a:rPr>
+              <a:t>全新产出</a:t>
+            </a:r>
+            <a:endParaRPr lang="en-US" sz="1200" dirty="0"/>
+          </a:p>
+        </p:txBody>
+      </p:sp>
+      <p:sp>
+        <p:nvSpPr>
+          <p:cNvPr id="15" name="Text 13"/>
+          <p:cNvSpPr/>
+          <p:nvPr/>
+        </p:nvSpPr>
+        <p:spPr>
+          <a:xfrm>
+            <a:off x="6629400" y="2834640"/>
+            <a:ext cx="1874520" cy="731520"/>
+          </a:xfrm>
+          <a:prstGeom prst="rect">
+            <a:avLst/>
+          </a:prstGeom>
+          <a:noFill/>
+          <a:ln/>
+        </p:spPr>
+        <p:txBody>
+          <a:bodyPr wrap="square" rtlCol="0" anchor="ctr"/>
+          <a:lstStyle/>
+          <a:p>
+            <a:pPr indent="0" marL="0">
+              <a:buNone/>
+            </a:pPr>
+            <a:r>
+              <a:rPr lang="en-US" sz="2800" b="1" dirty="0">
+                <a:solidFill>
+                  <a:srgbClr val="1E1E1E"/>
+                </a:solidFill>
+              </a:rPr>
+              <a:t>SOLO 独立版</a:t>
+            </a:r>
+            <a:endParaRPr lang="en-US" sz="2800" dirty="0"/>
+          </a:p>
+        </p:txBody>
+      </p:sp>
+      <p:sp>
+        <p:nvSpPr>
+          <p:cNvPr id="16" name="Text 14"/>
+          <p:cNvSpPr/>
+          <p:nvPr/>
+        </p:nvSpPr>
+        <p:spPr>
+          <a:xfrm>
+            <a:off x="6629400" y="3566160"/>
+            <a:ext cx="1874520" cy="274320"/>
+          </a:xfrm>
+          <a:prstGeom prst="rect">
+            <a:avLst/>
+          </a:prstGeom>
+          <a:noFill/>
+          <a:ln/>
+        </p:spPr>
+        <p:txBody>
+          <a:bodyPr wrap="square" rtlCol="0" anchor="ctr"/>
+          <a:lstStyle/>
+          <a:p>
+            <a:pPr indent="0" marL="0">
+              <a:buNone/>
+            </a:pPr>
+            <a:r>
+              <a:rPr lang="en-US" sz="1200" dirty="0">
+                <a:solidFill>
+                  <a:srgbClr val="666666"/>
+                </a:solidFill>
+              </a:rPr>
+              <a:t>2026年初 闭关</a:t>
+            </a:r>
+            <a:endParaRPr lang="en-US" sz="1200" dirty="0"/>
+          </a:p>
+        </p:txBody>
+      </p:sp>
+      <p:sp>
+        <p:nvSpPr>
+          <p:cNvPr id="17" name="Text 15"/>
+          <p:cNvSpPr/>
+          <p:nvPr/>
+        </p:nvSpPr>
+        <p:spPr>
+          <a:xfrm>
+            <a:off x="457200" y="4663440"/>
+            <a:ext cx="3657600" cy="274320"/>
           </a:xfrm>
           <a:prstGeom prst="rect">
             <a:avLst/>
@@ -2745,226 +3467,10 @@
             <a:r>
               <a:rPr lang="en-US" sz="1000" dirty="0">
                 <a:solidFill>
-                  <a:srgbClr val="555555"/>
-                </a:solidFill>
-              </a:rPr>
-              <a:t>2023.11.15</a:t>
-            </a:r>
-            <a:endParaRPr lang="en-US" sz="1000" dirty="0"/>
-          </a:p>
-        </p:txBody>
-      </p:sp>
-      <p:sp>
-        <p:nvSpPr>
-          <p:cNvPr id="9" name="Text 7"/>
-          <p:cNvSpPr/>
-          <p:nvPr/>
-        </p:nvSpPr>
-        <p:spPr>
-          <a:xfrm>
-            <a:off x="4846320" y="2926080"/>
-            <a:ext cx="2011680" cy="731520"/>
-          </a:xfrm>
-          <a:prstGeom prst="rect">
-            <a:avLst/>
-          </a:prstGeom>
-          <a:noFill/>
-          <a:ln/>
-        </p:spPr>
-        <p:txBody>
-          <a:bodyPr wrap="square" rtlCol="0" anchor="ctr"/>
-          <a:lstStyle/>
-          <a:p>
-            <a:pPr indent="0" marL="0">
-              <a:buNone/>
-            </a:pPr>
-            <a:r>
-              <a:rPr lang="en-US" sz="3200" b="1" dirty="0">
-                <a:solidFill>
-                  <a:srgbClr val="0A0A0B"/>
-                </a:solidFill>
-              </a:rPr>
-              <a:t>TRAE IDE</a:t>
-            </a:r>
-            <a:endParaRPr lang="en-US" sz="3200" dirty="0"/>
-          </a:p>
-        </p:txBody>
-      </p:sp>
-      <p:sp>
-        <p:nvSpPr>
-          <p:cNvPr id="10" name="Text 8"/>
-          <p:cNvSpPr/>
-          <p:nvPr/>
-        </p:nvSpPr>
-        <p:spPr>
-          <a:xfrm>
-            <a:off x="4846320" y="3749040"/>
-            <a:ext cx="2011680" cy="365760"/>
-          </a:xfrm>
-          <a:prstGeom prst="rect">
-            <a:avLst/>
-          </a:prstGeom>
-          <a:noFill/>
-          <a:ln/>
-        </p:spPr>
-        <p:txBody>
-          <a:bodyPr wrap="square" rtlCol="0" anchor="ctr"/>
-          <a:lstStyle/>
-          <a:p>
-            <a:pPr indent="0" marL="0">
-              <a:buNone/>
-            </a:pPr>
-            <a:r>
-              <a:rPr lang="en-US" sz="1400" dirty="0">
-                <a:solidFill>
-                  <a:srgbClr val="555555"/>
-                </a:solidFill>
-              </a:rPr>
-              <a:t>闭关产出</a:t>
-            </a:r>
-            <a:endParaRPr lang="en-US" sz="1400" dirty="0"/>
-          </a:p>
-        </p:txBody>
-      </p:sp>
-      <p:sp>
-        <p:nvSpPr>
-          <p:cNvPr id="11" name="Text 9"/>
-          <p:cNvSpPr/>
-          <p:nvPr/>
-        </p:nvSpPr>
-        <p:spPr>
-          <a:xfrm>
-            <a:off x="4846320" y="4114800"/>
-            <a:ext cx="2011680" cy="365760"/>
-          </a:xfrm>
-          <a:prstGeom prst="rect">
-            <a:avLst/>
-          </a:prstGeom>
-          <a:noFill/>
-          <a:ln/>
-        </p:spPr>
-        <p:txBody>
-          <a:bodyPr wrap="square" rtlCol="0" anchor="ctr"/>
-          <a:lstStyle/>
-          <a:p>
-            <a:pPr indent="0" marL="0">
-              <a:buNone/>
-            </a:pPr>
-            <a:r>
-              <a:rPr lang="en-US" sz="1000" dirty="0">
-                <a:solidFill>
-                  <a:srgbClr val="555555"/>
-                </a:solidFill>
-              </a:rPr>
-              <a:t>2024.11.15</a:t>
-            </a:r>
-            <a:endParaRPr lang="en-US" sz="1000" dirty="0"/>
-          </a:p>
-        </p:txBody>
-      </p:sp>
-      <p:sp>
-        <p:nvSpPr>
-          <p:cNvPr id="12" name="Text 10"/>
-          <p:cNvSpPr/>
-          <p:nvPr/>
-        </p:nvSpPr>
-        <p:spPr>
-          <a:xfrm>
-            <a:off x="7040880" y="2926080"/>
-            <a:ext cx="2011680" cy="731520"/>
-          </a:xfrm>
-          <a:prstGeom prst="rect">
-            <a:avLst/>
-          </a:prstGeom>
-          <a:noFill/>
-          <a:ln/>
-        </p:spPr>
-        <p:txBody>
-          <a:bodyPr wrap="square" rtlCol="0" anchor="ctr"/>
-          <a:lstStyle/>
-          <a:p>
-            <a:pPr indent="0" marL="0">
-              <a:buNone/>
-            </a:pPr>
-            <a:r>
-              <a:rPr lang="en-US" sz="3200" b="1" dirty="0">
-                <a:solidFill>
-                  <a:srgbClr val="0A0A0B"/>
-                </a:solidFill>
-              </a:rPr>
-              <a:t>SOLO 独立版</a:t>
-            </a:r>
-            <a:endParaRPr lang="en-US" sz="3200" dirty="0"/>
-          </a:p>
-        </p:txBody>
-      </p:sp>
-      <p:sp>
-        <p:nvSpPr>
-          <p:cNvPr id="13" name="Text 11"/>
-          <p:cNvSpPr/>
-          <p:nvPr/>
-        </p:nvSpPr>
-        <p:spPr>
-          <a:xfrm>
-            <a:off x="7040880" y="3749040"/>
-            <a:ext cx="2011680" cy="365760"/>
-          </a:xfrm>
-          <a:prstGeom prst="rect">
-            <a:avLst/>
-          </a:prstGeom>
-          <a:noFill/>
-          <a:ln/>
-        </p:spPr>
-        <p:txBody>
-          <a:bodyPr wrap="square" rtlCol="0" anchor="ctr"/>
-          <a:lstStyle/>
-          <a:p>
-            <a:pPr indent="0" marL="0">
-              <a:buNone/>
-            </a:pPr>
-            <a:r>
-              <a:rPr lang="en-US" sz="1400" dirty="0">
-                <a:solidFill>
-                  <a:srgbClr val="555555"/>
-                </a:solidFill>
-              </a:rPr>
-              <a:t>全新产出</a:t>
-            </a:r>
-            <a:endParaRPr lang="en-US" sz="1400" dirty="0"/>
-          </a:p>
-        </p:txBody>
-      </p:sp>
-      <p:sp>
-        <p:nvSpPr>
-          <p:cNvPr id="14" name="Text 12"/>
-          <p:cNvSpPr/>
-          <p:nvPr/>
-        </p:nvSpPr>
-        <p:spPr>
-          <a:xfrm>
-            <a:off x="7040880" y="4114800"/>
-            <a:ext cx="2011680" cy="365760"/>
-          </a:xfrm>
-          <a:prstGeom prst="rect">
-            <a:avLst/>
-          </a:prstGeom>
-          <a:noFill/>
-          <a:ln/>
-        </p:spPr>
-        <p:txBody>
-          <a:bodyPr wrap="square" rtlCol="0" anchor="ctr"/>
-          <a:lstStyle/>
-          <a:p>
-            <a:pPr indent="0" marL="0">
-              <a:buNone/>
-            </a:pPr>
-            <a:r>
-              <a:rPr lang="en-US" sz="1000" dirty="0">
-                <a:solidFill>
-                  <a:srgbClr val="555555"/>
-                </a:solidFill>
-              </a:rPr>
-              <a:t>2026年初 闭关</a:t>
+                  <a:srgbClr val="666666"/>
+                </a:solidFill>
+              </a:rPr>
+              <a:t>认知的迭代</a:t>
             </a:r>
             <a:endParaRPr lang="en-US" sz="1000" dirty="0"/>
           </a:p>
@@ -2984,7 +3490,7 @@
     <p:bg>
       <p:bgPr>
         <a:solidFill>
-          <a:srgbClr val="0A0A0B"/>
+          <a:srgbClr val="1E1E1E"/>
         </a:solidFill>
       </p:bgPr>
     </p:bg>
@@ -3010,26 +3516,104 @@
         </p:nvSpPr>
         <p:spPr>
           <a:xfrm>
-            <a:off x="457200" y="457200"/>
-            <a:ext cx="8229600" cy="457200"/>
-          </a:xfrm>
-          <a:prstGeom prst="rect">
-            <a:avLst/>
-          </a:prstGeom>
-          <a:noFill/>
-          <a:ln/>
-        </p:spPr>
-        <p:txBody>
-          <a:bodyPr wrap="square" rtlCol="0" anchor="ctr"/>
-          <a:lstStyle/>
-          <a:p>
-            <a:pPr indent="0" marL="0">
-              <a:buNone/>
-            </a:pPr>
-            <a:r>
-              <a:rPr lang="en-US" sz="1400" spc="200" kern="0" dirty="0">
-                <a:solidFill>
-                  <a:srgbClr val="CCCCCC"/>
+            <a:off x="457200" y="274320"/>
+            <a:ext cx="3657600" cy="274320"/>
+          </a:xfrm>
+          <a:prstGeom prst="rect">
+            <a:avLst/>
+          </a:prstGeom>
+          <a:noFill/>
+          <a:ln/>
+        </p:spPr>
+        <p:txBody>
+          <a:bodyPr wrap="square" rtlCol="0" anchor="ctr"/>
+          <a:lstStyle/>
+          <a:p>
+            <a:pPr indent="0" marL="0">
+              <a:buNone/>
+            </a:pPr>
+            <a:r>
+              <a:rPr lang="en-US" sz="1000" dirty="0">
+                <a:solidFill>
+                  <a:srgbClr val="A0A0A0"/>
+                </a:solidFill>
+                <a:latin typeface="Courier New" pitchFamily="34" charset="0"/>
+                <a:ea typeface="Courier New" pitchFamily="34" charset="-122"/>
+                <a:cs typeface="Courier New" pitchFamily="34" charset="-120"/>
+              </a:rPr>
+              <a:t>开场 · 重新定义 AI</a:t>
+            </a:r>
+            <a:endParaRPr lang="en-US" sz="1000" dirty="0"/>
+          </a:p>
+        </p:txBody>
+      </p:sp>
+      <p:sp>
+        <p:nvSpPr>
+          <p:cNvPr id="3" name="Text 1"/>
+          <p:cNvSpPr/>
+          <p:nvPr/>
+        </p:nvSpPr>
+        <p:spPr>
+          <a:xfrm>
+            <a:off x="5029200" y="274320"/>
+            <a:ext cx="3657600" cy="274320"/>
+          </a:xfrm>
+          <a:prstGeom prst="rect">
+            <a:avLst/>
+          </a:prstGeom>
+          <a:noFill/>
+          <a:ln/>
+        </p:spPr>
+        <p:txBody>
+          <a:bodyPr wrap="square" rtlCol="0" anchor="ctr"/>
+          <a:lstStyle/>
+          <a:p>
+            <a:pPr algn="r" indent="0" marL="0">
+              <a:buNone/>
+            </a:pPr>
+            <a:r>
+              <a:rPr lang="en-US" sz="1000" dirty="0">
+                <a:solidFill>
+                  <a:srgbClr val="A0A0A0"/>
+                </a:solidFill>
+                <a:latin typeface="Courier New" pitchFamily="34" charset="0"/>
+                <a:ea typeface="Courier New" pitchFamily="34" charset="-122"/>
+                <a:cs typeface="Courier New" pitchFamily="34" charset="-120"/>
+              </a:rPr>
+              <a:t>ACT I · 03 / 12</a:t>
+            </a:r>
+            <a:endParaRPr lang="en-US" sz="1000" dirty="0"/>
+          </a:p>
+        </p:txBody>
+      </p:sp>
+      <p:sp>
+        <p:nvSpPr>
+          <p:cNvPr id="4" name="Text 2"/>
+          <p:cNvSpPr/>
+          <p:nvPr/>
+        </p:nvSpPr>
+        <p:spPr>
+          <a:xfrm>
+            <a:off x="457200" y="914400"/>
+            <a:ext cx="8229600" cy="274320"/>
+          </a:xfrm>
+          <a:prstGeom prst="rect">
+            <a:avLst/>
+          </a:prstGeom>
+          <a:noFill/>
+          <a:ln/>
+        </p:spPr>
+        <p:txBody>
+          <a:bodyPr wrap="square" rtlCol="0" anchor="ctr"/>
+          <a:lstStyle/>
+          <a:p>
+            <a:pPr indent="0" marL="0">
+              <a:buNone/>
+            </a:pPr>
+            <a:r>
+              <a:rPr lang="en-US" sz="1400" b="1" dirty="0">
+                <a:solidFill>
+                  <a:srgbClr val="8AB4F8"/>
                 </a:solidFill>
               </a:rPr>
               <a:t>AI 角色跃迁</a:t>
@@ -3040,13 +3624,13 @@
       </p:sp>
       <p:sp>
         <p:nvSpPr>
-          <p:cNvPr id="3" name="Text 1"/>
-          <p:cNvSpPr/>
-          <p:nvPr/>
-        </p:nvSpPr>
-        <p:spPr>
-          <a:xfrm>
-            <a:off x="457200" y="2286000"/>
+          <p:cNvPr id="5" name="Text 3"/>
+          <p:cNvSpPr/>
+          <p:nvPr/>
+        </p:nvSpPr>
+        <p:spPr>
+          <a:xfrm>
+            <a:off x="914400" y="1737360"/>
             <a:ext cx="7315200" cy="1371600"/>
           </a:xfrm>
           <a:prstGeom prst="rect">
@@ -3065,12 +3649,84 @@
             <a:r>
               <a:rPr lang="en-US" sz="2800" i="1" dirty="0">
                 <a:solidFill>
-                  <a:srgbClr val="F1EFEA"/>
+                  <a:srgbClr val="F9F9F7"/>
                 </a:solidFill>
               </a:rPr>
               <a:t>"从“人人都配备的高潜实习生”，到“每个人专属的高级个人助理”。"</a:t>
             </a:r>
             <a:endParaRPr lang="en-US" sz="2800" dirty="0"/>
+          </a:p>
+        </p:txBody>
+      </p:sp>
+      <p:sp>
+        <p:nvSpPr>
+          <p:cNvPr id="6" name="Text 4"/>
+          <p:cNvSpPr/>
+          <p:nvPr/>
+        </p:nvSpPr>
+        <p:spPr>
+          <a:xfrm>
+            <a:off x="914400" y="3291840"/>
+            <a:ext cx="7315200" cy="365760"/>
+          </a:xfrm>
+          <a:prstGeom prst="rect">
+            <a:avLst/>
+          </a:prstGeom>
+          <a:noFill/>
+          <a:ln/>
+        </p:spPr>
+        <p:txBody>
+          <a:bodyPr wrap="square" rtlCol="0" anchor="ctr"/>
+          <a:lstStyle/>
+          <a:p>
+            <a:pPr indent="0" marL="0">
+              <a:buNone/>
+            </a:pPr>
+            <a:r>
+              <a:rPr lang="en-US" sz="1600" dirty="0">
+                <a:solidFill>
+                  <a:srgbClr val="A0A0A0"/>
+                </a:solidFill>
+              </a:rPr>
+              <a:t>— AI 能力边界认知的全面升级</a:t>
+            </a:r>
+            <a:endParaRPr lang="en-US" sz="1600" dirty="0"/>
+          </a:p>
+        </p:txBody>
+      </p:sp>
+      <p:sp>
+        <p:nvSpPr>
+          <p:cNvPr id="7" name="Text 5"/>
+          <p:cNvSpPr/>
+          <p:nvPr/>
+        </p:nvSpPr>
+        <p:spPr>
+          <a:xfrm>
+            <a:off x="457200" y="4663440"/>
+            <a:ext cx="3657600" cy="274320"/>
+          </a:xfrm>
+          <a:prstGeom prst="rect">
+            <a:avLst/>
+          </a:prstGeom>
+          <a:noFill/>
+          <a:ln/>
+        </p:spPr>
+        <p:txBody>
+          <a:bodyPr wrap="square" rtlCol="0" anchor="ctr"/>
+          <a:lstStyle/>
+          <a:p>
+            <a:pPr indent="0" marL="0">
+              <a:buNone/>
+            </a:pPr>
+            <a:r>
+              <a:rPr lang="en-US" sz="1000" dirty="0">
+                <a:solidFill>
+                  <a:srgbClr val="A0A0A0"/>
+                </a:solidFill>
+              </a:rPr>
+              <a:t>AI 角色跃迁</a:t>
+            </a:r>
+            <a:endParaRPr lang="en-US" sz="1000" dirty="0"/>
           </a:p>
         </p:txBody>
       </p:sp>
@@ -3088,7 +3744,7 @@
     <p:bg>
       <p:bgPr>
         <a:solidFill>
-          <a:srgbClr val="F1EFEA"/>
+          <a:srgbClr val="F9F9F7"/>
         </a:solidFill>
       </p:bgPr>
     </p:bg>
@@ -3114,26 +3770,104 @@
         </p:nvSpPr>
         <p:spPr>
           <a:xfrm>
-            <a:off x="457200" y="457200"/>
-            <a:ext cx="8229600" cy="457200"/>
-          </a:xfrm>
-          <a:prstGeom prst="rect">
-            <a:avLst/>
-          </a:prstGeom>
-          <a:noFill/>
-          <a:ln/>
-        </p:spPr>
-        <p:txBody>
-          <a:bodyPr wrap="square" rtlCol="0" anchor="ctr"/>
-          <a:lstStyle/>
-          <a:p>
-            <a:pPr indent="0" marL="0">
-              <a:buNone/>
-            </a:pPr>
-            <a:r>
-              <a:rPr lang="en-US" sz="1400" spc="200" kern="0" dirty="0">
-                <a:solidFill>
-                  <a:srgbClr val="555555"/>
+            <a:off x="457200" y="274320"/>
+            <a:ext cx="3657600" cy="274320"/>
+          </a:xfrm>
+          <a:prstGeom prst="rect">
+            <a:avLst/>
+          </a:prstGeom>
+          <a:noFill/>
+          <a:ln/>
+        </p:spPr>
+        <p:txBody>
+          <a:bodyPr wrap="square" rtlCol="0" anchor="ctr"/>
+          <a:lstStyle/>
+          <a:p>
+            <a:pPr indent="0" marL="0">
+              <a:buNone/>
+            </a:pPr>
+            <a:r>
+              <a:rPr lang="en-US" sz="1000" dirty="0">
+                <a:solidFill>
+                  <a:srgbClr val="666666"/>
+                </a:solidFill>
+                <a:latin typeface="Courier New" pitchFamily="34" charset="0"/>
+                <a:ea typeface="Courier New" pitchFamily="34" charset="-122"/>
+                <a:cs typeface="Courier New" pitchFamily="34" charset="-120"/>
+              </a:rPr>
+              <a:t>开场 · 认知的保鲜期</a:t>
+            </a:r>
+            <a:endParaRPr lang="en-US" sz="1000" dirty="0"/>
+          </a:p>
+        </p:txBody>
+      </p:sp>
+      <p:sp>
+        <p:nvSpPr>
+          <p:cNvPr id="3" name="Text 1"/>
+          <p:cNvSpPr/>
+          <p:nvPr/>
+        </p:nvSpPr>
+        <p:spPr>
+          <a:xfrm>
+            <a:off x="5029200" y="274320"/>
+            <a:ext cx="3657600" cy="274320"/>
+          </a:xfrm>
+          <a:prstGeom prst="rect">
+            <a:avLst/>
+          </a:prstGeom>
+          <a:noFill/>
+          <a:ln/>
+        </p:spPr>
+        <p:txBody>
+          <a:bodyPr wrap="square" rtlCol="0" anchor="ctr"/>
+          <a:lstStyle/>
+          <a:p>
+            <a:pPr algn="r" indent="0" marL="0">
+              <a:buNone/>
+            </a:pPr>
+            <a:r>
+              <a:rPr lang="en-US" sz="1000" dirty="0">
+                <a:solidFill>
+                  <a:srgbClr val="666666"/>
+                </a:solidFill>
+                <a:latin typeface="Courier New" pitchFamily="34" charset="0"/>
+                <a:ea typeface="Courier New" pitchFamily="34" charset="-122"/>
+                <a:cs typeface="Courier New" pitchFamily="34" charset="-120"/>
+              </a:rPr>
+              <a:t>ACT I · 04 / 12</a:t>
+            </a:r>
+            <a:endParaRPr lang="en-US" sz="1000" dirty="0"/>
+          </a:p>
+        </p:txBody>
+      </p:sp>
+      <p:sp>
+        <p:nvSpPr>
+          <p:cNvPr id="4" name="Text 2"/>
+          <p:cNvSpPr/>
+          <p:nvPr/>
+        </p:nvSpPr>
+        <p:spPr>
+          <a:xfrm>
+            <a:off x="457200" y="914400"/>
+            <a:ext cx="8229600" cy="274320"/>
+          </a:xfrm>
+          <a:prstGeom prst="rect">
+            <a:avLst/>
+          </a:prstGeom>
+          <a:noFill/>
+          <a:ln/>
+        </p:spPr>
+        <p:txBody>
+          <a:bodyPr wrap="square" rtlCol="0" anchor="ctr"/>
+          <a:lstStyle/>
+          <a:p>
+            <a:pPr indent="0" marL="0">
+              <a:buNone/>
+            </a:pPr>
+            <a:r>
+              <a:rPr lang="en-US" sz="1400" b="1" dirty="0">
+                <a:solidFill>
+                  <a:srgbClr val="0F52BA"/>
                 </a:solidFill>
               </a:rPr>
               <a:t>痛并快乐着的打脸</a:t>
@@ -3144,101 +3878,289 @@
       </p:sp>
       <p:sp>
         <p:nvSpPr>
-          <p:cNvPr id="3" name="Text 1"/>
-          <p:cNvSpPr/>
-          <p:nvPr/>
-        </p:nvSpPr>
-        <p:spPr>
-          <a:xfrm>
-            <a:off x="457200" y="1097280"/>
-            <a:ext cx="8229600" cy="1371600"/>
-          </a:xfrm>
-          <a:prstGeom prst="rect">
-            <a:avLst/>
-          </a:prstGeom>
-          <a:noFill/>
-          <a:ln/>
-        </p:spPr>
-        <p:txBody>
-          <a:bodyPr wrap="square" rtlCol="0" anchor="ctr"/>
-          <a:lstStyle/>
-          <a:p>
-            <a:pPr indent="0" marL="0">
-              <a:buNone/>
-            </a:pPr>
-            <a:r>
-              <a:rPr lang="en-US" sz="4800" b="1" dirty="0">
-                <a:solidFill>
-                  <a:srgbClr val="0A0A0B"/>
+          <p:cNvPr id="5" name="Text 3"/>
+          <p:cNvSpPr/>
+          <p:nvPr/>
+        </p:nvSpPr>
+        <p:spPr>
+          <a:xfrm>
+            <a:off x="457200" y="1280160"/>
+            <a:ext cx="8229600" cy="1097280"/>
+          </a:xfrm>
+          <a:prstGeom prst="rect">
+            <a:avLst/>
+          </a:prstGeom>
+          <a:noFill/>
+          <a:ln/>
+        </p:spPr>
+        <p:txBody>
+          <a:bodyPr wrap="square" rtlCol="0" anchor="t"/>
+          <a:lstStyle/>
+          <a:p>
+            <a:pPr algn="l" indent="0" marL="0">
+              <a:buNone/>
+            </a:pPr>
+            <a:r>
+              <a:rPr lang="en-US" sz="3600" b="1" dirty="0">
+                <a:solidFill>
+                  <a:srgbClr val="1E1E1E"/>
                 </a:solidFill>
               </a:rPr>
               <a:t>2月份的认知，在12月份就被推翻。</a:t>
             </a:r>
-            <a:endParaRPr lang="en-US" sz="4800" dirty="0"/>
-          </a:p>
-        </p:txBody>
-      </p:sp>
-      <p:sp>
-        <p:nvSpPr>
-          <p:cNvPr id="4" name="Text 2"/>
-          <p:cNvSpPr/>
-          <p:nvPr/>
-        </p:nvSpPr>
-        <p:spPr>
-          <a:xfrm>
-            <a:off x="457200" y="2286000"/>
-            <a:ext cx="7772400" cy="1371600"/>
-          </a:xfrm>
-          <a:prstGeom prst="rect">
-            <a:avLst/>
-          </a:prstGeom>
-          <a:noFill/>
-          <a:ln/>
-        </p:spPr>
-        <p:txBody>
-          <a:bodyPr wrap="square" rtlCol="0" anchor="ctr"/>
-          <a:lstStyle/>
-          <a:p>
-            <a:pPr indent="0" marL="0">
-              <a:buNone/>
-            </a:pPr>
-            <a:r>
-              <a:rPr lang="en-US" sz="1800" dirty="0">
-                <a:solidFill>
-                  <a:srgbClr val="555555"/>
+            <a:endParaRPr lang="en-US" sz="3600" dirty="0"/>
+          </a:p>
+        </p:txBody>
+      </p:sp>
+      <p:sp>
+        <p:nvSpPr>
+          <p:cNvPr id="6" name="Text 4"/>
+          <p:cNvSpPr/>
+          <p:nvPr/>
+        </p:nvSpPr>
+        <p:spPr>
+          <a:xfrm>
+            <a:off x="457200" y="2377440"/>
+            <a:ext cx="3657600" cy="274320"/>
+          </a:xfrm>
+          <a:prstGeom prst="rect">
+            <a:avLst/>
+          </a:prstGeom>
+          <a:noFill/>
+          <a:ln/>
+        </p:spPr>
+        <p:txBody>
+          <a:bodyPr wrap="square" rtlCol="0" anchor="ctr"/>
+          <a:lstStyle/>
+          <a:p>
+            <a:pPr indent="0" marL="0">
+              <a:buNone/>
+            </a:pPr>
+            <a:r>
+              <a:rPr lang="en-US" sz="1200" b="1" dirty="0">
+                <a:solidFill>
+                  <a:srgbClr val="666666"/>
+                </a:solidFill>
+              </a:rPr>
+              <a:t>2月份的判断</a:t>
+            </a:r>
+            <a:endParaRPr lang="en-US" sz="1200" dirty="0"/>
+          </a:p>
+        </p:txBody>
+      </p:sp>
+      <p:sp>
+        <p:nvSpPr>
+          <p:cNvPr id="7" name="Text 5"/>
+          <p:cNvSpPr/>
+          <p:nvPr/>
+        </p:nvSpPr>
+        <p:spPr>
+          <a:xfrm>
+            <a:off x="457200" y="2743200"/>
+            <a:ext cx="3657600" cy="457200"/>
+          </a:xfrm>
+          <a:prstGeom prst="rect">
+            <a:avLst/>
+          </a:prstGeom>
+          <a:noFill/>
+          <a:ln/>
+        </p:spPr>
+        <p:txBody>
+          <a:bodyPr wrap="square" rtlCol="0" anchor="ctr"/>
+          <a:lstStyle/>
+          <a:p>
+            <a:pPr indent="0" marL="0">
+              <a:buNone/>
+            </a:pPr>
+            <a:r>
+              <a:rPr lang="en-US" sz="2000" b="1" dirty="0">
+                <a:solidFill>
+                  <a:srgbClr val="1E1E1E"/>
+                </a:solidFill>
+              </a:rPr>
+              <a:t>Tab Tab 是仪式感</a:t>
+            </a:r>
+            <a:endParaRPr lang="en-US" sz="2000" dirty="0"/>
+          </a:p>
+        </p:txBody>
+      </p:sp>
+      <p:sp>
+        <p:nvSpPr>
+          <p:cNvPr id="8" name="Text 6"/>
+          <p:cNvSpPr/>
+          <p:nvPr/>
+        </p:nvSpPr>
+        <p:spPr>
+          <a:xfrm>
+            <a:off x="457200" y="3291840"/>
+            <a:ext cx="3840480" cy="1828800"/>
+          </a:xfrm>
+          <a:prstGeom prst="rect">
+            <a:avLst/>
+          </a:prstGeom>
+          <a:noFill/>
+          <a:ln/>
+        </p:spPr>
+        <p:txBody>
+          <a:bodyPr wrap="square" rtlCol="0" anchor="t"/>
+          <a:lstStyle/>
+          <a:p>
+            <a:pPr indent="0" marL="0">
+              <a:buNone/>
+            </a:pPr>
+            <a:r>
+              <a:rPr lang="en-US" sz="1600" dirty="0">
+                <a:solidFill>
+                  <a:srgbClr val="666666"/>
                 </a:solidFill>
               </a:rPr>
               <a:t>当时认为 Builder 只是吸引尝鲜，Tab Tab 才是过日子的惊喜感。虽然知道未来是 Agent（自主理解、调用工具、完成任务），但觉得这一天还很远。</a:t>
             </a:r>
-            <a:endParaRPr lang="en-US" sz="1800" dirty="0"/>
-          </a:p>
-          <a:p>
-            <a:pPr indent="0" marL="0">
-              <a:buNone/>
-            </a:pPr>
-            <a:r>
-              <a:rPr lang="en-US" sz="1800" dirty="0">
-                <a:solidFill>
-                  <a:srgbClr val="555555"/>
-                </a:solidFill>
-              </a:rPr>
-              <a:t>        </a:t>
-            </a:r>
-            <a:endParaRPr lang="en-US" sz="1800" dirty="0"/>
-          </a:p>
-          <a:p>
-            <a:pPr indent="0" marL="0">
-              <a:buNone/>
-            </a:pPr>
-            <a:r>
-              <a:rPr lang="en-US" sz="1800" dirty="0">
-                <a:solidFill>
-                  <a:srgbClr val="555555"/>
-                </a:solidFill>
-              </a:rPr>
-              <a:t>          用 Agent 做长时间异步并行、在严肃场景中深度使用已成共识。比如社区 Expert 全年用 Agent 写了 30 万行代码，但只 Tab Tab 了 12 次。直接进入了第三阶段。</a:t>
-            </a:r>
-            <a:endParaRPr lang="en-US" sz="1800" dirty="0"/>
+            <a:endParaRPr lang="en-US" sz="1600" dirty="0"/>
+          </a:p>
+        </p:txBody>
+      </p:sp>
+      <p:sp>
+        <p:nvSpPr>
+          <p:cNvPr id="9" name="Text 7"/>
+          <p:cNvSpPr/>
+          <p:nvPr/>
+        </p:nvSpPr>
+        <p:spPr>
+          <a:xfrm>
+            <a:off x="4572000" y="2377440"/>
+            <a:ext cx="3657600" cy="274320"/>
+          </a:xfrm>
+          <a:prstGeom prst="rect">
+            <a:avLst/>
+          </a:prstGeom>
+          <a:noFill/>
+          <a:ln/>
+        </p:spPr>
+        <p:txBody>
+          <a:bodyPr wrap="square" rtlCol="0" anchor="ctr"/>
+          <a:lstStyle/>
+          <a:p>
+            <a:pPr indent="0" marL="0">
+              <a:buNone/>
+            </a:pPr>
+            <a:r>
+              <a:rPr lang="en-US" sz="1200" b="1" dirty="0">
+                <a:solidFill>
+                  <a:srgbClr val="666666"/>
+                </a:solidFill>
+              </a:rPr>
+              <a:t>12月份的共识</a:t>
+            </a:r>
+            <a:endParaRPr lang="en-US" sz="1200" dirty="0"/>
+          </a:p>
+        </p:txBody>
+      </p:sp>
+      <p:sp>
+        <p:nvSpPr>
+          <p:cNvPr id="10" name="Text 8"/>
+          <p:cNvSpPr/>
+          <p:nvPr/>
+        </p:nvSpPr>
+        <p:spPr>
+          <a:xfrm>
+            <a:off x="4572000" y="2743200"/>
+            <a:ext cx="3657600" cy="457200"/>
+          </a:xfrm>
+          <a:prstGeom prst="rect">
+            <a:avLst/>
+          </a:prstGeom>
+          <a:noFill/>
+          <a:ln/>
+        </p:spPr>
+        <p:txBody>
+          <a:bodyPr wrap="square" rtlCol="0" anchor="ctr"/>
+          <a:lstStyle/>
+          <a:p>
+            <a:pPr indent="0" marL="0">
+              <a:buNone/>
+            </a:pPr>
+            <a:r>
+              <a:rPr lang="en-US" sz="2000" b="1" dirty="0">
+                <a:solidFill>
+                  <a:srgbClr val="1E1E1E"/>
+                </a:solidFill>
+              </a:rPr>
+              <a:t>AI 自主编程已成常态</a:t>
+            </a:r>
+            <a:endParaRPr lang="en-US" sz="2000" dirty="0"/>
+          </a:p>
+        </p:txBody>
+      </p:sp>
+      <p:sp>
+        <p:nvSpPr>
+          <p:cNvPr id="11" name="Text 9"/>
+          <p:cNvSpPr/>
+          <p:nvPr/>
+        </p:nvSpPr>
+        <p:spPr>
+          <a:xfrm>
+            <a:off x="4572000" y="3291840"/>
+            <a:ext cx="3840480" cy="1828800"/>
+          </a:xfrm>
+          <a:prstGeom prst="rect">
+            <a:avLst/>
+          </a:prstGeom>
+          <a:noFill/>
+          <a:ln/>
+        </p:spPr>
+        <p:txBody>
+          <a:bodyPr wrap="square" rtlCol="0" anchor="t"/>
+          <a:lstStyle/>
+          <a:p>
+            <a:pPr indent="0" marL="0">
+              <a:buNone/>
+            </a:pPr>
+            <a:r>
+              <a:rPr lang="en-US" sz="1600" dirty="0">
+                <a:solidFill>
+                  <a:srgbClr val="666666"/>
+                </a:solidFill>
+              </a:rPr>
+              <a:t>用 Agent 做长时间异步并行、在严肃场景中深度使用已成共识。比如社区 Expert 全年用 Agent 写了 30 万行代码，但只 Tab Tab 了 12 次。直接进入了第三阶段。</a:t>
+            </a:r>
+            <a:endParaRPr lang="en-US" sz="1600" dirty="0"/>
+          </a:p>
+        </p:txBody>
+      </p:sp>
+      <p:sp>
+        <p:nvSpPr>
+          <p:cNvPr id="12" name="Text 10"/>
+          <p:cNvSpPr/>
+          <p:nvPr/>
+        </p:nvSpPr>
+        <p:spPr>
+          <a:xfrm>
+            <a:off x="457200" y="4663440"/>
+            <a:ext cx="3657600" cy="274320"/>
+          </a:xfrm>
+          <a:prstGeom prst="rect">
+            <a:avLst/>
+          </a:prstGeom>
+          <a:noFill/>
+          <a:ln/>
+        </p:spPr>
+        <p:txBody>
+          <a:bodyPr wrap="square" rtlCol="0" anchor="ctr"/>
+          <a:lstStyle/>
+          <a:p>
+            <a:pPr indent="0" marL="0">
+              <a:buNone/>
+            </a:pPr>
+            <a:r>
+              <a:rPr lang="en-US" sz="1000" dirty="0">
+                <a:solidFill>
+                  <a:srgbClr val="666666"/>
+                </a:solidFill>
+              </a:rPr>
+              <a:t>认知的跃迁速度</a:t>
+            </a:r>
+            <a:endParaRPr lang="en-US" sz="1000" dirty="0"/>
           </a:p>
         </p:txBody>
       </p:sp>
@@ -3256,7 +4178,7 @@
     <p:bg>
       <p:bgPr>
         <a:solidFill>
-          <a:srgbClr val="F1EFEA"/>
+          <a:srgbClr val="F9F9F7"/>
         </a:solidFill>
       </p:bgPr>
     </p:bg>
@@ -3282,31 +4204,34 @@
         </p:nvSpPr>
         <p:spPr>
           <a:xfrm>
-            <a:off x="457200" y="457200"/>
-            <a:ext cx="8229600" cy="457200"/>
-          </a:xfrm>
-          <a:prstGeom prst="rect">
-            <a:avLst/>
-          </a:prstGeom>
-          <a:noFill/>
-          <a:ln/>
-        </p:spPr>
-        <p:txBody>
-          <a:bodyPr wrap="square" rtlCol="0" anchor="ctr"/>
-          <a:lstStyle/>
-          <a:p>
-            <a:pPr indent="0" marL="0">
-              <a:buNone/>
-            </a:pPr>
-            <a:r>
-              <a:rPr lang="en-US" sz="1400" spc="200" kern="0" dirty="0">
-                <a:solidFill>
-                  <a:srgbClr val="555555"/>
-                </a:solidFill>
-              </a:rPr>
-              <a:t>Act II</a:t>
-            </a:r>
-            <a:endParaRPr lang="en-US" sz="1400" dirty="0"/>
+            <a:off x="457200" y="274320"/>
+            <a:ext cx="3657600" cy="274320"/>
+          </a:xfrm>
+          <a:prstGeom prst="rect">
+            <a:avLst/>
+          </a:prstGeom>
+          <a:noFill/>
+          <a:ln/>
+        </p:spPr>
+        <p:txBody>
+          <a:bodyPr wrap="square" rtlCol="0" anchor="ctr"/>
+          <a:lstStyle/>
+          <a:p>
+            <a:pPr indent="0" marL="0">
+              <a:buNone/>
+            </a:pPr>
+            <a:r>
+              <a:rPr lang="en-US" sz="1000" dirty="0">
+                <a:solidFill>
+                  <a:srgbClr val="666666"/>
+                </a:solidFill>
+                <a:latin typeface="Courier New" pitchFamily="34" charset="0"/>
+                <a:ea typeface="Courier New" pitchFamily="34" charset="-122"/>
+                <a:cs typeface="Courier New" pitchFamily="34" charset="-120"/>
+              </a:rPr>
+              <a:t>第二幕 · 真实实践</a:t>
+            </a:r>
+            <a:endParaRPr lang="en-US" sz="1000" dirty="0"/>
           </a:p>
         </p:txBody>
       </p:sp>
@@ -3318,67 +4243,106 @@
         </p:nvSpPr>
         <p:spPr>
           <a:xfrm>
-            <a:off x="457200" y="1097280"/>
-            <a:ext cx="8229600" cy="1371600"/>
-          </a:xfrm>
-          <a:prstGeom prst="rect">
-            <a:avLst/>
-          </a:prstGeom>
-          <a:noFill/>
-          <a:ln/>
-        </p:spPr>
-        <p:txBody>
-          <a:bodyPr wrap="square" rtlCol="0" anchor="ctr"/>
-          <a:lstStyle/>
-          <a:p>
-            <a:pPr indent="0" marL="0">
-              <a:buNone/>
-            </a:pPr>
-            <a:r>
-              <a:rPr lang="en-US" sz="4800" b="1" dirty="0">
-                <a:solidFill>
-                  <a:srgbClr val="0A0A0B"/>
+            <a:off x="5029200" y="274320"/>
+            <a:ext cx="3657600" cy="274320"/>
+          </a:xfrm>
+          <a:prstGeom prst="rect">
+            <a:avLst/>
+          </a:prstGeom>
+          <a:noFill/>
+          <a:ln/>
+        </p:spPr>
+        <p:txBody>
+          <a:bodyPr wrap="square" rtlCol="0" anchor="ctr"/>
+          <a:lstStyle/>
+          <a:p>
+            <a:pPr algn="r" indent="0" marL="0">
+              <a:buNone/>
+            </a:pPr>
+            <a:r>
+              <a:rPr lang="en-US" sz="1000" dirty="0">
+                <a:solidFill>
+                  <a:srgbClr val="666666"/>
+                </a:solidFill>
+                <a:latin typeface="Courier New" pitchFamily="34" charset="0"/>
+                <a:ea typeface="Courier New" pitchFamily="34" charset="-122"/>
+                <a:cs typeface="Courier New" pitchFamily="34" charset="-120"/>
+              </a:rPr>
+              <a:t>ACT II · 05 / 12</a:t>
+            </a:r>
+            <a:endParaRPr lang="en-US" sz="1000" dirty="0"/>
+          </a:p>
+        </p:txBody>
+      </p:sp>
+      <p:sp>
+        <p:nvSpPr>
+          <p:cNvPr id="4" name="Text 2"/>
+          <p:cNvSpPr/>
+          <p:nvPr/>
+        </p:nvSpPr>
+        <p:spPr>
+          <a:xfrm>
+            <a:off x="457200" y="1828800"/>
+            <a:ext cx="8229600" cy="1097280"/>
+          </a:xfrm>
+          <a:prstGeom prst="rect">
+            <a:avLst/>
+          </a:prstGeom>
+          <a:noFill/>
+          <a:ln/>
+        </p:spPr>
+        <p:txBody>
+          <a:bodyPr wrap="square" rtlCol="0" anchor="t"/>
+          <a:lstStyle/>
+          <a:p>
+            <a:pPr algn="ctr" indent="0" marL="0">
+              <a:buNone/>
+            </a:pPr>
+            <a:r>
+              <a:rPr lang="en-US" sz="5400" b="1" dirty="0">
+                <a:solidFill>
+                  <a:srgbClr val="1E1E1E"/>
                 </a:solidFill>
               </a:rPr>
               <a:t>实践：SOLO Powers SOLO</a:t>
             </a:r>
-            <a:endParaRPr lang="en-US" sz="4800" dirty="0"/>
-          </a:p>
-        </p:txBody>
-      </p:sp>
-      <p:sp>
-        <p:nvSpPr>
-          <p:cNvPr id="4" name="Text 2"/>
-          <p:cNvSpPr/>
-          <p:nvPr/>
-        </p:nvSpPr>
-        <p:spPr>
-          <a:xfrm>
-            <a:off x="457200" y="2286000"/>
-            <a:ext cx="7772400" cy="1371600"/>
-          </a:xfrm>
-          <a:prstGeom prst="rect">
-            <a:avLst/>
-          </a:prstGeom>
-          <a:noFill/>
-          <a:ln/>
-        </p:spPr>
-        <p:txBody>
-          <a:bodyPr wrap="square" rtlCol="0" anchor="ctr"/>
-          <a:lstStyle/>
-          <a:p>
-            <a:pPr indent="0" marL="0">
-              <a:buNone/>
-            </a:pPr>
-            <a:r>
-              <a:rPr lang="en-US" sz="1800" dirty="0">
-                <a:solidFill>
-                  <a:srgbClr val="555555"/>
+            <a:endParaRPr lang="en-US" sz="5400" dirty="0"/>
+          </a:p>
+        </p:txBody>
+      </p:sp>
+      <p:sp>
+        <p:nvSpPr>
+          <p:cNvPr id="5" name="Text 3"/>
+          <p:cNvSpPr/>
+          <p:nvPr/>
+        </p:nvSpPr>
+        <p:spPr>
+          <a:xfrm>
+            <a:off x="1371600" y="3657600"/>
+            <a:ext cx="6400800" cy="914400"/>
+          </a:xfrm>
+          <a:prstGeom prst="rect">
+            <a:avLst/>
+          </a:prstGeom>
+          <a:noFill/>
+          <a:ln/>
+        </p:spPr>
+        <p:txBody>
+          <a:bodyPr wrap="square" rtlCol="0" anchor="t"/>
+          <a:lstStyle/>
+          <a:p>
+            <a:pPr algn="ctr" indent="0" marL="0">
+              <a:buNone/>
+            </a:pPr>
+            <a:r>
+              <a:rPr lang="en-US" sz="2000" dirty="0">
+                <a:solidFill>
+                  <a:srgbClr val="666666"/>
                 </a:solidFill>
               </a:rPr>
               <a:t>在前线看到了什么？我们把自己作为最佳实践，吃自己的狗粮。</a:t>
             </a:r>
-            <a:endParaRPr lang="en-US" sz="1800" dirty="0"/>
+            <a:endParaRPr lang="en-US" sz="2000" dirty="0"/>
           </a:p>
         </p:txBody>
       </p:sp>
@@ -3396,7 +4360,7 @@
     <p:bg>
       <p:bgPr>
         <a:solidFill>
-          <a:srgbClr val="0A0A0B"/>
+          <a:srgbClr val="1E1E1E"/>
         </a:solidFill>
       </p:bgPr>
     </p:bg>
@@ -3422,26 +4386,104 @@
         </p:nvSpPr>
         <p:spPr>
           <a:xfrm>
-            <a:off x="457200" y="457200"/>
-            <a:ext cx="8229600" cy="457200"/>
-          </a:xfrm>
-          <a:prstGeom prst="rect">
-            <a:avLst/>
-          </a:prstGeom>
-          <a:noFill/>
-          <a:ln/>
-        </p:spPr>
-        <p:txBody>
-          <a:bodyPr wrap="square" rtlCol="0" anchor="ctr"/>
-          <a:lstStyle/>
-          <a:p>
-            <a:pPr indent="0" marL="0">
-              <a:buNone/>
-            </a:pPr>
-            <a:r>
-              <a:rPr lang="en-US" sz="1400" spc="200" kern="0" dirty="0">
-                <a:solidFill>
-                  <a:srgbClr val="CCCCCC"/>
+            <a:off x="457200" y="274320"/>
+            <a:ext cx="3657600" cy="274320"/>
+          </a:xfrm>
+          <a:prstGeom prst="rect">
+            <a:avLst/>
+          </a:prstGeom>
+          <a:noFill/>
+          <a:ln/>
+        </p:spPr>
+        <p:txBody>
+          <a:bodyPr wrap="square" rtlCol="0" anchor="ctr"/>
+          <a:lstStyle/>
+          <a:p>
+            <a:pPr indent="0" marL="0">
+              <a:buNone/>
+            </a:pPr>
+            <a:r>
+              <a:rPr lang="en-US" sz="1000" dirty="0">
+                <a:solidFill>
+                  <a:srgbClr val="A0A0A0"/>
+                </a:solidFill>
+                <a:latin typeface="Courier New" pitchFamily="34" charset="0"/>
+                <a:ea typeface="Courier New" pitchFamily="34" charset="-122"/>
+                <a:cs typeface="Courier New" pitchFamily="34" charset="-120"/>
+              </a:rPr>
+              <a:t>实践 · 惊人的数据</a:t>
+            </a:r>
+            <a:endParaRPr lang="en-US" sz="1000" dirty="0"/>
+          </a:p>
+        </p:txBody>
+      </p:sp>
+      <p:sp>
+        <p:nvSpPr>
+          <p:cNvPr id="3" name="Text 1"/>
+          <p:cNvSpPr/>
+          <p:nvPr/>
+        </p:nvSpPr>
+        <p:spPr>
+          <a:xfrm>
+            <a:off x="5029200" y="274320"/>
+            <a:ext cx="3657600" cy="274320"/>
+          </a:xfrm>
+          <a:prstGeom prst="rect">
+            <a:avLst/>
+          </a:prstGeom>
+          <a:noFill/>
+          <a:ln/>
+        </p:spPr>
+        <p:txBody>
+          <a:bodyPr wrap="square" rtlCol="0" anchor="ctr"/>
+          <a:lstStyle/>
+          <a:p>
+            <a:pPr algn="r" indent="0" marL="0">
+              <a:buNone/>
+            </a:pPr>
+            <a:r>
+              <a:rPr lang="en-US" sz="1000" dirty="0">
+                <a:solidFill>
+                  <a:srgbClr val="A0A0A0"/>
+                </a:solidFill>
+                <a:latin typeface="Courier New" pitchFamily="34" charset="0"/>
+                <a:ea typeface="Courier New" pitchFamily="34" charset="-122"/>
+                <a:cs typeface="Courier New" pitchFamily="34" charset="-120"/>
+              </a:rPr>
+              <a:t>ACT II · 06 / 12</a:t>
+            </a:r>
+            <a:endParaRPr lang="en-US" sz="1000" dirty="0"/>
+          </a:p>
+        </p:txBody>
+      </p:sp>
+      <p:sp>
+        <p:nvSpPr>
+          <p:cNvPr id="4" name="Text 2"/>
+          <p:cNvSpPr/>
+          <p:nvPr/>
+        </p:nvSpPr>
+        <p:spPr>
+          <a:xfrm>
+            <a:off x="457200" y="914400"/>
+            <a:ext cx="8229600" cy="274320"/>
+          </a:xfrm>
+          <a:prstGeom prst="rect">
+            <a:avLst/>
+          </a:prstGeom>
+          <a:noFill/>
+          <a:ln/>
+        </p:spPr>
+        <p:txBody>
+          <a:bodyPr wrap="square" rtlCol="0" anchor="ctr"/>
+          <a:lstStyle/>
+          <a:p>
+            <a:pPr indent="0" marL="0">
+              <a:buNone/>
+            </a:pPr>
+            <a:r>
+              <a:rPr lang="en-US" sz="1400" b="1" dirty="0">
+                <a:solidFill>
+                  <a:srgbClr val="8AB4F8"/>
                 </a:solidFill>
               </a:rPr>
               <a:t>开发 SOLO 的真实数据</a:t>
@@ -3452,266 +4494,302 @@
       </p:sp>
       <p:sp>
         <p:nvSpPr>
-          <p:cNvPr id="3" name="Text 1"/>
-          <p:cNvSpPr/>
-          <p:nvPr/>
-        </p:nvSpPr>
-        <p:spPr>
-          <a:xfrm>
-            <a:off x="457200" y="1097280"/>
-            <a:ext cx="8229600" cy="1371600"/>
-          </a:xfrm>
-          <a:prstGeom prst="rect">
-            <a:avLst/>
-          </a:prstGeom>
-          <a:noFill/>
-          <a:ln/>
-        </p:spPr>
-        <p:txBody>
-          <a:bodyPr wrap="square" rtlCol="0" anchor="ctr"/>
-          <a:lstStyle/>
-          <a:p>
-            <a:pPr indent="0" marL="0">
-              <a:buNone/>
-            </a:pPr>
-            <a:r>
-              <a:rPr lang="en-US" sz="4800" b="1" dirty="0">
-                <a:solidFill>
-                  <a:srgbClr val="F1EFEA"/>
+          <p:cNvPr id="5" name="Text 3"/>
+          <p:cNvSpPr/>
+          <p:nvPr/>
+        </p:nvSpPr>
+        <p:spPr>
+          <a:xfrm>
+            <a:off x="457200" y="1280160"/>
+            <a:ext cx="8229600" cy="1097280"/>
+          </a:xfrm>
+          <a:prstGeom prst="rect">
+            <a:avLst/>
+          </a:prstGeom>
+          <a:noFill/>
+          <a:ln/>
+        </p:spPr>
+        <p:txBody>
+          <a:bodyPr wrap="square" rtlCol="0" anchor="t"/>
+          <a:lstStyle/>
+          <a:p>
+            <a:pPr algn="l" indent="0" marL="0">
+              <a:buNone/>
+            </a:pPr>
+            <a:r>
+              <a:rPr lang="en-US" sz="3600" b="1" dirty="0">
+                <a:solidFill>
+                  <a:srgbClr val="F9F9F7"/>
                 </a:solidFill>
               </a:rPr>
               <a:t>我们不仅是做工具的人，更是第一批深度用户。</a:t>
             </a:r>
-            <a:endParaRPr lang="en-US" sz="4800" dirty="0"/>
-          </a:p>
-        </p:txBody>
-      </p:sp>
-      <p:sp>
-        <p:nvSpPr>
-          <p:cNvPr id="4" name="Text 2"/>
-          <p:cNvSpPr/>
-          <p:nvPr/>
-        </p:nvSpPr>
-        <p:spPr>
-          <a:xfrm>
-            <a:off x="457200" y="2926080"/>
-            <a:ext cx="2011680" cy="731520"/>
-          </a:xfrm>
-          <a:prstGeom prst="rect">
-            <a:avLst/>
-          </a:prstGeom>
-          <a:noFill/>
-          <a:ln/>
-        </p:spPr>
-        <p:txBody>
-          <a:bodyPr wrap="square" rtlCol="0" anchor="ctr"/>
-          <a:lstStyle/>
-          <a:p>
-            <a:pPr indent="0" marL="0">
-              <a:buNone/>
-            </a:pPr>
-            <a:r>
-              <a:rPr lang="en-US" sz="3200" b="1" dirty="0">
-                <a:solidFill>
-                  <a:srgbClr val="F1EFEA"/>
+            <a:endParaRPr lang="en-US" sz="3600" dirty="0"/>
+          </a:p>
+        </p:txBody>
+      </p:sp>
+      <p:sp>
+        <p:nvSpPr>
+          <p:cNvPr id="6" name="Text 4"/>
+          <p:cNvSpPr/>
+          <p:nvPr/>
+        </p:nvSpPr>
+        <p:spPr>
+          <a:xfrm>
+            <a:off x="457200" y="2560320"/>
+            <a:ext cx="2560320" cy="274320"/>
+          </a:xfrm>
+          <a:prstGeom prst="rect">
+            <a:avLst/>
+          </a:prstGeom>
+          <a:noFill/>
+          <a:ln/>
+        </p:spPr>
+        <p:txBody>
+          <a:bodyPr wrap="square" rtlCol="0" anchor="ctr"/>
+          <a:lstStyle/>
+          <a:p>
+            <a:pPr indent="0" marL="0">
+              <a:buNone/>
+            </a:pPr>
+            <a:r>
+              <a:rPr lang="en-US" sz="1200" b="1" dirty="0">
+                <a:solidFill>
+                  <a:srgbClr val="A0A0A0"/>
+                </a:solidFill>
+              </a:rPr>
+              <a:t>产出代码行数</a:t>
+            </a:r>
+            <a:endParaRPr lang="en-US" sz="1200" dirty="0"/>
+          </a:p>
+        </p:txBody>
+      </p:sp>
+      <p:sp>
+        <p:nvSpPr>
+          <p:cNvPr id="7" name="Text 5"/>
+          <p:cNvSpPr/>
+          <p:nvPr/>
+        </p:nvSpPr>
+        <p:spPr>
+          <a:xfrm>
+            <a:off x="457200" y="2834640"/>
+            <a:ext cx="2560320" cy="731520"/>
+          </a:xfrm>
+          <a:prstGeom prst="rect">
+            <a:avLst/>
+          </a:prstGeom>
+          <a:noFill/>
+          <a:ln/>
+        </p:spPr>
+        <p:txBody>
+          <a:bodyPr wrap="square" rtlCol="0" anchor="ctr"/>
+          <a:lstStyle/>
+          <a:p>
+            <a:pPr indent="0" marL="0">
+              <a:buNone/>
+            </a:pPr>
+            <a:r>
+              <a:rPr lang="en-US" sz="4000" b="1" dirty="0">
+                <a:solidFill>
+                  <a:srgbClr val="F9F9F7"/>
                 </a:solidFill>
               </a:rPr>
               <a:t>100万+</a:t>
             </a:r>
-            <a:endParaRPr lang="en-US" sz="3200" dirty="0"/>
-          </a:p>
-        </p:txBody>
-      </p:sp>
-      <p:sp>
-        <p:nvSpPr>
-          <p:cNvPr id="5" name="Text 3"/>
-          <p:cNvSpPr/>
-          <p:nvPr/>
-        </p:nvSpPr>
-        <p:spPr>
-          <a:xfrm>
-            <a:off x="457200" y="3749040"/>
-            <a:ext cx="2011680" cy="365760"/>
-          </a:xfrm>
-          <a:prstGeom prst="rect">
-            <a:avLst/>
-          </a:prstGeom>
-          <a:noFill/>
-          <a:ln/>
-        </p:spPr>
-        <p:txBody>
-          <a:bodyPr wrap="square" rtlCol="0" anchor="ctr"/>
-          <a:lstStyle/>
-          <a:p>
-            <a:pPr indent="0" marL="0">
-              <a:buNone/>
-            </a:pPr>
-            <a:r>
-              <a:rPr lang="en-US" sz="1400" dirty="0">
-                <a:solidFill>
-                  <a:srgbClr val="CCCCCC"/>
-                </a:solidFill>
-              </a:rPr>
-              <a:t>产出代码行数</a:t>
-            </a:r>
-            <a:endParaRPr lang="en-US" sz="1400" dirty="0"/>
-          </a:p>
-        </p:txBody>
-      </p:sp>
-      <p:sp>
-        <p:nvSpPr>
-          <p:cNvPr id="6" name="Text 4"/>
-          <p:cNvSpPr/>
-          <p:nvPr/>
-        </p:nvSpPr>
-        <p:spPr>
-          <a:xfrm>
-            <a:off x="2651760" y="2926080"/>
-            <a:ext cx="2011680" cy="731520"/>
-          </a:xfrm>
-          <a:prstGeom prst="rect">
-            <a:avLst/>
-          </a:prstGeom>
-          <a:noFill/>
-          <a:ln/>
-        </p:spPr>
-        <p:txBody>
-          <a:bodyPr wrap="square" rtlCol="0" anchor="ctr"/>
-          <a:lstStyle/>
-          <a:p>
-            <a:pPr indent="0" marL="0">
-              <a:buNone/>
-            </a:pPr>
-            <a:r>
-              <a:rPr lang="en-US" sz="3200" b="1" dirty="0">
-                <a:solidFill>
-                  <a:srgbClr val="F1EFEA"/>
+            <a:endParaRPr lang="en-US" sz="4000" dirty="0"/>
+          </a:p>
+        </p:txBody>
+      </p:sp>
+      <p:sp>
+        <p:nvSpPr>
+          <p:cNvPr id="8" name="Text 6"/>
+          <p:cNvSpPr/>
+          <p:nvPr/>
+        </p:nvSpPr>
+        <p:spPr>
+          <a:xfrm>
+            <a:off x="3200400" y="2560320"/>
+            <a:ext cx="2560320" cy="274320"/>
+          </a:xfrm>
+          <a:prstGeom prst="rect">
+            <a:avLst/>
+          </a:prstGeom>
+          <a:noFill/>
+          <a:ln/>
+        </p:spPr>
+        <p:txBody>
+          <a:bodyPr wrap="square" rtlCol="0" anchor="ctr"/>
+          <a:lstStyle/>
+          <a:p>
+            <a:pPr indent="0" marL="0">
+              <a:buNone/>
+            </a:pPr>
+            <a:r>
+              <a:rPr lang="en-US" sz="1200" b="1" dirty="0">
+                <a:solidFill>
+                  <a:srgbClr val="A0A0A0"/>
+                </a:solidFill>
+              </a:rPr>
+              <a:t>总提交次数</a:t>
+            </a:r>
+            <a:endParaRPr lang="en-US" sz="1200" dirty="0"/>
+          </a:p>
+        </p:txBody>
+      </p:sp>
+      <p:sp>
+        <p:nvSpPr>
+          <p:cNvPr id="9" name="Text 7"/>
+          <p:cNvSpPr/>
+          <p:nvPr/>
+        </p:nvSpPr>
+        <p:spPr>
+          <a:xfrm>
+            <a:off x="3200400" y="2834640"/>
+            <a:ext cx="2560320" cy="731520"/>
+          </a:xfrm>
+          <a:prstGeom prst="rect">
+            <a:avLst/>
+          </a:prstGeom>
+          <a:noFill/>
+          <a:ln/>
+        </p:spPr>
+        <p:txBody>
+          <a:bodyPr wrap="square" rtlCol="0" anchor="ctr"/>
+          <a:lstStyle/>
+          <a:p>
+            <a:pPr indent="0" marL="0">
+              <a:buNone/>
+            </a:pPr>
+            <a:r>
+              <a:rPr lang="en-US" sz="4000" b="1" dirty="0">
+                <a:solidFill>
+                  <a:srgbClr val="F9F9F7"/>
                 </a:solidFill>
               </a:rPr>
               <a:t>9,000+</a:t>
             </a:r>
-            <a:endParaRPr lang="en-US" sz="3200" dirty="0"/>
-          </a:p>
-        </p:txBody>
-      </p:sp>
-      <p:sp>
-        <p:nvSpPr>
-          <p:cNvPr id="7" name="Text 5"/>
-          <p:cNvSpPr/>
-          <p:nvPr/>
-        </p:nvSpPr>
-        <p:spPr>
-          <a:xfrm>
-            <a:off x="2651760" y="3749040"/>
-            <a:ext cx="2011680" cy="365760"/>
-          </a:xfrm>
-          <a:prstGeom prst="rect">
-            <a:avLst/>
-          </a:prstGeom>
-          <a:noFill/>
-          <a:ln/>
-        </p:spPr>
-        <p:txBody>
-          <a:bodyPr wrap="square" rtlCol="0" anchor="ctr"/>
-          <a:lstStyle/>
-          <a:p>
-            <a:pPr indent="0" marL="0">
-              <a:buNone/>
-            </a:pPr>
-            <a:r>
-              <a:rPr lang="en-US" sz="1400" dirty="0">
-                <a:solidFill>
-                  <a:srgbClr val="CCCCCC"/>
-                </a:solidFill>
-              </a:rPr>
-              <a:t>总提交次数</a:t>
-            </a:r>
-            <a:endParaRPr lang="en-US" sz="1400" dirty="0"/>
-          </a:p>
-        </p:txBody>
-      </p:sp>
-      <p:sp>
-        <p:nvSpPr>
-          <p:cNvPr id="8" name="Text 6"/>
-          <p:cNvSpPr/>
-          <p:nvPr/>
-        </p:nvSpPr>
-        <p:spPr>
-          <a:xfrm>
-            <a:off x="4846320" y="2926080"/>
-            <a:ext cx="2011680" cy="731520"/>
-          </a:xfrm>
-          <a:prstGeom prst="rect">
-            <a:avLst/>
-          </a:prstGeom>
-          <a:noFill/>
-          <a:ln/>
-        </p:spPr>
-        <p:txBody>
-          <a:bodyPr wrap="square" rtlCol="0" anchor="ctr"/>
-          <a:lstStyle/>
-          <a:p>
-            <a:pPr indent="0" marL="0">
-              <a:buNone/>
-            </a:pPr>
-            <a:r>
-              <a:rPr lang="en-US" sz="3200" b="1" dirty="0">
-                <a:solidFill>
-                  <a:srgbClr val="F1EFEA"/>
+            <a:endParaRPr lang="en-US" sz="4000" dirty="0"/>
+          </a:p>
+        </p:txBody>
+      </p:sp>
+      <p:sp>
+        <p:nvSpPr>
+          <p:cNvPr id="10" name="Text 8"/>
+          <p:cNvSpPr/>
+          <p:nvPr/>
+        </p:nvSpPr>
+        <p:spPr>
+          <a:xfrm>
+            <a:off x="5943600" y="2560320"/>
+            <a:ext cx="2560320" cy="274320"/>
+          </a:xfrm>
+          <a:prstGeom prst="rect">
+            <a:avLst/>
+          </a:prstGeom>
+          <a:noFill/>
+          <a:ln/>
+        </p:spPr>
+        <p:txBody>
+          <a:bodyPr wrap="square" rtlCol="0" anchor="ctr"/>
+          <a:lstStyle/>
+          <a:p>
+            <a:pPr indent="0" marL="0">
+              <a:buNone/>
+            </a:pPr>
+            <a:r>
+              <a:rPr lang="en-US" sz="1200" b="1" dirty="0">
+                <a:solidFill>
+                  <a:srgbClr val="A0A0A0"/>
+                </a:solidFill>
+              </a:rPr>
+              <a:t>AI 代码贡献率</a:t>
+            </a:r>
+            <a:endParaRPr lang="en-US" sz="1200" dirty="0"/>
+          </a:p>
+        </p:txBody>
+      </p:sp>
+      <p:sp>
+        <p:nvSpPr>
+          <p:cNvPr id="11" name="Text 9"/>
+          <p:cNvSpPr/>
+          <p:nvPr/>
+        </p:nvSpPr>
+        <p:spPr>
+          <a:xfrm>
+            <a:off x="5943600" y="2834640"/>
+            <a:ext cx="2560320" cy="731520"/>
+          </a:xfrm>
+          <a:prstGeom prst="rect">
+            <a:avLst/>
+          </a:prstGeom>
+          <a:noFill/>
+          <a:ln/>
+        </p:spPr>
+        <p:txBody>
+          <a:bodyPr wrap="square" rtlCol="0" anchor="ctr"/>
+          <a:lstStyle/>
+          <a:p>
+            <a:pPr indent="0" marL="0">
+              <a:buNone/>
+            </a:pPr>
+            <a:r>
+              <a:rPr lang="en-US" sz="4000" b="1" dirty="0">
+                <a:solidFill>
+                  <a:srgbClr val="F9F9F7"/>
                 </a:solidFill>
               </a:rPr>
               <a:t>93%</a:t>
             </a:r>
-            <a:endParaRPr lang="en-US" sz="3200" dirty="0"/>
-          </a:p>
-        </p:txBody>
-      </p:sp>
-      <p:sp>
-        <p:nvSpPr>
-          <p:cNvPr id="9" name="Text 7"/>
-          <p:cNvSpPr/>
-          <p:nvPr/>
-        </p:nvSpPr>
-        <p:spPr>
-          <a:xfrm>
-            <a:off x="4846320" y="3749040"/>
-            <a:ext cx="2011680" cy="365760"/>
-          </a:xfrm>
-          <a:prstGeom prst="rect">
-            <a:avLst/>
-          </a:prstGeom>
-          <a:noFill/>
-          <a:ln/>
-        </p:spPr>
-        <p:txBody>
-          <a:bodyPr wrap="square" rtlCol="0" anchor="ctr"/>
-          <a:lstStyle/>
-          <a:p>
-            <a:pPr indent="0" marL="0">
-              <a:buNone/>
-            </a:pPr>
-            <a:r>
-              <a:rPr lang="en-US" sz="1400" dirty="0">
-                <a:solidFill>
-                  <a:srgbClr val="CCCCCC"/>
-                </a:solidFill>
-              </a:rPr>
-              <a:t>AI 代码贡献率</a:t>
-            </a:r>
-            <a:endParaRPr lang="en-US" sz="1400" dirty="0"/>
-          </a:p>
-        </p:txBody>
-      </p:sp>
-      <p:sp>
-        <p:nvSpPr>
-          <p:cNvPr id="10" name="Text 8"/>
-          <p:cNvSpPr/>
-          <p:nvPr/>
-        </p:nvSpPr>
-        <p:spPr>
-          <a:xfrm>
-            <a:off x="4846320" y="4114800"/>
-            <a:ext cx="2011680" cy="365760"/>
+            <a:endParaRPr lang="en-US" sz="4000" dirty="0"/>
+          </a:p>
+        </p:txBody>
+      </p:sp>
+      <p:sp>
+        <p:nvSpPr>
+          <p:cNvPr id="12" name="Text 10"/>
+          <p:cNvSpPr/>
+          <p:nvPr/>
+        </p:nvSpPr>
+        <p:spPr>
+          <a:xfrm>
+            <a:off x="5943600" y="3566160"/>
+            <a:ext cx="2560320" cy="274320"/>
+          </a:xfrm>
+          <a:prstGeom prst="rect">
+            <a:avLst/>
+          </a:prstGeom>
+          <a:noFill/>
+          <a:ln/>
+        </p:spPr>
+        <p:txBody>
+          <a:bodyPr wrap="square" rtlCol="0" anchor="ctr"/>
+          <a:lstStyle/>
+          <a:p>
+            <a:pPr indent="0" marL="0">
+              <a:buNone/>
+            </a:pPr>
+            <a:r>
+              <a:rPr lang="en-US" sz="1200" dirty="0">
+                <a:solidFill>
+                  <a:srgbClr val="A0A0A0"/>
+                </a:solidFill>
+              </a:rPr>
+              <a:t>半年后可能就是整个行业的常态</a:t>
+            </a:r>
+            <a:endParaRPr lang="en-US" sz="1200" dirty="0"/>
+          </a:p>
+        </p:txBody>
+      </p:sp>
+      <p:sp>
+        <p:nvSpPr>
+          <p:cNvPr id="13" name="Text 11"/>
+          <p:cNvSpPr/>
+          <p:nvPr/>
+        </p:nvSpPr>
+        <p:spPr>
+          <a:xfrm>
+            <a:off x="457200" y="4663440"/>
+            <a:ext cx="3657600" cy="274320"/>
           </a:xfrm>
           <a:prstGeom prst="rect">
             <a:avLst/>
@@ -3729,10 +4807,10 @@
             <a:r>
               <a:rPr lang="en-US" sz="1000" dirty="0">
                 <a:solidFill>
-                  <a:srgbClr val="CCCCCC"/>
-                </a:solidFill>
-              </a:rPr>
-              <a:t>半年后可能就是整个行业的常态</a:t>
+                  <a:srgbClr val="A0A0A0"/>
+                </a:solidFill>
+              </a:rPr>
+              <a:t>SOLO Powers SOLO</a:t>
             </a:r>
             <a:endParaRPr lang="en-US" sz="1000" dirty="0"/>
           </a:p>
@@ -3752,7 +4830,7 @@
     <p:bg>
       <p:bgPr>
         <a:solidFill>
-          <a:srgbClr val="F1EFEA"/>
+          <a:srgbClr val="F9F9F7"/>
         </a:solidFill>
       </p:bgPr>
     </p:bg>
@@ -3778,26 +4856,104 @@
         </p:nvSpPr>
         <p:spPr>
           <a:xfrm>
-            <a:off x="457200" y="457200"/>
-            <a:ext cx="8229600" cy="457200"/>
-          </a:xfrm>
-          <a:prstGeom prst="rect">
-            <a:avLst/>
-          </a:prstGeom>
-          <a:noFill/>
-          <a:ln/>
-        </p:spPr>
-        <p:txBody>
-          <a:bodyPr wrap="square" rtlCol="0" anchor="ctr"/>
-          <a:lstStyle/>
-          <a:p>
-            <a:pPr indent="0" marL="0">
-              <a:buNone/>
-            </a:pPr>
-            <a:r>
-              <a:rPr lang="en-US" sz="1400" spc="200" kern="0" dirty="0">
-                <a:solidFill>
-                  <a:srgbClr val="555555"/>
+            <a:off x="457200" y="274320"/>
+            <a:ext cx="3657600" cy="274320"/>
+          </a:xfrm>
+          <a:prstGeom prst="rect">
+            <a:avLst/>
+          </a:prstGeom>
+          <a:noFill/>
+          <a:ln/>
+        </p:spPr>
+        <p:txBody>
+          <a:bodyPr wrap="square" rtlCol="0" anchor="ctr"/>
+          <a:lstStyle/>
+          <a:p>
+            <a:pPr indent="0" marL="0">
+              <a:buNone/>
+            </a:pPr>
+            <a:r>
+              <a:rPr lang="en-US" sz="1000" dirty="0">
+                <a:solidFill>
+                  <a:srgbClr val="666666"/>
+                </a:solidFill>
+                <a:latin typeface="Courier New" pitchFamily="34" charset="0"/>
+                <a:ea typeface="Courier New" pitchFamily="34" charset="-122"/>
+                <a:cs typeface="Courier New" pitchFamily="34" charset="-120"/>
+              </a:rPr>
+              <a:t>实践 · 积极变化</a:t>
+            </a:r>
+            <a:endParaRPr lang="en-US" sz="1000" dirty="0"/>
+          </a:p>
+        </p:txBody>
+      </p:sp>
+      <p:sp>
+        <p:nvSpPr>
+          <p:cNvPr id="3" name="Text 1"/>
+          <p:cNvSpPr/>
+          <p:nvPr/>
+        </p:nvSpPr>
+        <p:spPr>
+          <a:xfrm>
+            <a:off x="5029200" y="274320"/>
+            <a:ext cx="3657600" cy="274320"/>
+          </a:xfrm>
+          <a:prstGeom prst="rect">
+            <a:avLst/>
+          </a:prstGeom>
+          <a:noFill/>
+          <a:ln/>
+        </p:spPr>
+        <p:txBody>
+          <a:bodyPr wrap="square" rtlCol="0" anchor="ctr"/>
+          <a:lstStyle/>
+          <a:p>
+            <a:pPr algn="r" indent="0" marL="0">
+              <a:buNone/>
+            </a:pPr>
+            <a:r>
+              <a:rPr lang="en-US" sz="1000" dirty="0">
+                <a:solidFill>
+                  <a:srgbClr val="666666"/>
+                </a:solidFill>
+                <a:latin typeface="Courier New" pitchFamily="34" charset="0"/>
+                <a:ea typeface="Courier New" pitchFamily="34" charset="-122"/>
+                <a:cs typeface="Courier New" pitchFamily="34" charset="-120"/>
+              </a:rPr>
+              <a:t>ACT II · 07 / 12</a:t>
+            </a:r>
+            <a:endParaRPr lang="en-US" sz="1000" dirty="0"/>
+          </a:p>
+        </p:txBody>
+      </p:sp>
+      <p:sp>
+        <p:nvSpPr>
+          <p:cNvPr id="4" name="Text 2"/>
+          <p:cNvSpPr/>
+          <p:nvPr/>
+        </p:nvSpPr>
+        <p:spPr>
+          <a:xfrm>
+            <a:off x="457200" y="914400"/>
+            <a:ext cx="8229600" cy="274320"/>
+          </a:xfrm>
+          <a:prstGeom prst="rect">
+            <a:avLst/>
+          </a:prstGeom>
+          <a:noFill/>
+          <a:ln/>
+        </p:spPr>
+        <p:txBody>
+          <a:bodyPr wrap="square" rtlCol="0" anchor="ctr"/>
+          <a:lstStyle/>
+          <a:p>
+            <a:pPr indent="0" marL="0">
+              <a:buNone/>
+            </a:pPr>
+            <a:r>
+              <a:rPr lang="en-US" sz="1400" b="1" dirty="0">
+                <a:solidFill>
+                  <a:srgbClr val="0F52BA"/>
                 </a:solidFill>
               </a:rPr>
               <a:t>The Good Side</a:t>
@@ -3808,59 +4964,59 @@
       </p:sp>
       <p:sp>
         <p:nvSpPr>
-          <p:cNvPr id="3" name="Text 1"/>
-          <p:cNvSpPr/>
-          <p:nvPr/>
-        </p:nvSpPr>
-        <p:spPr>
-          <a:xfrm>
-            <a:off x="457200" y="1097280"/>
-            <a:ext cx="8229600" cy="1371600"/>
-          </a:xfrm>
-          <a:prstGeom prst="rect">
-            <a:avLst/>
-          </a:prstGeom>
-          <a:noFill/>
-          <a:ln/>
-        </p:spPr>
-        <p:txBody>
-          <a:bodyPr wrap="square" rtlCol="0" anchor="ctr"/>
-          <a:lstStyle/>
-          <a:p>
-            <a:pPr indent="0" marL="0">
-              <a:buNone/>
-            </a:pPr>
-            <a:r>
-              <a:rPr lang="en-US" sz="4800" b="1" dirty="0">
-                <a:solidFill>
-                  <a:srgbClr val="0A0A0B"/>
+          <p:cNvPr id="5" name="Text 3"/>
+          <p:cNvSpPr/>
+          <p:nvPr/>
+        </p:nvSpPr>
+        <p:spPr>
+          <a:xfrm>
+            <a:off x="457200" y="1280160"/>
+            <a:ext cx="8229600" cy="1097280"/>
+          </a:xfrm>
+          <a:prstGeom prst="rect">
+            <a:avLst/>
+          </a:prstGeom>
+          <a:noFill/>
+          <a:ln/>
+        </p:spPr>
+        <p:txBody>
+          <a:bodyPr wrap="square" rtlCol="0" anchor="t"/>
+          <a:lstStyle/>
+          <a:p>
+            <a:pPr algn="l" indent="0" marL="0">
+              <a:buNone/>
+            </a:pPr>
+            <a:r>
+              <a:rPr lang="en-US" sz="3600" b="1" dirty="0">
+                <a:solidFill>
+                  <a:srgbClr val="1E1E1E"/>
                 </a:solidFill>
               </a:rPr>
               <a:t>知识显性化：从个人到团队</a:t>
             </a:r>
-            <a:endParaRPr lang="en-US" sz="4800" dirty="0"/>
-          </a:p>
-        </p:txBody>
-      </p:sp>
-      <p:sp>
-        <p:nvSpPr>
-          <p:cNvPr id="4" name="Text 2"/>
-          <p:cNvSpPr/>
-          <p:nvPr/>
-        </p:nvSpPr>
-        <p:spPr>
-          <a:xfrm>
-            <a:off x="457200" y="2286000"/>
-            <a:ext cx="7772400" cy="1371600"/>
-          </a:xfrm>
-          <a:prstGeom prst="rect">
-            <a:avLst/>
-          </a:prstGeom>
-          <a:noFill/>
-          <a:ln/>
-        </p:spPr>
-        <p:txBody>
-          <a:bodyPr wrap="square" rtlCol="0" anchor="ctr"/>
+            <a:endParaRPr lang="en-US" sz="3600" dirty="0"/>
+          </a:p>
+        </p:txBody>
+      </p:sp>
+      <p:sp>
+        <p:nvSpPr>
+          <p:cNvPr id="6" name="Text 4"/>
+          <p:cNvSpPr/>
+          <p:nvPr/>
+        </p:nvSpPr>
+        <p:spPr>
+          <a:xfrm>
+            <a:off x="457200" y="2377440"/>
+            <a:ext cx="4114800" cy="2286000"/>
+          </a:xfrm>
+          <a:prstGeom prst="rect">
+            <a:avLst/>
+          </a:prstGeom>
+          <a:noFill/>
+          <a:ln/>
+        </p:spPr>
+        <p:txBody>
+          <a:bodyPr wrap="square" rtlCol="0" anchor="t"/>
           <a:lstStyle/>
           <a:p>
             <a:pPr indent="0" marL="0">
@@ -3869,54 +5025,18 @@
             <a:r>
               <a:rPr lang="en-US" sz="1800" dirty="0">
                 <a:solidFill>
-                  <a:srgbClr val="555555"/>
+                  <a:srgbClr val="666666"/>
                 </a:solidFill>
               </a:rPr>
               <a:t>我们将团队的“隐性知识”沉淀为 AI 能读懂的 Skill 文件。那些只存在老员工脑子里的模块设计取舍、隐性耦合，现在变成了 AI 可以准确执行的标准。</a:t>
             </a:r>
             <a:endParaRPr lang="en-US" sz="1800" dirty="0"/>
-          </a:p>
-        </p:txBody>
-      </p:sp>
-      <p:sp>
-        <p:nvSpPr>
-          <p:cNvPr id="5" name="Text 3"/>
-          <p:cNvSpPr/>
-          <p:nvPr/>
-        </p:nvSpPr>
-        <p:spPr>
-          <a:xfrm>
-            <a:off x="457200" y="3200400"/>
-            <a:ext cx="7315200" cy="1371600"/>
-          </a:xfrm>
-          <a:prstGeom prst="rect">
-            <a:avLst/>
-          </a:prstGeom>
-          <a:noFill/>
-          <a:ln/>
-        </p:spPr>
-        <p:txBody>
-          <a:bodyPr wrap="square" rtlCol="0" anchor="ctr"/>
-          <a:lstStyle/>
-          <a:p>
-            <a:pPr indent="0" marL="0">
-              <a:buNone/>
-            </a:pPr>
-            <a:r>
-              <a:rPr lang="en-US" sz="2800" i="1" dirty="0">
-                <a:solidFill>
-                  <a:srgbClr val="0A0A0B"/>
-                </a:solidFill>
-              </a:rPr>
-              <a:t>"以前新人上手要问三个老员工，现在一个 Skill 文件就能让 AI 准确执行。维护成本大幅下降。"</a:t>
-            </a:r>
-            <a:endParaRPr lang="en-US" sz="2800" dirty="0"/>
           </a:p>
         </p:txBody>
       </p:sp>
       <p:pic>
         <p:nvPicPr>
-          <p:cNvPr id="6" name="Image 0" descr="/workspace/SOLO-0408-直播/ppt/images/01-slide-image.png">    </p:cNvPr>
+          <p:cNvPr id="7" name="Image 0" descr="/workspace/SOLO-0408-直播/ppt/images/01-slide-image.png">    </p:cNvPr>
           <p:cNvPicPr>
             <a:picLocks noChangeAspect="1"/>
           </p:cNvPicPr>
@@ -3930,14 +5050,50 @@
         </p:blipFill>
         <p:spPr>
           <a:xfrm>
-            <a:off x="5029200" y="1371600"/>
-            <a:ext cx="3840480" cy="2157984"/>
+            <a:off x="4754880" y="1097280"/>
+            <a:ext cx="3931920" cy="2194560"/>
           </a:xfrm>
           <a:prstGeom prst="rect">
             <a:avLst/>
           </a:prstGeom>
         </p:spPr>
       </p:pic>
+      <p:sp>
+        <p:nvSpPr>
+          <p:cNvPr id="8" name="Text 5"/>
+          <p:cNvSpPr/>
+          <p:nvPr/>
+        </p:nvSpPr>
+        <p:spPr>
+          <a:xfrm>
+            <a:off x="457200" y="4663440"/>
+            <a:ext cx="3657600" cy="274320"/>
+          </a:xfrm>
+          <a:prstGeom prst="rect">
+            <a:avLst/>
+          </a:prstGeom>
+          <a:noFill/>
+          <a:ln/>
+        </p:spPr>
+        <p:txBody>
+          <a:bodyPr wrap="square" rtlCol="0" anchor="ctr"/>
+          <a:lstStyle/>
+          <a:p>
+            <a:pPr indent="0" marL="0">
+              <a:buNone/>
+            </a:pPr>
+            <a:r>
+              <a:rPr lang="en-US" sz="1000" dirty="0">
+                <a:solidFill>
+                  <a:srgbClr val="666666"/>
+                </a:solidFill>
+              </a:rPr>
+              <a:t>知识显性化探索</a:t>
+            </a:r>
+            <a:endParaRPr lang="en-US" sz="1000" dirty="0"/>
+          </a:p>
+        </p:txBody>
+      </p:sp>
     </p:spTree>
   </p:cSld>
   <p:clrMapOvr>
@@ -3952,7 +5108,7 @@
     <p:bg>
       <p:bgPr>
         <a:solidFill>
-          <a:srgbClr val="F1EFEA"/>
+          <a:srgbClr val="F9F9F7"/>
         </a:solidFill>
       </p:bgPr>
     </p:bg>
@@ -3978,26 +5134,104 @@
         </p:nvSpPr>
         <p:spPr>
           <a:xfrm>
-            <a:off x="457200" y="457200"/>
-            <a:ext cx="8229600" cy="457200"/>
-          </a:xfrm>
-          <a:prstGeom prst="rect">
-            <a:avLst/>
-          </a:prstGeom>
-          <a:noFill/>
-          <a:ln/>
-        </p:spPr>
-        <p:txBody>
-          <a:bodyPr wrap="square" rtlCol="0" anchor="ctr"/>
-          <a:lstStyle/>
-          <a:p>
-            <a:pPr indent="0" marL="0">
-              <a:buNone/>
-            </a:pPr>
-            <a:r>
-              <a:rPr lang="en-US" sz="1400" spc="200" kern="0" dirty="0">
-                <a:solidFill>
-                  <a:srgbClr val="555555"/>
+            <a:off x="457200" y="274320"/>
+            <a:ext cx="3657600" cy="274320"/>
+          </a:xfrm>
+          <a:prstGeom prst="rect">
+            <a:avLst/>
+          </a:prstGeom>
+          <a:noFill/>
+          <a:ln/>
+        </p:spPr>
+        <p:txBody>
+          <a:bodyPr wrap="square" rtlCol="0" anchor="ctr"/>
+          <a:lstStyle/>
+          <a:p>
+            <a:pPr indent="0" marL="0">
+              <a:buNone/>
+            </a:pPr>
+            <a:r>
+              <a:rPr lang="en-US" sz="1000" dirty="0">
+                <a:solidFill>
+                  <a:srgbClr val="666666"/>
+                </a:solidFill>
+                <a:latin typeface="Courier New" pitchFamily="34" charset="0"/>
+                <a:ea typeface="Courier New" pitchFamily="34" charset="-122"/>
+                <a:cs typeface="Courier New" pitchFamily="34" charset="-120"/>
+              </a:rPr>
+              <a:t>实践 · 真实痛点</a:t>
+            </a:r>
+            <a:endParaRPr lang="en-US" sz="1000" dirty="0"/>
+          </a:p>
+        </p:txBody>
+      </p:sp>
+      <p:sp>
+        <p:nvSpPr>
+          <p:cNvPr id="3" name="Text 1"/>
+          <p:cNvSpPr/>
+          <p:nvPr/>
+        </p:nvSpPr>
+        <p:spPr>
+          <a:xfrm>
+            <a:off x="5029200" y="274320"/>
+            <a:ext cx="3657600" cy="274320"/>
+          </a:xfrm>
+          <a:prstGeom prst="rect">
+            <a:avLst/>
+          </a:prstGeom>
+          <a:noFill/>
+          <a:ln/>
+        </p:spPr>
+        <p:txBody>
+          <a:bodyPr wrap="square" rtlCol="0" anchor="ctr"/>
+          <a:lstStyle/>
+          <a:p>
+            <a:pPr algn="r" indent="0" marL="0">
+              <a:buNone/>
+            </a:pPr>
+            <a:r>
+              <a:rPr lang="en-US" sz="1000" dirty="0">
+                <a:solidFill>
+                  <a:srgbClr val="666666"/>
+                </a:solidFill>
+                <a:latin typeface="Courier New" pitchFamily="34" charset="0"/>
+                <a:ea typeface="Courier New" pitchFamily="34" charset="-122"/>
+                <a:cs typeface="Courier New" pitchFamily="34" charset="-120"/>
+              </a:rPr>
+              <a:t>ACT II · 08 / 12</a:t>
+            </a:r>
+            <a:endParaRPr lang="en-US" sz="1000" dirty="0"/>
+          </a:p>
+        </p:txBody>
+      </p:sp>
+      <p:sp>
+        <p:nvSpPr>
+          <p:cNvPr id="4" name="Text 2"/>
+          <p:cNvSpPr/>
+          <p:nvPr/>
+        </p:nvSpPr>
+        <p:spPr>
+          <a:xfrm>
+            <a:off x="457200" y="914400"/>
+            <a:ext cx="8229600" cy="274320"/>
+          </a:xfrm>
+          <a:prstGeom prst="rect">
+            <a:avLst/>
+          </a:prstGeom>
+          <a:noFill/>
+          <a:ln/>
+        </p:spPr>
+        <p:txBody>
+          <a:bodyPr wrap="square" rtlCol="0" anchor="ctr"/>
+          <a:lstStyle/>
+          <a:p>
+            <a:pPr indent="0" marL="0">
+              <a:buNone/>
+            </a:pPr>
+            <a:r>
+              <a:rPr lang="en-US" sz="1400" b="1" dirty="0">
+                <a:solidFill>
+                  <a:srgbClr val="0F52BA"/>
                 </a:solidFill>
               </a:rPr>
               <a:t>The Bad Side</a:t>
@@ -4008,59 +5242,59 @@
       </p:sp>
       <p:sp>
         <p:nvSpPr>
-          <p:cNvPr id="3" name="Text 1"/>
-          <p:cNvSpPr/>
-          <p:nvPr/>
-        </p:nvSpPr>
-        <p:spPr>
-          <a:xfrm>
-            <a:off x="457200" y="1097280"/>
-            <a:ext cx="8229600" cy="1371600"/>
-          </a:xfrm>
-          <a:prstGeom prst="rect">
-            <a:avLst/>
-          </a:prstGeom>
-          <a:noFill/>
-          <a:ln/>
-        </p:spPr>
-        <p:txBody>
-          <a:bodyPr wrap="square" rtlCol="0" anchor="ctr"/>
-          <a:lstStyle/>
-          <a:p>
-            <a:pPr indent="0" marL="0">
-              <a:buNone/>
-            </a:pPr>
-            <a:r>
-              <a:rPr lang="en-US" sz="4800" b="1" dirty="0">
-                <a:solidFill>
-                  <a:srgbClr val="0A0A0B"/>
+          <p:cNvPr id="5" name="Text 3"/>
+          <p:cNvSpPr/>
+          <p:nvPr/>
+        </p:nvSpPr>
+        <p:spPr>
+          <a:xfrm>
+            <a:off x="457200" y="1280160"/>
+            <a:ext cx="8229600" cy="1097280"/>
+          </a:xfrm>
+          <a:prstGeom prst="rect">
+            <a:avLst/>
+          </a:prstGeom>
+          <a:noFill/>
+          <a:ln/>
+        </p:spPr>
+        <p:txBody>
+          <a:bodyPr wrap="square" rtlCol="0" anchor="t"/>
+          <a:lstStyle/>
+          <a:p>
+            <a:pPr algn="l" indent="0" marL="0">
+              <a:buNone/>
+            </a:pPr>
+            <a:r>
+              <a:rPr lang="en-US" sz="3600" b="1" dirty="0">
+                <a:solidFill>
+                  <a:srgbClr val="1E1E1E"/>
                 </a:solidFill>
               </a:rPr>
               <a:t>个人速度，不等于组织速度</a:t>
             </a:r>
-            <a:endParaRPr lang="en-US" sz="4800" dirty="0"/>
-          </a:p>
-        </p:txBody>
-      </p:sp>
-      <p:sp>
-        <p:nvSpPr>
-          <p:cNvPr id="4" name="Text 2"/>
-          <p:cNvSpPr/>
-          <p:nvPr/>
-        </p:nvSpPr>
-        <p:spPr>
-          <a:xfrm>
-            <a:off x="457200" y="2286000"/>
-            <a:ext cx="7772400" cy="1371600"/>
-          </a:xfrm>
-          <a:prstGeom prst="rect">
-            <a:avLst/>
-          </a:prstGeom>
-          <a:noFill/>
-          <a:ln/>
-        </p:spPr>
-        <p:txBody>
-          <a:bodyPr wrap="square" rtlCol="0" anchor="ctr"/>
+            <a:endParaRPr lang="en-US" sz="3600" dirty="0"/>
+          </a:p>
+        </p:txBody>
+      </p:sp>
+      <p:sp>
+        <p:nvSpPr>
+          <p:cNvPr id="6" name="Text 4"/>
+          <p:cNvSpPr/>
+          <p:nvPr/>
+        </p:nvSpPr>
+        <p:spPr>
+          <a:xfrm>
+            <a:off x="457200" y="2377440"/>
+            <a:ext cx="4114800" cy="2286000"/>
+          </a:xfrm>
+          <a:prstGeom prst="rect">
+            <a:avLst/>
+          </a:prstGeom>
+          <a:noFill/>
+          <a:ln/>
+        </p:spPr>
+        <p:txBody>
+          <a:bodyPr wrap="square" rtlCol="0" anchor="t"/>
           <a:lstStyle/>
           <a:p>
             <a:pPr indent="0" marL="0">
@@ -4069,54 +5303,18 @@
             <a:r>
               <a:rPr lang="en-US" sz="1800" dirty="0">
                 <a:solidFill>
-                  <a:srgbClr val="555555"/>
+                  <a:srgbClr val="666666"/>
                 </a:solidFill>
               </a:rPr>
               <a:t>AI 让写代码快了一个数量级，但产出量大了，Review 成为瓶颈。上下游衔接成本上升，交付周期并未同比例缩短。</a:t>
             </a:r>
             <a:endParaRPr lang="en-US" sz="1800" dirty="0"/>
-          </a:p>
-        </p:txBody>
-      </p:sp>
-      <p:sp>
-        <p:nvSpPr>
-          <p:cNvPr id="5" name="Text 3"/>
-          <p:cNvSpPr/>
-          <p:nvPr/>
-        </p:nvSpPr>
-        <p:spPr>
-          <a:xfrm>
-            <a:off x="457200" y="3200400"/>
-            <a:ext cx="7315200" cy="1371600"/>
-          </a:xfrm>
-          <a:prstGeom prst="rect">
-            <a:avLst/>
-          </a:prstGeom>
-          <a:noFill/>
-          <a:ln/>
-        </p:spPr>
-        <p:txBody>
-          <a:bodyPr wrap="square" rtlCol="0" anchor="ctr"/>
-          <a:lstStyle/>
-          <a:p>
-            <a:pPr indent="0" marL="0">
-              <a:buNone/>
-            </a:pPr>
-            <a:r>
-              <a:rPr lang="en-US" sz="2800" i="1" dirty="0">
-                <a:solidFill>
-                  <a:srgbClr val="0A0A0B"/>
-                </a:solidFill>
-              </a:rPr>
-              <a:t>"多人协同下的“隐性破坏”防不胜防。代码写得越快，这种交互层面、边界状态的“改坏”就越多。"</a:t>
-            </a:r>
-            <a:endParaRPr lang="en-US" sz="2800" dirty="0"/>
           </a:p>
         </p:txBody>
       </p:sp>
       <p:pic>
         <p:nvPicPr>
-          <p:cNvPr id="6" name="Image 0" descr="/workspace/SOLO-0408-直播/ppt/images/02-slide-image.png">    </p:cNvPr>
+          <p:cNvPr id="7" name="Image 0" descr="/workspace/SOLO-0408-直播/ppt/images/02-slide-image.png">    </p:cNvPr>
           <p:cNvPicPr>
             <a:picLocks noChangeAspect="1"/>
           </p:cNvPicPr>
@@ -4130,14 +5328,50 @@
         </p:blipFill>
         <p:spPr>
           <a:xfrm>
-            <a:off x="5029200" y="1371600"/>
-            <a:ext cx="3840480" cy="2157984"/>
+            <a:off x="4754880" y="1097280"/>
+            <a:ext cx="3931920" cy="2194560"/>
           </a:xfrm>
           <a:prstGeom prst="rect">
             <a:avLst/>
           </a:prstGeom>
         </p:spPr>
       </p:pic>
+      <p:sp>
+        <p:nvSpPr>
+          <p:cNvPr id="8" name="Text 5"/>
+          <p:cNvSpPr/>
+          <p:nvPr/>
+        </p:nvSpPr>
+        <p:spPr>
+          <a:xfrm>
+            <a:off x="457200" y="4663440"/>
+            <a:ext cx="3657600" cy="274320"/>
+          </a:xfrm>
+          <a:prstGeom prst="rect">
+            <a:avLst/>
+          </a:prstGeom>
+          <a:noFill/>
+          <a:ln/>
+        </p:spPr>
+        <p:txBody>
+          <a:bodyPr wrap="square" rtlCol="0" anchor="ctr"/>
+          <a:lstStyle/>
+          <a:p>
+            <a:pPr indent="0" marL="0">
+              <a:buNone/>
+            </a:pPr>
+            <a:r>
+              <a:rPr lang="en-US" sz="1000" dirty="0">
+                <a:solidFill>
+                  <a:srgbClr val="666666"/>
+                </a:solidFill>
+              </a:rPr>
+              <a:t>效率瓶颈的转移</a:t>
+            </a:r>
+            <a:endParaRPr lang="en-US" sz="1000" dirty="0"/>
+          </a:p>
+        </p:txBody>
+      </p:sp>
     </p:spTree>
   </p:cSld>
   <p:clrMapOvr>
@@ -4152,7 +5386,7 @@
     <p:bg>
       <p:bgPr>
         <a:solidFill>
-          <a:srgbClr val="0A0A0B"/>
+          <a:srgbClr val="1E1E1E"/>
         </a:solidFill>
       </p:bgPr>
     </p:bg>
@@ -4178,31 +5412,34 @@
         </p:nvSpPr>
         <p:spPr>
           <a:xfrm>
-            <a:off x="457200" y="457200"/>
-            <a:ext cx="8229600" cy="457200"/>
-          </a:xfrm>
-          <a:prstGeom prst="rect">
-            <a:avLst/>
-          </a:prstGeom>
-          <a:noFill/>
-          <a:ln/>
-        </p:spPr>
-        <p:txBody>
-          <a:bodyPr wrap="square" rtlCol="0" anchor="ctr"/>
-          <a:lstStyle/>
-          <a:p>
-            <a:pPr indent="0" marL="0">
-              <a:buNone/>
-            </a:pPr>
-            <a:r>
-              <a:rPr lang="en-US" sz="1400" spc="200" kern="0" dirty="0">
-                <a:solidFill>
-                  <a:srgbClr val="CCCCCC"/>
-                </a:solidFill>
-              </a:rPr>
-              <a:t>Act III</a:t>
-            </a:r>
-            <a:endParaRPr lang="en-US" sz="1400" dirty="0"/>
+            <a:off x="457200" y="274320"/>
+            <a:ext cx="3657600" cy="274320"/>
+          </a:xfrm>
+          <a:prstGeom prst="rect">
+            <a:avLst/>
+          </a:prstGeom>
+          <a:noFill/>
+          <a:ln/>
+        </p:spPr>
+        <p:txBody>
+          <a:bodyPr wrap="square" rtlCol="0" anchor="ctr"/>
+          <a:lstStyle/>
+          <a:p>
+            <a:pPr indent="0" marL="0">
+              <a:buNone/>
+            </a:pPr>
+            <a:r>
+              <a:rPr lang="en-US" sz="1000" dirty="0">
+                <a:solidFill>
+                  <a:srgbClr val="A0A0A0"/>
+                </a:solidFill>
+                <a:latin typeface="Courier New" pitchFamily="34" charset="0"/>
+                <a:ea typeface="Courier New" pitchFamily="34" charset="-122"/>
+                <a:cs typeface="Courier New" pitchFamily="34" charset="-120"/>
+              </a:rPr>
+              <a:t>第三幕 · 未来趋势</a:t>
+            </a:r>
+            <a:endParaRPr lang="en-US" sz="1000" dirty="0"/>
           </a:p>
         </p:txBody>
       </p:sp>
@@ -4214,67 +5451,106 @@
         </p:nvSpPr>
         <p:spPr>
           <a:xfrm>
-            <a:off x="457200" y="1097280"/>
-            <a:ext cx="8229600" cy="1371600"/>
-          </a:xfrm>
-          <a:prstGeom prst="rect">
-            <a:avLst/>
-          </a:prstGeom>
-          <a:noFill/>
-          <a:ln/>
-        </p:spPr>
-        <p:txBody>
-          <a:bodyPr wrap="square" rtlCol="0" anchor="ctr"/>
-          <a:lstStyle/>
-          <a:p>
-            <a:pPr indent="0" marL="0">
-              <a:buNone/>
-            </a:pPr>
-            <a:r>
-              <a:rPr lang="en-US" sz="4800" b="1" dirty="0">
-                <a:solidFill>
-                  <a:srgbClr val="F1EFEA"/>
+            <a:off x="5029200" y="274320"/>
+            <a:ext cx="3657600" cy="274320"/>
+          </a:xfrm>
+          <a:prstGeom prst="rect">
+            <a:avLst/>
+          </a:prstGeom>
+          <a:noFill/>
+          <a:ln/>
+        </p:spPr>
+        <p:txBody>
+          <a:bodyPr wrap="square" rtlCol="0" anchor="ctr"/>
+          <a:lstStyle/>
+          <a:p>
+            <a:pPr algn="r" indent="0" marL="0">
+              <a:buNone/>
+            </a:pPr>
+            <a:r>
+              <a:rPr lang="en-US" sz="1000" dirty="0">
+                <a:solidFill>
+                  <a:srgbClr val="A0A0A0"/>
+                </a:solidFill>
+                <a:latin typeface="Courier New" pitchFamily="34" charset="0"/>
+                <a:ea typeface="Courier New" pitchFamily="34" charset="-122"/>
+                <a:cs typeface="Courier New" pitchFamily="34" charset="-120"/>
+              </a:rPr>
+              <a:t>ACT III · 09 / 12</a:t>
+            </a:r>
+            <a:endParaRPr lang="en-US" sz="1000" dirty="0"/>
+          </a:p>
+        </p:txBody>
+      </p:sp>
+      <p:sp>
+        <p:nvSpPr>
+          <p:cNvPr id="4" name="Text 2"/>
+          <p:cNvSpPr/>
+          <p:nvPr/>
+        </p:nvSpPr>
+        <p:spPr>
+          <a:xfrm>
+            <a:off x="457200" y="1828800"/>
+            <a:ext cx="8229600" cy="1097280"/>
+          </a:xfrm>
+          <a:prstGeom prst="rect">
+            <a:avLst/>
+          </a:prstGeom>
+          <a:noFill/>
+          <a:ln/>
+        </p:spPr>
+        <p:txBody>
+          <a:bodyPr wrap="square" rtlCol="0" anchor="t"/>
+          <a:lstStyle/>
+          <a:p>
+            <a:pPr algn="ctr" indent="0" marL="0">
+              <a:buNone/>
+            </a:pPr>
+            <a:r>
+              <a:rPr lang="en-US" sz="5400" b="1" dirty="0">
+                <a:solidFill>
+                  <a:srgbClr val="F9F9F7"/>
                 </a:solidFill>
               </a:rPr>
               <a:t>趋势：两个清晰的方向</a:t>
             </a:r>
-            <a:endParaRPr lang="en-US" sz="4800" dirty="0"/>
-          </a:p>
-        </p:txBody>
-      </p:sp>
-      <p:sp>
-        <p:nvSpPr>
-          <p:cNvPr id="4" name="Text 2"/>
-          <p:cNvSpPr/>
-          <p:nvPr/>
-        </p:nvSpPr>
-        <p:spPr>
-          <a:xfrm>
-            <a:off x="457200" y="2286000"/>
-            <a:ext cx="7772400" cy="1371600"/>
-          </a:xfrm>
-          <a:prstGeom prst="rect">
-            <a:avLst/>
-          </a:prstGeom>
-          <a:noFill/>
-          <a:ln/>
-        </p:spPr>
-        <p:txBody>
-          <a:bodyPr wrap="square" rtlCol="0" anchor="ctr"/>
-          <a:lstStyle/>
-          <a:p>
-            <a:pPr indent="0" marL="0">
-              <a:buNone/>
-            </a:pPr>
-            <a:r>
-              <a:rPr lang="en-US" sz="1800" dirty="0">
-                <a:solidFill>
-                  <a:srgbClr val="CCCCCC"/>
+            <a:endParaRPr lang="en-US" sz="5400" dirty="0"/>
+          </a:p>
+        </p:txBody>
+      </p:sp>
+      <p:sp>
+        <p:nvSpPr>
+          <p:cNvPr id="5" name="Text 3"/>
+          <p:cNvSpPr/>
+          <p:nvPr/>
+        </p:nvSpPr>
+        <p:spPr>
+          <a:xfrm>
+            <a:off x="1371600" y="3657600"/>
+            <a:ext cx="6400800" cy="914400"/>
+          </a:xfrm>
+          <a:prstGeom prst="rect">
+            <a:avLst/>
+          </a:prstGeom>
+          <a:noFill/>
+          <a:ln/>
+        </p:spPr>
+        <p:txBody>
+          <a:bodyPr wrap="square" rtlCol="0" anchor="t"/>
+          <a:lstStyle/>
+          <a:p>
+            <a:pPr algn="ctr" indent="0" marL="0">
+              <a:buNone/>
+            </a:pPr>
+            <a:r>
+              <a:rPr lang="en-US" sz="2000" dirty="0">
+                <a:solidFill>
+                  <a:srgbClr val="A0A0A0"/>
                 </a:solidFill>
               </a:rPr>
               <a:t>基于一线的实践经验，我们看到了 AI Coding 正在发生的质变。</a:t>
             </a:r>
-            <a:endParaRPr lang="en-US" sz="1800" dirty="0"/>
+            <a:endParaRPr lang="en-US" sz="2000" dirty="0"/>
           </a:p>
         </p:txBody>
       </p:sp>

</xml_diff>